<commit_message>
Moyee: tastingfee-model in vergelijking, vaste afname met maand opzegtermijn
Co-Authored-By: Claude Opus 5 <noreply@anthropic.com>
Claude-Session: https://claude.ai/code/session_0141FN3f3hHkYQHTyvTJJGrw
</commit_message>
<xml_diff>
--- a/output/LINK. voorstel Moyee Coffee.pptx
+++ b/output/LINK. voorstel Moyee Coffee.pptx
@@ -3233,12 +3233,12 @@
         </p:nvSpPr>
         <p:spPr>
           <a:xfrm>
-            <a:off x="609598" y="2679693"/>
-            <a:ext cx="5384787" cy="2971793"/>
+            <a:off x="609598" y="2539994"/>
+            <a:ext cx="5384787" cy="2920993"/>
           </a:xfrm>
           <a:prstGeom prst="roundRect">
             <a:avLst>
-              <a:gd name="adj" fmla="val 3419"/>
+              <a:gd name="adj" fmla="val 3478"/>
             </a:avLst>
           </a:prstGeom>
           <a:solidFill>
@@ -3255,7 +3255,7 @@
         </p:nvSpPr>
         <p:spPr>
           <a:xfrm>
-            <a:off x="939798" y="2959093"/>
+            <a:off x="939798" y="2819393"/>
             <a:ext cx="4724388" cy="190500"/>
           </a:xfrm>
           <a:prstGeom prst="rect">
@@ -3280,7 +3280,7 @@
                 <a:ea typeface="Arial" pitchFamily="34" charset="-122"/>
                 <a:cs typeface="Arial" pitchFamily="34" charset="-120"/>
               </a:rPr>
-              <a:t>NU</a:t>
+              <a:t>NU · VIER BELDAGEN</a:t>
             </a:r>
             <a:endParaRPr lang="en-US" sz="800" dirty="0"/>
           </a:p>
@@ -3294,7 +3294,7 @@
         </p:nvSpPr>
         <p:spPr>
           <a:xfrm>
-            <a:off x="939798" y="3174992"/>
+            <a:off x="939798" y="3035292"/>
             <a:ext cx="4724388" cy="330199"/>
           </a:xfrm>
           <a:prstGeom prst="rect">
@@ -3319,7 +3319,7 @@
                 <a:ea typeface="Arial" pitchFamily="34" charset="-122"/>
                 <a:cs typeface="Arial" pitchFamily="34" charset="-120"/>
               </a:rPr>
-              <a:t>€ 1.500 per maand plus € 150 per lead</a:t>
+              <a:t>€ 1.500 per maand plus € 150 per tasting</a:t>
             </a:r>
             <a:endParaRPr lang="en-US" sz="1500" dirty="0"/>
           </a:p>
@@ -3333,7 +3333,7 @@
         </p:nvSpPr>
         <p:spPr>
           <a:xfrm>
-            <a:off x="939798" y="3619491"/>
+            <a:off x="939798" y="3479791"/>
             <a:ext cx="3479791" cy="469899"/>
           </a:xfrm>
           <a:prstGeom prst="rect">
@@ -3358,7 +3358,7 @@
                 <a:ea typeface="Arial" pitchFamily="34" charset="-122"/>
                 <a:cs typeface="Arial" pitchFamily="34" charset="-120"/>
               </a:rPr>
-              <a:t>Beldagen per 4 weken</a:t>
+              <a:t>Kosten per 4 weken</a:t>
             </a:r>
             <a:endParaRPr lang="en-US" sz="1100" dirty="0"/>
           </a:p>
@@ -3372,7 +3372,7 @@
         </p:nvSpPr>
         <p:spPr>
           <a:xfrm>
-            <a:off x="4419589" y="3619491"/>
+            <a:off x="4419589" y="3479791"/>
             <a:ext cx="1244597" cy="469899"/>
           </a:xfrm>
           <a:prstGeom prst="rect">
@@ -3397,7 +3397,7 @@
                 <a:ea typeface="Arial" pitchFamily="34" charset="-122"/>
                 <a:cs typeface="Arial" pitchFamily="34" charset="-120"/>
               </a:rPr>
-              <a:t>4</a:t>
+              <a:t>± € 2.400</a:t>
             </a:r>
             <a:endParaRPr lang="en-US" sz="1350" dirty="0"/>
           </a:p>
@@ -3411,7 +3411,7 @@
         </p:nvSpPr>
         <p:spPr>
           <a:xfrm>
-            <a:off x="939798" y="4089390"/>
+            <a:off x="939798" y="3949690"/>
             <a:ext cx="4724388" cy="0"/>
           </a:xfrm>
           <a:prstGeom prst="line">
@@ -3434,7 +3434,7 @@
         </p:nvSpPr>
         <p:spPr>
           <a:xfrm>
-            <a:off x="939798" y="4089390"/>
+            <a:off x="939798" y="3949690"/>
             <a:ext cx="3479791" cy="469899"/>
           </a:xfrm>
           <a:prstGeom prst="rect">
@@ -3459,7 +3459,7 @@
                 <a:ea typeface="Arial" pitchFamily="34" charset="-122"/>
                 <a:cs typeface="Arial" pitchFamily="34" charset="-120"/>
               </a:rPr>
-              <a:t>Kosten per 4 weken</a:t>
+              <a:t>Waarvan tastingfees</a:t>
             </a:r>
             <a:endParaRPr lang="en-US" sz="1100" dirty="0"/>
           </a:p>
@@ -3473,7 +3473,7 @@
         </p:nvSpPr>
         <p:spPr>
           <a:xfrm>
-            <a:off x="4419589" y="4089390"/>
+            <a:off x="4419589" y="3949690"/>
             <a:ext cx="1244597" cy="469899"/>
           </a:xfrm>
           <a:prstGeom prst="rect">
@@ -3498,7 +3498,7 @@
                 <a:ea typeface="Arial" pitchFamily="34" charset="-122"/>
                 <a:cs typeface="Arial" pitchFamily="34" charset="-120"/>
               </a:rPr>
-              <a:t>€ 2.940</a:t>
+              <a:t>± € 900</a:t>
             </a:r>
             <a:endParaRPr lang="en-US" sz="1350" dirty="0"/>
           </a:p>
@@ -3512,7 +3512,7 @@
         </p:nvSpPr>
         <p:spPr>
           <a:xfrm>
-            <a:off x="939798" y="4559289"/>
+            <a:off x="939798" y="4419589"/>
             <a:ext cx="4724388" cy="0"/>
           </a:xfrm>
           <a:prstGeom prst="line">
@@ -3535,7 +3535,7 @@
         </p:nvSpPr>
         <p:spPr>
           <a:xfrm>
-            <a:off x="939798" y="4559289"/>
+            <a:off x="939798" y="4419589"/>
             <a:ext cx="3479791" cy="469899"/>
           </a:xfrm>
           <a:prstGeom prst="rect">
@@ -3574,7 +3574,7 @@
         </p:nvSpPr>
         <p:spPr>
           <a:xfrm>
-            <a:off x="4419589" y="4559289"/>
+            <a:off x="4419589" y="4419589"/>
             <a:ext cx="1244597" cy="469899"/>
           </a:xfrm>
           <a:prstGeom prst="rect">
@@ -3613,7 +3613,7 @@
         </p:nvSpPr>
         <p:spPr>
           <a:xfrm>
-            <a:off x="939798" y="5029187"/>
+            <a:off x="939798" y="4889488"/>
             <a:ext cx="4724388" cy="0"/>
           </a:xfrm>
           <a:prstGeom prst="line">
@@ -3636,7 +3636,7 @@
         </p:nvSpPr>
         <p:spPr>
           <a:xfrm>
-            <a:off x="939798" y="5029187"/>
+            <a:off x="939798" y="4889488"/>
             <a:ext cx="3479791" cy="469899"/>
           </a:xfrm>
           <a:prstGeom prst="rect">
@@ -3675,7 +3675,7 @@
         </p:nvSpPr>
         <p:spPr>
           <a:xfrm>
-            <a:off x="4419589" y="5029187"/>
+            <a:off x="4419589" y="4889488"/>
             <a:ext cx="1244597" cy="469899"/>
           </a:xfrm>
           <a:prstGeom prst="rect">
@@ -3700,7 +3700,7 @@
                 <a:ea typeface="Arial" pitchFamily="34" charset="-122"/>
                 <a:cs typeface="Arial" pitchFamily="34" charset="-120"/>
               </a:rPr>
-              <a:t>€ 306</a:t>
+              <a:t>± € 250</a:t>
             </a:r>
             <a:endParaRPr lang="en-US" sz="1350" dirty="0"/>
           </a:p>
@@ -3714,12 +3714,12 @@
         </p:nvSpPr>
         <p:spPr>
           <a:xfrm>
-            <a:off x="6197585" y="2679693"/>
-            <a:ext cx="5384787" cy="2971793"/>
+            <a:off x="6197585" y="2539994"/>
+            <a:ext cx="5384787" cy="2920993"/>
           </a:xfrm>
           <a:prstGeom prst="roundRect">
             <a:avLst>
-              <a:gd name="adj" fmla="val 3419"/>
+              <a:gd name="adj" fmla="val 3478"/>
             </a:avLst>
           </a:prstGeom>
           <a:solidFill>
@@ -3736,7 +3736,7 @@
         </p:nvSpPr>
         <p:spPr>
           <a:xfrm>
-            <a:off x="6527784" y="2959093"/>
+            <a:off x="6527784" y="2819393"/>
             <a:ext cx="4724388" cy="190500"/>
           </a:xfrm>
           <a:prstGeom prst="rect">
@@ -3761,7 +3761,7 @@
                 <a:ea typeface="Arial" pitchFamily="34" charset="-122"/>
                 <a:cs typeface="Arial" pitchFamily="34" charset="-120"/>
               </a:rPr>
-              <a:t>VOORSTEL</a:t>
+              <a:t>VOORSTEL · ACHT BELDAGEN</a:t>
             </a:r>
             <a:endParaRPr lang="en-US" sz="800" dirty="0"/>
           </a:p>
@@ -3775,7 +3775,7 @@
         </p:nvSpPr>
         <p:spPr>
           <a:xfrm>
-            <a:off x="6527784" y="3174992"/>
+            <a:off x="6527784" y="3035292"/>
             <a:ext cx="4724388" cy="330199"/>
           </a:xfrm>
           <a:prstGeom prst="rect">
@@ -3800,7 +3800,7 @@
                 <a:ea typeface="Arial" pitchFamily="34" charset="-122"/>
                 <a:cs typeface="Arial" pitchFamily="34" charset="-120"/>
               </a:rPr>
-              <a:t>Acht beldagen per 4 weken, één vaste dagprijs</a:t>
+              <a:t>€ 500 per beldag, verder niets</a:t>
             </a:r>
             <a:endParaRPr lang="en-US" sz="1500" dirty="0"/>
           </a:p>
@@ -3814,7 +3814,7 @@
         </p:nvSpPr>
         <p:spPr>
           <a:xfrm>
-            <a:off x="6527784" y="3619491"/>
+            <a:off x="6527784" y="3479791"/>
             <a:ext cx="3479791" cy="469899"/>
           </a:xfrm>
           <a:prstGeom prst="rect">
@@ -3839,7 +3839,7 @@
                 <a:ea typeface="Arial" pitchFamily="34" charset="-122"/>
                 <a:cs typeface="Arial" pitchFamily="34" charset="-120"/>
               </a:rPr>
-              <a:t>Beldagen per 4 weken</a:t>
+              <a:t>Kosten per 4 weken</a:t>
             </a:r>
             <a:endParaRPr lang="en-US" sz="1100" dirty="0"/>
           </a:p>
@@ -3853,7 +3853,7 @@
         </p:nvSpPr>
         <p:spPr>
           <a:xfrm>
-            <a:off x="10007575" y="3619491"/>
+            <a:off x="10007575" y="3479791"/>
             <a:ext cx="1244597" cy="469899"/>
           </a:xfrm>
           <a:prstGeom prst="rect">
@@ -3878,7 +3878,7 @@
                 <a:ea typeface="Arial" pitchFamily="34" charset="-122"/>
                 <a:cs typeface="Arial" pitchFamily="34" charset="-120"/>
               </a:rPr>
-              <a:t>8</a:t>
+              <a:t>€ 4.000</a:t>
             </a:r>
             <a:endParaRPr lang="en-US" sz="1350" dirty="0"/>
           </a:p>
@@ -3892,7 +3892,7 @@
         </p:nvSpPr>
         <p:spPr>
           <a:xfrm>
-            <a:off x="6527784" y="4089390"/>
+            <a:off x="6527784" y="3949690"/>
             <a:ext cx="4724388" cy="0"/>
           </a:xfrm>
           <a:prstGeom prst="line">
@@ -3915,7 +3915,7 @@
         </p:nvSpPr>
         <p:spPr>
           <a:xfrm>
-            <a:off x="6527784" y="4089390"/>
+            <a:off x="6527784" y="3949690"/>
             <a:ext cx="3479791" cy="469899"/>
           </a:xfrm>
           <a:prstGeom prst="rect">
@@ -3940,7 +3940,7 @@
                 <a:ea typeface="Arial" pitchFamily="34" charset="-122"/>
                 <a:cs typeface="Arial" pitchFamily="34" charset="-120"/>
               </a:rPr>
-              <a:t>Kosten per 4 weken</a:t>
+              <a:t>Waarvan tastingfees</a:t>
             </a:r>
             <a:endParaRPr lang="en-US" sz="1100" dirty="0"/>
           </a:p>
@@ -3954,7 +3954,7 @@
         </p:nvSpPr>
         <p:spPr>
           <a:xfrm>
-            <a:off x="10007575" y="4089390"/>
+            <a:off x="10007575" y="3949690"/>
             <a:ext cx="1244597" cy="469899"/>
           </a:xfrm>
           <a:prstGeom prst="rect">
@@ -3979,7 +3979,7 @@
                 <a:ea typeface="Arial" pitchFamily="34" charset="-122"/>
                 <a:cs typeface="Arial" pitchFamily="34" charset="-120"/>
               </a:rPr>
-              <a:t>€ 4.000</a:t>
+              <a:t>€ 0</a:t>
             </a:r>
             <a:endParaRPr lang="en-US" sz="1350" dirty="0"/>
           </a:p>
@@ -3993,7 +3993,7 @@
         </p:nvSpPr>
         <p:spPr>
           <a:xfrm>
-            <a:off x="6527784" y="4559289"/>
+            <a:off x="6527784" y="4419589"/>
             <a:ext cx="4724388" cy="0"/>
           </a:xfrm>
           <a:prstGeom prst="line">
@@ -4016,7 +4016,7 @@
         </p:nvSpPr>
         <p:spPr>
           <a:xfrm>
-            <a:off x="6527784" y="4559289"/>
+            <a:off x="6527784" y="4419589"/>
             <a:ext cx="3479791" cy="469899"/>
           </a:xfrm>
           <a:prstGeom prst="rect">
@@ -4055,7 +4055,7 @@
         </p:nvSpPr>
         <p:spPr>
           <a:xfrm>
-            <a:off x="10007575" y="4559289"/>
+            <a:off x="10007575" y="4419589"/>
             <a:ext cx="1244597" cy="469899"/>
           </a:xfrm>
           <a:prstGeom prst="rect">
@@ -4094,7 +4094,7 @@
         </p:nvSpPr>
         <p:spPr>
           <a:xfrm>
-            <a:off x="6527784" y="5029187"/>
+            <a:off x="6527784" y="4889488"/>
             <a:ext cx="4724388" cy="0"/>
           </a:xfrm>
           <a:prstGeom prst="line">
@@ -4117,7 +4117,7 @@
         </p:nvSpPr>
         <p:spPr>
           <a:xfrm>
-            <a:off x="6527784" y="5029187"/>
+            <a:off x="6527784" y="4889488"/>
             <a:ext cx="3479791" cy="469899"/>
           </a:xfrm>
           <a:prstGeom prst="rect">
@@ -4156,7 +4156,7 @@
         </p:nvSpPr>
         <p:spPr>
           <a:xfrm>
-            <a:off x="10007575" y="5029187"/>
+            <a:off x="10007575" y="4889488"/>
             <a:ext cx="1244597" cy="469899"/>
           </a:xfrm>
           <a:prstGeom prst="rect">
@@ -4240,7 +4240,7 @@
                 <a:ea typeface="Arial" pitchFamily="34" charset="-122"/>
                 <a:cs typeface="Arial" pitchFamily="34" charset="-120"/>
               </a:rPr>
-              <a:t>Ook bij vier beldagen gaan jullie erop vooruit: € 2.400 in plaats van € 2.940, bij hetzelfde aantal leads.</a:t>
+              <a:t>Bij vier beldagen betalen jullie ongeveer hetzelfde als nu, vanaf zes beldagen zakt de prijs per lead.</a:t>
             </a:r>
             <a:endParaRPr lang="en-US" sz="1200" dirty="0"/>
           </a:p>
@@ -4992,7 +4992,7 @@
                 <a:ea typeface="Arial" pitchFamily="34" charset="-122"/>
                 <a:cs typeface="Arial" pitchFamily="34" charset="-120"/>
               </a:rPr>
-              <a:t>Op- en afschalen per periode</a:t>
+              <a:t>Vastgelegd, opzegbaar met een maand</a:t>
             </a:r>
             <a:endParaRPr lang="en-US" sz="1150" dirty="0"/>
           </a:p>
@@ -5034,7 +5034,7 @@
                 <a:ea typeface="Arial" pitchFamily="34" charset="-122"/>
                 <a:cs typeface="Arial" pitchFamily="34" charset="-120"/>
               </a:rPr>
-              <a:t>Elke vier weken kiezen jullie opnieuw hoeveel beldagen je afneemt. Groeit de vraag, dan schalen we mee op.</a:t>
+              <a:t>We leggen het aantal beldagen vast, zodat wij de capaciteit kunnen reserveren en jullie weten waar je aan toe bent. Opzeggen kan met een maand.</a:t>
             </a:r>
             <a:endParaRPr lang="en-US" sz="875" dirty="0"/>
           </a:p>
@@ -5164,7 +5164,7 @@
                 <a:ea typeface="Arial" pitchFamily="34" charset="-122"/>
                 <a:cs typeface="Arial" pitchFamily="34" charset="-120"/>
               </a:rPr>
-              <a:t>Geen kosten per lead meer</a:t>
+              <a:t>Geen kosten per tasting meer</a:t>
             </a:r>
             <a:endParaRPr lang="en-US" sz="1150" dirty="0"/>
           </a:p>
@@ -5206,7 +5206,7 @@
                 <a:ea typeface="Arial" pitchFamily="34" charset="-122"/>
                 <a:cs typeface="Arial" pitchFamily="34" charset="-120"/>
               </a:rPr>
-              <a:t>De dagprijs is alles. Er komt geen bedrag per lead meer bovenop, dus jullie weten vooraf precies wat een periode kost.</a:t>
+              <a:t>De dagprijs is alles. Er komt geen bedrag per tasting meer bovenop, dus jullie weten vooraf precies wat een periode kost.</a:t>
             </a:r>
             <a:endParaRPr lang="en-US" sz="875" dirty="0"/>
           </a:p>
@@ -5755,7 +5755,7 @@
                 <a:ea typeface="Arial" pitchFamily="34" charset="-122"/>
                 <a:cs typeface="Arial" pitchFamily="34" charset="-120"/>
               </a:rPr>
-              <a:t>Niet-exclusief</a:t>
+              <a:t>Opzegtermijn van één maand</a:t>
             </a:r>
             <a:endParaRPr lang="en-US" sz="1200" dirty="0"/>
           </a:p>
@@ -5797,7 +5797,7 @@
                 <a:ea typeface="Arial" pitchFamily="34" charset="-122"/>
                 <a:cs typeface="Arial" pitchFamily="34" charset="-120"/>
               </a:rPr>
-              <a:t>Jullie zitten nergens aan vast en houden alle vrijheid.</a:t>
+              <a:t>We leggen het aantal beldagen vast, opzeggen kan met een maand.</a:t>
             </a:r>
             <a:endParaRPr lang="en-US" sz="950" dirty="0"/>
           </a:p>
@@ -13516,7 +13516,7 @@
                 <a:ea typeface="Arial" pitchFamily="34" charset="-122"/>
                 <a:cs typeface="Arial" pitchFamily="34" charset="-120"/>
               </a:rPr>
-              <a:t>In negentien weken hebben we 1.572 bedrijven gebeld. Elk van die gesprekken is ook een moment waarop iemand hoort wat Moyee doet.</a:t>
+              <a:t>In negentien weken hebben we 1.572 bedrijven gebeld. Dat is nog maar een fractie van de markt, dus we kunnen hier nog lang op doorbellen.</a:t>
             </a:r>
             <a:endParaRPr lang="en-US" sz="1050" dirty="0"/>
           </a:p>

</xml_diff>

<commit_message>
Moyee: staffel naar drie schijven met 500 euro als ondergrens
Co-Authored-By: Claude Opus 5 <noreply@anthropic.com>
Claude-Session: https://claude.ai/code/session_0141FN3f3hHkYQHTyvTJJGrw
</commit_message>
<xml_diff>
--- a/output/LINK. voorstel Moyee Coffee.pptx
+++ b/output/LINK. voorstel Moyee Coffee.pptx
@@ -4240,7 +4240,7 @@
                 <a:ea typeface="Arial" pitchFamily="34" charset="-122"/>
                 <a:cs typeface="Arial" pitchFamily="34" charset="-120"/>
               </a:rPr>
-              <a:t>Bij vier beldagen betalen jullie ongeveer hetzelfde als nu, vanaf zes beldagen zakt de prijs per lead.</a:t>
+              <a:t>Bij vier beldagen betalen jullie ongeveer hetzelfde als nu, vanaf vijf beldagen zakt de prijs per lead.</a:t>
             </a:r>
             <a:endParaRPr lang="en-US" sz="1200" dirty="0"/>
           </a:p>
@@ -14256,11 +14256,11 @@
         <p:spPr>
           <a:xfrm>
             <a:off x="609598" y="2666993"/>
-            <a:ext cx="10972773" cy="2578094"/>
+            <a:ext cx="10972773" cy="2355844"/>
           </a:xfrm>
           <a:prstGeom prst="roundRect">
             <a:avLst>
-              <a:gd name="adj" fmla="val 3941"/>
+              <a:gd name="adj" fmla="val 4313"/>
             </a:avLst>
           </a:prstGeom>
           <a:ln w="9525">
@@ -14459,7 +14459,7 @@
         <p:spPr>
           <a:xfrm>
             <a:off x="888998" y="3136892"/>
-            <a:ext cx="2920993" cy="527049"/>
+            <a:ext cx="2920993" cy="628648"/>
           </a:xfrm>
           <a:prstGeom prst="rect">
             <a:avLst/>
@@ -14498,7 +14498,7 @@
         <p:spPr>
           <a:xfrm>
             <a:off x="3886190" y="3136892"/>
-            <a:ext cx="2349494" cy="527049"/>
+            <a:ext cx="2349494" cy="628648"/>
           </a:xfrm>
           <a:prstGeom prst="rect">
             <a:avLst/>
@@ -14537,7 +14537,7 @@
         <p:spPr>
           <a:xfrm>
             <a:off x="6324584" y="3136892"/>
-            <a:ext cx="2349494" cy="527049"/>
+            <a:ext cx="2349494" cy="628648"/>
           </a:xfrm>
           <a:prstGeom prst="rect">
             <a:avLst/>
@@ -14576,7 +14576,7 @@
         <p:spPr>
           <a:xfrm>
             <a:off x="8737578" y="3136892"/>
-            <a:ext cx="2539994" cy="527049"/>
+            <a:ext cx="2539994" cy="628648"/>
           </a:xfrm>
           <a:prstGeom prst="rect">
             <a:avLst/>
@@ -14614,7 +14614,7 @@
         </p:nvSpPr>
         <p:spPr>
           <a:xfrm>
-            <a:off x="609598" y="3663941"/>
+            <a:off x="609598" y="3765541"/>
             <a:ext cx="10972773" cy="0"/>
           </a:xfrm>
           <a:prstGeom prst="line">
@@ -14637,8 +14637,8 @@
         </p:nvSpPr>
         <p:spPr>
           <a:xfrm>
-            <a:off x="888998" y="3663941"/>
-            <a:ext cx="2920993" cy="527049"/>
+            <a:off x="888998" y="3765541"/>
+            <a:ext cx="2920993" cy="628648"/>
           </a:xfrm>
           <a:prstGeom prst="rect">
             <a:avLst/>
@@ -14662,7 +14662,7 @@
                 <a:ea typeface="Arial" pitchFamily="34" charset="-122"/>
                 <a:cs typeface="Arial" pitchFamily="34" charset="-120"/>
               </a:rPr>
-              <a:t>6 beldagen</a:t>
+              <a:t>5 tot 7 beldagen</a:t>
             </a:r>
             <a:endParaRPr lang="en-US" sz="1250" dirty="0"/>
           </a:p>
@@ -14676,8 +14676,8 @@
         </p:nvSpPr>
         <p:spPr>
           <a:xfrm>
-            <a:off x="3886190" y="3663941"/>
-            <a:ext cx="2349494" cy="527049"/>
+            <a:off x="3886190" y="3765541"/>
+            <a:ext cx="2349494" cy="628648"/>
           </a:xfrm>
           <a:prstGeom prst="rect">
             <a:avLst/>
@@ -14715,8 +14715,8 @@
         </p:nvSpPr>
         <p:spPr>
           <a:xfrm>
-            <a:off x="6324584" y="3663941"/>
-            <a:ext cx="2349494" cy="527049"/>
+            <a:off x="6324584" y="3765541"/>
+            <a:ext cx="2349494" cy="628648"/>
           </a:xfrm>
           <a:prstGeom prst="rect">
             <a:avLst/>
@@ -14740,7 +14740,7 @@
                 <a:ea typeface="Arial" pitchFamily="34" charset="-122"/>
                 <a:cs typeface="Arial" pitchFamily="34" charset="-120"/>
               </a:rPr>
-              <a:t>€ 3.300</a:t>
+              <a:t>€ 2.750 tot € 3.850</a:t>
             </a:r>
             <a:endParaRPr lang="en-US" sz="1250" dirty="0"/>
           </a:p>
@@ -14754,8 +14754,8 @@
         </p:nvSpPr>
         <p:spPr>
           <a:xfrm>
-            <a:off x="8737578" y="3663941"/>
-            <a:ext cx="2539994" cy="527049"/>
+            <a:off x="8737578" y="3765541"/>
+            <a:ext cx="2539994" cy="628648"/>
           </a:xfrm>
           <a:prstGeom prst="rect">
             <a:avLst/>
@@ -14779,7 +14779,7 @@
                 <a:ea typeface="Arial" pitchFamily="34" charset="-122"/>
                 <a:cs typeface="Arial" pitchFamily="34" charset="-120"/>
               </a:rPr>
-              <a:t>± 14 leads</a:t>
+              <a:t>± 12 tot 17 leads</a:t>
             </a:r>
             <a:endParaRPr lang="en-US" sz="1250" dirty="0"/>
           </a:p>
@@ -14793,8 +14793,8 @@
         </p:nvSpPr>
         <p:spPr>
           <a:xfrm>
-            <a:off x="615948" y="4190990"/>
-            <a:ext cx="10960073" cy="527049"/>
+            <a:off x="615948" y="4394189"/>
+            <a:ext cx="10960073" cy="628648"/>
           </a:xfrm>
           <a:prstGeom prst="rect">
             <a:avLst/>
@@ -14815,7 +14815,7 @@
         </p:nvSpPr>
         <p:spPr>
           <a:xfrm>
-            <a:off x="609598" y="4190990"/>
+            <a:off x="609598" y="4394189"/>
             <a:ext cx="10972773" cy="0"/>
           </a:xfrm>
           <a:prstGeom prst="line">
@@ -14838,8 +14838,8 @@
         </p:nvSpPr>
         <p:spPr>
           <a:xfrm>
-            <a:off x="888998" y="4190990"/>
-            <a:ext cx="2920993" cy="527049"/>
+            <a:off x="888998" y="4394189"/>
+            <a:ext cx="2920993" cy="628648"/>
           </a:xfrm>
           <a:prstGeom prst="rect">
             <a:avLst/>
@@ -14863,7 +14863,7 @@
                 <a:ea typeface="Arial" pitchFamily="34" charset="-122"/>
                 <a:cs typeface="Arial" pitchFamily="34" charset="-120"/>
               </a:rPr>
-              <a:t>8 beldagen</a:t>
+              <a:t>8 beldagen of meer</a:t>
             </a:r>
             <a:pPr indent="0" marL="0">
               <a:buNone/>
@@ -14891,8 +14891,8 @@
         </p:nvSpPr>
         <p:spPr>
           <a:xfrm>
-            <a:off x="3886190" y="4190990"/>
-            <a:ext cx="2349494" cy="527049"/>
+            <a:off x="3886190" y="4394189"/>
+            <a:ext cx="2349494" cy="628648"/>
           </a:xfrm>
           <a:prstGeom prst="rect">
             <a:avLst/>
@@ -14930,8 +14930,8 @@
         </p:nvSpPr>
         <p:spPr>
           <a:xfrm>
-            <a:off x="6324584" y="4190990"/>
-            <a:ext cx="2349494" cy="527049"/>
+            <a:off x="6324584" y="4394189"/>
+            <a:ext cx="2349494" cy="628648"/>
           </a:xfrm>
           <a:prstGeom prst="rect">
             <a:avLst/>
@@ -14955,7 +14955,7 @@
                 <a:ea typeface="Arial" pitchFamily="34" charset="-122"/>
                 <a:cs typeface="Arial" pitchFamily="34" charset="-120"/>
               </a:rPr>
-              <a:t>€ 4.000</a:t>
+              <a:t>vanaf € 4.000</a:t>
             </a:r>
             <a:endParaRPr lang="en-US" sz="1250" dirty="0"/>
           </a:p>
@@ -14969,8 +14969,8 @@
         </p:nvSpPr>
         <p:spPr>
           <a:xfrm>
-            <a:off x="8737578" y="4190990"/>
-            <a:ext cx="2539994" cy="527049"/>
+            <a:off x="8737578" y="4394189"/>
+            <a:ext cx="2539994" cy="628648"/>
           </a:xfrm>
           <a:prstGeom prst="rect">
             <a:avLst/>
@@ -14994,7 +14994,7 @@
                 <a:ea typeface="Arial" pitchFamily="34" charset="-122"/>
                 <a:cs typeface="Arial" pitchFamily="34" charset="-120"/>
               </a:rPr>
-              <a:t>± 19 leads</a:t>
+              <a:t>vanaf ± 19 leads</a:t>
             </a:r>
             <a:endParaRPr lang="en-US" sz="1250" dirty="0"/>
           </a:p>
@@ -15003,185 +15003,6 @@
       <p:sp>
         <p:nvSpPr>
           <p:cNvPr id="28" name="Shape 26"/>
-          <p:cNvSpPr/>
-          <p:nvPr/>
-        </p:nvSpPr>
-        <p:spPr>
-          <a:xfrm>
-            <a:off x="609598" y="4718038"/>
-            <a:ext cx="10972773" cy="0"/>
-          </a:xfrm>
-          <a:prstGeom prst="line">
-            <a:avLst/>
-          </a:prstGeom>
-          <a:noFill/>
-          <a:ln w="9525">
-            <a:solidFill>
-              <a:srgbClr val="3A4152"/>
-            </a:solidFill>
-            <a:prstDash val="solid"/>
-          </a:ln>
-        </p:spPr>
-      </p:sp>
-      <p:sp>
-        <p:nvSpPr>
-          <p:cNvPr id="29" name="Text 27"/>
-          <p:cNvSpPr txBox="1"/>
-          <p:nvPr/>
-        </p:nvSpPr>
-        <p:spPr>
-          <a:xfrm>
-            <a:off x="888998" y="4718038"/>
-            <a:ext cx="2920993" cy="527049"/>
-          </a:xfrm>
-          <a:prstGeom prst="rect">
-            <a:avLst/>
-          </a:prstGeom>
-          <a:noFill/>
-          <a:ln/>
-        </p:spPr>
-        <p:txBody>
-          <a:bodyPr wrap="square" lIns="0" tIns="0" rIns="0" bIns="0" rtlCol="0" anchor="ctr"/>
-          <a:lstStyle/>
-          <a:p>
-            <a:pPr indent="0" marL="0">
-              <a:buNone/>
-            </a:pPr>
-            <a:r>
-              <a:rPr lang="en-US" sz="1250" b="1" dirty="0">
-                <a:solidFill>
-                  <a:srgbClr val="F2EFE6"/>
-                </a:solidFill>
-                <a:latin typeface="Arial" pitchFamily="34" charset="0"/>
-                <a:ea typeface="Arial" pitchFamily="34" charset="-122"/>
-                <a:cs typeface="Arial" pitchFamily="34" charset="-120"/>
-              </a:rPr>
-              <a:t>10 of meer</a:t>
-            </a:r>
-            <a:endParaRPr lang="en-US" sz="1250" dirty="0"/>
-          </a:p>
-        </p:txBody>
-      </p:sp>
-      <p:sp>
-        <p:nvSpPr>
-          <p:cNvPr id="30" name="Text 28"/>
-          <p:cNvSpPr txBox="1"/>
-          <p:nvPr/>
-        </p:nvSpPr>
-        <p:spPr>
-          <a:xfrm>
-            <a:off x="3886190" y="4718038"/>
-            <a:ext cx="2349494" cy="527049"/>
-          </a:xfrm>
-          <a:prstGeom prst="rect">
-            <a:avLst/>
-          </a:prstGeom>
-          <a:noFill/>
-          <a:ln/>
-        </p:spPr>
-        <p:txBody>
-          <a:bodyPr wrap="square" lIns="0" tIns="0" rIns="0" bIns="0" rtlCol="0" anchor="ctr"/>
-          <a:lstStyle/>
-          <a:p>
-            <a:pPr indent="0" marL="0">
-              <a:buNone/>
-            </a:pPr>
-            <a:r>
-              <a:rPr lang="en-US" sz="1250" b="1" dirty="0">
-                <a:solidFill>
-                  <a:srgbClr val="F2EFE6"/>
-                </a:solidFill>
-                <a:latin typeface="Arial" pitchFamily="34" charset="0"/>
-                <a:ea typeface="Arial" pitchFamily="34" charset="-122"/>
-                <a:cs typeface="Arial" pitchFamily="34" charset="-120"/>
-              </a:rPr>
-              <a:t>€ 475</a:t>
-            </a:r>
-            <a:endParaRPr lang="en-US" sz="1250" dirty="0"/>
-          </a:p>
-        </p:txBody>
-      </p:sp>
-      <p:sp>
-        <p:nvSpPr>
-          <p:cNvPr id="31" name="Text 29"/>
-          <p:cNvSpPr txBox="1"/>
-          <p:nvPr/>
-        </p:nvSpPr>
-        <p:spPr>
-          <a:xfrm>
-            <a:off x="6324584" y="4718038"/>
-            <a:ext cx="2349494" cy="527049"/>
-          </a:xfrm>
-          <a:prstGeom prst="rect">
-            <a:avLst/>
-          </a:prstGeom>
-          <a:noFill/>
-          <a:ln/>
-        </p:spPr>
-        <p:txBody>
-          <a:bodyPr wrap="square" lIns="0" tIns="0" rIns="0" bIns="0" rtlCol="0" anchor="ctr"/>
-          <a:lstStyle/>
-          <a:p>
-            <a:pPr indent="0" marL="0">
-              <a:buNone/>
-            </a:pPr>
-            <a:r>
-              <a:rPr lang="en-US" sz="1250" b="1" dirty="0">
-                <a:solidFill>
-                  <a:srgbClr val="F2EFE6"/>
-                </a:solidFill>
-                <a:latin typeface="Arial" pitchFamily="34" charset="0"/>
-                <a:ea typeface="Arial" pitchFamily="34" charset="-122"/>
-                <a:cs typeface="Arial" pitchFamily="34" charset="-120"/>
-              </a:rPr>
-              <a:t>vanaf € 4.750</a:t>
-            </a:r>
-            <a:endParaRPr lang="en-US" sz="1250" dirty="0"/>
-          </a:p>
-        </p:txBody>
-      </p:sp>
-      <p:sp>
-        <p:nvSpPr>
-          <p:cNvPr id="32" name="Text 30"/>
-          <p:cNvSpPr txBox="1"/>
-          <p:nvPr/>
-        </p:nvSpPr>
-        <p:spPr>
-          <a:xfrm>
-            <a:off x="8737578" y="4718038"/>
-            <a:ext cx="2539994" cy="527049"/>
-          </a:xfrm>
-          <a:prstGeom prst="rect">
-            <a:avLst/>
-          </a:prstGeom>
-          <a:noFill/>
-          <a:ln/>
-        </p:spPr>
-        <p:txBody>
-          <a:bodyPr wrap="square" lIns="0" tIns="0" rIns="0" bIns="0" rtlCol="0" anchor="ctr"/>
-          <a:lstStyle/>
-          <a:p>
-            <a:pPr indent="0" marL="0">
-              <a:buNone/>
-            </a:pPr>
-            <a:r>
-              <a:rPr lang="en-US" sz="1250" b="1" dirty="0">
-                <a:solidFill>
-                  <a:srgbClr val="F2EFE6"/>
-                </a:solidFill>
-                <a:latin typeface="Arial" pitchFamily="34" charset="0"/>
-                <a:ea typeface="Arial" pitchFamily="34" charset="-122"/>
-                <a:cs typeface="Arial" pitchFamily="34" charset="-120"/>
-              </a:rPr>
-              <a:t>in overleg</a:t>
-            </a:r>
-            <a:endParaRPr lang="en-US" sz="1250" dirty="0"/>
-          </a:p>
-        </p:txBody>
-      </p:sp>
-      <p:sp>
-        <p:nvSpPr>
-          <p:cNvPr id="33" name="Shape 31"/>
           <p:cNvSpPr/>
           <p:nvPr/>
         </p:nvSpPr>
@@ -15201,7 +15022,7 @@
       </p:sp>
       <p:sp>
         <p:nvSpPr>
-          <p:cNvPr id="34" name="Text 32"/>
+          <p:cNvPr id="29" name="Text 27"/>
           <p:cNvSpPr txBox="1"/>
           <p:nvPr/>
         </p:nvSpPr>

</xml_diff>

<commit_message>
Moyee: succesfee bij klanten die drie maanden achter elkaar bestellen
Co-Authored-By: Claude Opus 5 <noreply@anthropic.com>
Claude-Session: https://claude.ai/code/session_0141FN3f3hHkYQHTyvTJJGrw
</commit_message>
<xml_diff>
--- a/output/LINK. voorstel Moyee Coffee.pptx
+++ b/output/LINK. voorstel Moyee Coffee.pptx
@@ -4484,7 +4484,7 @@
                 <a:ea typeface="Arial" pitchFamily="34" charset="-122"/>
                 <a:cs typeface="Arial" pitchFamily="34" charset="-120"/>
               </a:rPr>
-              <a:t>Wat als het </a:t>
+              <a:t>Zo houden we elkaar </a:t>
             </a:r>
             <a:pPr algn="l" indent="0" marL="0">
               <a:lnSpc>
@@ -4501,7 +4501,7 @@
                 <a:ea typeface="Georgia" pitchFamily="34" charset="-122"/>
                 <a:cs typeface="Georgia" pitchFamily="34" charset="-120"/>
               </a:rPr>
-              <a:t>meer of minder</a:t>
+              <a:t>scherp</a:t>
             </a:r>
             <a:pPr algn="l" indent="0" marL="0">
               <a:lnSpc>
@@ -4518,7 +4518,7 @@
                 <a:ea typeface="Arial" pitchFamily="34" charset="-122"/>
                 <a:cs typeface="Arial" pitchFamily="34" charset="-120"/>
               </a:rPr>
-              <a:t> is.</a:t>
+              <a:t>.</a:t>
             </a:r>
             <a:endParaRPr lang="en-US" sz="3200" dirty="0"/>
           </a:p>
@@ -5164,7 +5164,7 @@
                 <a:ea typeface="Arial" pitchFamily="34" charset="-122"/>
                 <a:cs typeface="Arial" pitchFamily="34" charset="-120"/>
               </a:rPr>
-              <a:t>Geen kosten per tasting meer</a:t>
+              <a:t>Succesfee bij klanten die blijven</a:t>
             </a:r>
             <a:endParaRPr lang="en-US" sz="1150" dirty="0"/>
           </a:p>
@@ -5206,7 +5206,7 @@
                 <a:ea typeface="Arial" pitchFamily="34" charset="-122"/>
                 <a:cs typeface="Arial" pitchFamily="34" charset="-120"/>
               </a:rPr>
-              <a:t>De dagprijs is alles. Er komt geen bedrag per tasting meer bovenop, dus jullie weten vooraf precies wat een periode kost.</a:t>
+              <a:t>Wordt een lead een klant die drie maanden achter elkaar bestelt, dan krijgen wij daar een succesfee over. Zo verdienen wij pas extra als de klant blijft.</a:t>
             </a:r>
             <a:endParaRPr lang="en-US" sz="875" dirty="0"/>
           </a:p>
@@ -5265,7 +5265,7 @@
                 <a:ea typeface="Arial" pitchFamily="34" charset="-122"/>
                 <a:cs typeface="Arial" pitchFamily="34" charset="-120"/>
               </a:rPr>
-              <a:t>De verwachting komt uit jullie eigen cijfers, dus we sturen op iets dat we al waargemaakt hebben.</a:t>
+              <a:t>De verwachting komt uit jullie eigen cijfers, dus we sturen op iets dat we al waargemaakt hebben. Over de hoogte van de succesfee maken we samen een afspraak.</a:t>
             </a:r>
             <a:endParaRPr lang="en-US" sz="1200" dirty="0"/>
           </a:p>

</xml_diff>

<commit_message>
Moyee: hele belexport verwerkt als databron voor deck en brew sheet
- analyse-moyee.py leest de Steam-export en schrijft content/moyee-stats.json
- sync-moyee.py vult de deck, brew-moyee.py vult de webpresentatie
- 2.629 pogingen, 61 leads, 23 tastings, pijplijn en dag/dagdeel-analyse
- staffel herrekend op 23,2 leads per 1.000 pogingen bij 100 pogingen per beldag

Co-Authored-By: Claude Opus 5 <noreply@anthropic.com>
Claude-Session: https://claude.ai/code/session_0141FN3f3hHkYQHTyvTJJGrw
</commit_message>
<xml_diff>
--- a/output/LINK. voorstel Moyee Coffee.pptx
+++ b/output/LINK. voorstel Moyee Coffee.pptx
@@ -18,9 +18,10 @@
     <p:sldId id="266" r:id="rId12"/>
     <p:sldId id="267" r:id="rId13"/>
     <p:sldId id="268" r:id="rId14"/>
+    <p:sldId id="269" r:id="rId15"/>
   </p:sldIdLst>
   <p:notesMasterIdLst>
-    <p:notesMasterId r:id="rId15"/>
+    <p:notesMasterId r:id="rId16"/>
   </p:notesMasterIdLst>
   <p:sldSz cx="12191970" cy="6858000"/>
   <p:notesSz cx="6858000" cy="12191970"/>
@@ -890,6 +891,94 @@
             <a:fld id="{F7021451-1387-4CA6-816F-3879F97B5CBC}" type="slidenum">
               <a:rPr lang="en-US"/>
               <a:t>13</a:t>
+            </a:fld>
+            <a:endParaRPr lang="en-US"/>
+          </a:p>
+        </p:txBody>
+      </p:sp>
+    </p:spTree>
+    <p:extLst>
+      <p:ext uri="{BB962C8B-B14F-4D97-AF65-F5344CB8AC3E}">
+        <p14:creationId xmlns:p14="http://schemas.microsoft.com/office/powerpoint/2010/main" val="1024086991"/>
+      </p:ext>
+    </p:extLst>
+  </p:cSld>
+  <p:clrMapOvr>
+    <a:masterClrMapping/>
+  </p:clrMapOvr>
+</p:notes>
+</file>
+
+<file path=ppt/notesSlides/notesSlide14.xml><?xml version="1.0" encoding="utf-8"?>
+<p:notes xmlns:a="http://schemas.openxmlformats.org/drawingml/2006/main" xmlns:r="http://schemas.openxmlformats.org/officeDocument/2006/relationships" xmlns:p="http://schemas.openxmlformats.org/presentationml/2006/main">
+  <p:cSld>
+    <p:spTree>
+      <p:nvGrpSpPr>
+        <p:cNvPr id="1" name=""/>
+        <p:cNvGrpSpPr/>
+        <p:nvPr/>
+      </p:nvGrpSpPr>
+      <p:grpSpPr>
+        <a:xfrm>
+          <a:off x="0" y="0"/>
+          <a:ext cx="0" cy="0"/>
+          <a:chOff x="0" y="0"/>
+          <a:chExt cx="0" cy="0"/>
+        </a:xfrm>
+      </p:grpSpPr>
+      <p:sp>
+        <p:nvSpPr>
+          <p:cNvPr id="2" name="Slide Image Placeholder 1"/>
+          <p:cNvSpPr>
+            <a:spLocks noGrp="1" noRot="1" noChangeAspect="1"/>
+          </p:cNvSpPr>
+          <p:nvPr>
+            <p:ph type="sldImg"/>
+          </p:nvPr>
+        </p:nvSpPr>
+        <p:spPr/>
+      </p:sp>
+      <p:sp>
+        <p:nvSpPr>
+          <p:cNvPr id="3" name="Notes Placeholder 2"/>
+          <p:cNvSpPr>
+            <a:spLocks noGrp="1"/>
+          </p:cNvSpPr>
+          <p:nvPr>
+            <p:ph type="body" idx="1"/>
+          </p:nvPr>
+        </p:nvSpPr>
+        <p:spPr/>
+        <p:txBody>
+          <a:bodyPr/>
+          <a:lstStyle/>
+          <a:p>
+            <a:r>
+              <a:rPr lang="en-US" dirty="0"/>
+              <a:t/>
+            </a:r>
+            <a:endParaRPr lang="en-US" dirty="0"/>
+          </a:p>
+        </p:txBody>
+      </p:sp>
+      <p:sp>
+        <p:nvSpPr>
+          <p:cNvPr id="4" name="Slide Number Placeholder 3"/>
+          <p:cNvSpPr>
+            <a:spLocks noGrp="1"/>
+          </p:cNvSpPr>
+          <p:nvPr>
+            <p:ph type="sldNum" sz="quarter" idx="10"/>
+          </p:nvPr>
+        </p:nvSpPr>
+        <p:spPr/>
+        <p:txBody>
+          <a:bodyPr/>
+          <a:lstStyle/>
+          <a:p>
+            <a:fld id="{F7021451-1387-4CA6-816F-3879F97B5CBC}" type="slidenum">
+              <a:rPr lang="en-US"/>
+              <a:t>14</a:t>
             </a:fld>
             <a:endParaRPr lang="en-US"/>
           </a:p>
@@ -2629,7 +2718,7 @@
                 <a:ea typeface="Arial" pitchFamily="34" charset="-122"/>
                 <a:cs typeface="Arial" pitchFamily="34" charset="-120"/>
               </a:rPr>
-              <a:t>1 / 13</a:t>
+              <a:t>1 / 14</a:t>
             </a:r>
             <a:endParaRPr lang="en-US" sz="750" dirty="0"/>
           </a:p>
@@ -2786,7 +2875,7 @@
                 <a:ea typeface="Arial" pitchFamily="34" charset="-122"/>
                 <a:cs typeface="Arial" pitchFamily="34" charset="-120"/>
               </a:rPr>
-              <a:t>Wat negentien weken bellen voor Moyee heeft opgeleverd, hoe wij werken en het voorstel om vanaf nu met vaste beldagen per vier weken te draaien.</a:t>
+              <a:t>Wat bijna zes maanden bellen voor Moyee heeft opgeleverd, hoe wij werken en het voorstel om vanaf nu met vaste beldagen per vier weken te draaien.</a:t>
             </a:r>
             <a:endParaRPr lang="en-US" sz="1400" dirty="0"/>
           </a:p>
@@ -2958,6 +3047,1096 @@
 <file path=ppt/slides/slide10.xml><?xml version="1.0" encoding="utf-8"?>
 <p:sld xmlns:a="http://schemas.openxmlformats.org/drawingml/2006/main" xmlns:r="http://schemas.openxmlformats.org/officeDocument/2006/relationships" xmlns:p="http://schemas.openxmlformats.org/presentationml/2006/main">
   <p:cSld name="Slide 10">
+    <p:bg>
+      <p:bgPr>
+        <a:solidFill>
+          <a:srgbClr val="141821"/>
+        </a:solidFill>
+      </p:bgPr>
+    </p:bg>
+    <p:spTree>
+      <p:nvGrpSpPr>
+        <p:cNvPr id="1" name=""/>
+        <p:cNvGrpSpPr/>
+        <p:nvPr/>
+      </p:nvGrpSpPr>
+      <p:grpSpPr>
+        <a:xfrm>
+          <a:off x="0" y="0"/>
+          <a:ext cx="0" cy="0"/>
+          <a:chOff x="0" y="0"/>
+          <a:chExt cx="0" cy="0"/>
+        </a:xfrm>
+      </p:grpSpPr>
+      <p:sp>
+        <p:nvSpPr>
+          <p:cNvPr id="2" name="Text 0"/>
+          <p:cNvSpPr txBox="1"/>
+          <p:nvPr/>
+        </p:nvSpPr>
+        <p:spPr>
+          <a:xfrm>
+            <a:off x="596899" y="368299"/>
+            <a:ext cx="1904995" cy="330199"/>
+          </a:xfrm>
+          <a:prstGeom prst="rect">
+            <a:avLst/>
+          </a:prstGeom>
+          <a:noFill/>
+          <a:ln/>
+        </p:spPr>
+        <p:txBody>
+          <a:bodyPr wrap="square" lIns="0" tIns="0" rIns="0" bIns="0" rtlCol="0" anchor="ctr"/>
+          <a:lstStyle/>
+          <a:p>
+            <a:pPr algn="l" indent="0" marL="0">
+              <a:buNone/>
+            </a:pPr>
+            <a:r>
+              <a:rPr lang="en-US" sz="1800" b="1" dirty="0">
+                <a:solidFill>
+                  <a:srgbClr val="F2EFE6"/>
+                </a:solidFill>
+                <a:latin typeface="Arial" pitchFamily="34" charset="0"/>
+                <a:ea typeface="Arial" pitchFamily="34" charset="-122"/>
+                <a:cs typeface="Arial" pitchFamily="34" charset="-120"/>
+              </a:rPr>
+              <a:t>LINK</a:t>
+            </a:r>
+            <a:pPr algn="l" indent="0" marL="0">
+              <a:buNone/>
+            </a:pPr>
+            <a:r>
+              <a:rPr lang="en-US" sz="1800" b="1" dirty="0">
+                <a:solidFill>
+                  <a:srgbClr val="38B6FF"/>
+                </a:solidFill>
+                <a:latin typeface="Arial" pitchFamily="34" charset="0"/>
+                <a:ea typeface="Arial" pitchFamily="34" charset="-122"/>
+                <a:cs typeface="Arial" pitchFamily="34" charset="-120"/>
+              </a:rPr>
+              <a:t>.</a:t>
+            </a:r>
+            <a:endParaRPr lang="en-US" sz="1800" dirty="0"/>
+          </a:p>
+        </p:txBody>
+      </p:sp>
+      <p:sp>
+        <p:nvSpPr>
+          <p:cNvPr id="3" name="Text 1"/>
+          <p:cNvSpPr txBox="1"/>
+          <p:nvPr/>
+        </p:nvSpPr>
+        <p:spPr>
+          <a:xfrm>
+            <a:off x="609598" y="6381734"/>
+            <a:ext cx="5714986" cy="228599"/>
+          </a:xfrm>
+          <a:prstGeom prst="rect">
+            <a:avLst/>
+          </a:prstGeom>
+          <a:noFill/>
+          <a:ln/>
+        </p:spPr>
+        <p:txBody>
+          <a:bodyPr wrap="square" lIns="0" tIns="0" rIns="0" bIns="0" rtlCol="0" anchor="ctr"/>
+          <a:lstStyle/>
+          <a:p>
+            <a:pPr algn="l" indent="0" marL="0">
+              <a:buNone/>
+            </a:pPr>
+            <a:r>
+              <a:rPr lang="en-US" sz="750" b="1" spc="100" kern="0" dirty="0">
+                <a:solidFill>
+                  <a:srgbClr val="BDC3CE"/>
+                </a:solidFill>
+                <a:latin typeface="Arial" pitchFamily="34" charset="0"/>
+                <a:ea typeface="Arial" pitchFamily="34" charset="-122"/>
+                <a:cs typeface="Arial" pitchFamily="34" charset="-120"/>
+              </a:rPr>
+              <a:t>LINK. · Moyee Coffee</a:t>
+            </a:r>
+            <a:endParaRPr lang="en-US" sz="750" dirty="0"/>
+          </a:p>
+        </p:txBody>
+      </p:sp>
+      <p:sp>
+        <p:nvSpPr>
+          <p:cNvPr id="4" name="Text 2"/>
+          <p:cNvSpPr txBox="1"/>
+          <p:nvPr/>
+        </p:nvSpPr>
+        <p:spPr>
+          <a:xfrm>
+            <a:off x="9677376" y="6381734"/>
+            <a:ext cx="1904995" cy="228599"/>
+          </a:xfrm>
+          <a:prstGeom prst="rect">
+            <a:avLst/>
+          </a:prstGeom>
+          <a:noFill/>
+          <a:ln/>
+        </p:spPr>
+        <p:txBody>
+          <a:bodyPr wrap="square" lIns="0" tIns="0" rIns="0" bIns="0" rtlCol="0" anchor="ctr"/>
+          <a:lstStyle/>
+          <a:p>
+            <a:pPr algn="r" indent="0" marL="0">
+              <a:buNone/>
+            </a:pPr>
+            <a:r>
+              <a:rPr lang="en-US" sz="750" b="1" spc="100" kern="0" dirty="0">
+                <a:solidFill>
+                  <a:srgbClr val="BDC3CE"/>
+                </a:solidFill>
+                <a:latin typeface="Arial" pitchFamily="34" charset="0"/>
+                <a:ea typeface="Arial" pitchFamily="34" charset="-122"/>
+                <a:cs typeface="Arial" pitchFamily="34" charset="-120"/>
+              </a:rPr>
+              <a:t>10 / 14</a:t>
+            </a:r>
+            <a:endParaRPr lang="en-US" sz="750" dirty="0"/>
+          </a:p>
+        </p:txBody>
+      </p:sp>
+      <p:sp>
+        <p:nvSpPr>
+          <p:cNvPr id="5" name="Text 3"/>
+          <p:cNvSpPr txBox="1"/>
+          <p:nvPr/>
+        </p:nvSpPr>
+        <p:spPr>
+          <a:xfrm>
+            <a:off x="609598" y="1206497"/>
+            <a:ext cx="10159975" cy="215899"/>
+          </a:xfrm>
+          <a:prstGeom prst="rect">
+            <a:avLst/>
+          </a:prstGeom>
+          <a:noFill/>
+          <a:ln/>
+        </p:spPr>
+        <p:txBody>
+          <a:bodyPr wrap="square" lIns="0" tIns="0" rIns="0" bIns="0" rtlCol="0" anchor="ctr"/>
+          <a:lstStyle/>
+          <a:p>
+            <a:pPr algn="l" indent="0" marL="0">
+              <a:buNone/>
+            </a:pPr>
+            <a:r>
+              <a:rPr lang="en-US" sz="950" b="1" spc="400" kern="0" dirty="0">
+                <a:solidFill>
+                  <a:srgbClr val="38B6FF"/>
+                </a:solidFill>
+                <a:latin typeface="Arial" pitchFamily="34" charset="0"/>
+                <a:ea typeface="Arial" pitchFamily="34" charset="-122"/>
+                <a:cs typeface="Arial" pitchFamily="34" charset="-120"/>
+              </a:rPr>
+              <a:t>HET VOORSTEL</a:t>
+            </a:r>
+            <a:endParaRPr lang="en-US" sz="950" dirty="0"/>
+          </a:p>
+        </p:txBody>
+      </p:sp>
+      <p:sp>
+        <p:nvSpPr>
+          <p:cNvPr id="6" name="Text 4"/>
+          <p:cNvSpPr txBox="1"/>
+          <p:nvPr/>
+        </p:nvSpPr>
+        <p:spPr>
+          <a:xfrm>
+            <a:off x="609598" y="1511296"/>
+            <a:ext cx="10972773" cy="1142997"/>
+          </a:xfrm>
+          <a:prstGeom prst="rect">
+            <a:avLst/>
+          </a:prstGeom>
+          <a:noFill/>
+          <a:ln/>
+        </p:spPr>
+        <p:txBody>
+          <a:bodyPr wrap="square" lIns="0" tIns="0" rIns="0" bIns="0" rtlCol="0" anchor="t"/>
+          <a:lstStyle/>
+          <a:p>
+            <a:pPr algn="l" indent="0" marL="0">
+              <a:lnSpc>
+                <a:spcPct val="108000"/>
+              </a:lnSpc>
+              <a:buNone/>
+            </a:pPr>
+            <a:r>
+              <a:rPr lang="en-US" sz="3200" b="1" dirty="0">
+                <a:solidFill>
+                  <a:srgbClr val="F2EFE6"/>
+                </a:solidFill>
+                <a:latin typeface="Arial" pitchFamily="34" charset="0"/>
+                <a:ea typeface="Arial" pitchFamily="34" charset="-122"/>
+                <a:cs typeface="Arial" pitchFamily="34" charset="-120"/>
+              </a:rPr>
+              <a:t>Vaste beldagen per vier weken, </a:t>
+            </a:r>
+            <a:pPr algn="l" indent="0" marL="0">
+              <a:lnSpc>
+                <a:spcPct val="108000"/>
+              </a:lnSpc>
+              <a:buNone/>
+            </a:pPr>
+            <a:r>
+              <a:rPr lang="en-US" sz="3000" i="1" dirty="0">
+                <a:solidFill>
+                  <a:srgbClr val="F2EFE6"/>
+                </a:solidFill>
+                <a:latin typeface="Georgia" pitchFamily="34" charset="0"/>
+                <a:ea typeface="Georgia" pitchFamily="34" charset="-122"/>
+                <a:cs typeface="Georgia" pitchFamily="34" charset="-120"/>
+              </a:rPr>
+              <a:t>één dagprijs</a:t>
+            </a:r>
+            <a:pPr algn="l" indent="0" marL="0">
+              <a:lnSpc>
+                <a:spcPct val="108000"/>
+              </a:lnSpc>
+              <a:buNone/>
+            </a:pPr>
+            <a:r>
+              <a:rPr lang="en-US" sz="3200" b="1" dirty="0">
+                <a:solidFill>
+                  <a:srgbClr val="F2EFE6"/>
+                </a:solidFill>
+                <a:latin typeface="Arial" pitchFamily="34" charset="0"/>
+                <a:ea typeface="Arial" pitchFamily="34" charset="-122"/>
+                <a:cs typeface="Arial" pitchFamily="34" charset="-120"/>
+              </a:rPr>
+              <a:t>.</a:t>
+            </a:r>
+            <a:endParaRPr lang="en-US" sz="3200" dirty="0"/>
+          </a:p>
+        </p:txBody>
+      </p:sp>
+      <p:sp>
+        <p:nvSpPr>
+          <p:cNvPr id="7" name="Shape 5"/>
+          <p:cNvSpPr/>
+          <p:nvPr/>
+        </p:nvSpPr>
+        <p:spPr>
+          <a:xfrm>
+            <a:off x="609598" y="2666993"/>
+            <a:ext cx="10972773" cy="2355844"/>
+          </a:xfrm>
+          <a:prstGeom prst="roundRect">
+            <a:avLst>
+              <a:gd name="adj" fmla="val 4313"/>
+            </a:avLst>
+          </a:prstGeom>
+          <a:ln w="9525">
+            <a:solidFill>
+              <a:srgbClr val="3A4152"/>
+            </a:solidFill>
+            <a:prstDash val="solid"/>
+          </a:ln>
+        </p:spPr>
+      </p:sp>
+      <p:sp>
+        <p:nvSpPr>
+          <p:cNvPr id="8" name="Text 6"/>
+          <p:cNvSpPr txBox="1"/>
+          <p:nvPr/>
+        </p:nvSpPr>
+        <p:spPr>
+          <a:xfrm>
+            <a:off x="888998" y="2666993"/>
+            <a:ext cx="2920993" cy="469899"/>
+          </a:xfrm>
+          <a:prstGeom prst="rect">
+            <a:avLst/>
+          </a:prstGeom>
+          <a:noFill/>
+          <a:ln/>
+        </p:spPr>
+        <p:txBody>
+          <a:bodyPr wrap="square" lIns="0" tIns="0" rIns="0" bIns="0" rtlCol="0" anchor="ctr"/>
+          <a:lstStyle/>
+          <a:p>
+            <a:pPr indent="0" marL="0">
+              <a:buNone/>
+            </a:pPr>
+            <a:r>
+              <a:rPr lang="en-US" sz="800" b="1" spc="160" kern="0" dirty="0">
+                <a:solidFill>
+                  <a:srgbClr val="C2C8D2"/>
+                </a:solidFill>
+                <a:latin typeface="Arial" pitchFamily="34" charset="0"/>
+                <a:ea typeface="Arial" pitchFamily="34" charset="-122"/>
+                <a:cs typeface="Arial" pitchFamily="34" charset="-120"/>
+              </a:rPr>
+              <a:t>BELDAGEN PER 4 WEKEN</a:t>
+            </a:r>
+            <a:endParaRPr lang="en-US" sz="800" dirty="0"/>
+          </a:p>
+        </p:txBody>
+      </p:sp>
+      <p:sp>
+        <p:nvSpPr>
+          <p:cNvPr id="9" name="Text 7"/>
+          <p:cNvSpPr txBox="1"/>
+          <p:nvPr/>
+        </p:nvSpPr>
+        <p:spPr>
+          <a:xfrm>
+            <a:off x="3886190" y="2666993"/>
+            <a:ext cx="2349494" cy="469899"/>
+          </a:xfrm>
+          <a:prstGeom prst="rect">
+            <a:avLst/>
+          </a:prstGeom>
+          <a:noFill/>
+          <a:ln/>
+        </p:spPr>
+        <p:txBody>
+          <a:bodyPr wrap="square" lIns="0" tIns="0" rIns="0" bIns="0" rtlCol="0" anchor="ctr"/>
+          <a:lstStyle/>
+          <a:p>
+            <a:pPr indent="0" marL="0">
+              <a:buNone/>
+            </a:pPr>
+            <a:r>
+              <a:rPr lang="en-US" sz="800" b="1" spc="160" kern="0" dirty="0">
+                <a:solidFill>
+                  <a:srgbClr val="C2C8D2"/>
+                </a:solidFill>
+                <a:latin typeface="Arial" pitchFamily="34" charset="0"/>
+                <a:ea typeface="Arial" pitchFamily="34" charset="-122"/>
+                <a:cs typeface="Arial" pitchFamily="34" charset="-120"/>
+              </a:rPr>
+              <a:t>PRIJS PER BELDAG</a:t>
+            </a:r>
+            <a:endParaRPr lang="en-US" sz="800" dirty="0"/>
+          </a:p>
+        </p:txBody>
+      </p:sp>
+      <p:sp>
+        <p:nvSpPr>
+          <p:cNvPr id="10" name="Text 8"/>
+          <p:cNvSpPr txBox="1"/>
+          <p:nvPr/>
+        </p:nvSpPr>
+        <p:spPr>
+          <a:xfrm>
+            <a:off x="6324584" y="2666993"/>
+            <a:ext cx="2349494" cy="469899"/>
+          </a:xfrm>
+          <a:prstGeom prst="rect">
+            <a:avLst/>
+          </a:prstGeom>
+          <a:noFill/>
+          <a:ln/>
+        </p:spPr>
+        <p:txBody>
+          <a:bodyPr wrap="square" lIns="0" tIns="0" rIns="0" bIns="0" rtlCol="0" anchor="ctr"/>
+          <a:lstStyle/>
+          <a:p>
+            <a:pPr indent="0" marL="0">
+              <a:buNone/>
+            </a:pPr>
+            <a:r>
+              <a:rPr lang="en-US" sz="800" b="1" spc="160" kern="0" dirty="0">
+                <a:solidFill>
+                  <a:srgbClr val="C2C8D2"/>
+                </a:solidFill>
+                <a:latin typeface="Arial" pitchFamily="34" charset="0"/>
+                <a:ea typeface="Arial" pitchFamily="34" charset="-122"/>
+                <a:cs typeface="Arial" pitchFamily="34" charset="-120"/>
+              </a:rPr>
+              <a:t>PER 4 WEKEN</a:t>
+            </a:r>
+            <a:endParaRPr lang="en-US" sz="800" dirty="0"/>
+          </a:p>
+        </p:txBody>
+      </p:sp>
+      <p:sp>
+        <p:nvSpPr>
+          <p:cNvPr id="11" name="Text 9"/>
+          <p:cNvSpPr txBox="1"/>
+          <p:nvPr/>
+        </p:nvSpPr>
+        <p:spPr>
+          <a:xfrm>
+            <a:off x="8737578" y="2666993"/>
+            <a:ext cx="2539994" cy="469899"/>
+          </a:xfrm>
+          <a:prstGeom prst="rect">
+            <a:avLst/>
+          </a:prstGeom>
+          <a:noFill/>
+          <a:ln/>
+        </p:spPr>
+        <p:txBody>
+          <a:bodyPr wrap="square" lIns="0" tIns="0" rIns="0" bIns="0" rtlCol="0" anchor="ctr"/>
+          <a:lstStyle/>
+          <a:p>
+            <a:pPr indent="0" marL="0">
+              <a:buNone/>
+            </a:pPr>
+            <a:r>
+              <a:rPr lang="en-US" sz="800" b="1" spc="160" kern="0" dirty="0">
+                <a:solidFill>
+                  <a:srgbClr val="C2C8D2"/>
+                </a:solidFill>
+                <a:latin typeface="Arial" pitchFamily="34" charset="0"/>
+                <a:ea typeface="Arial" pitchFamily="34" charset="-122"/>
+                <a:cs typeface="Arial" pitchFamily="34" charset="-120"/>
+              </a:rPr>
+              <a:t>VERWACHTE LEADS</a:t>
+            </a:r>
+            <a:endParaRPr lang="en-US" sz="800" dirty="0"/>
+          </a:p>
+        </p:txBody>
+      </p:sp>
+      <p:sp>
+        <p:nvSpPr>
+          <p:cNvPr id="12" name="Shape 10"/>
+          <p:cNvSpPr/>
+          <p:nvPr/>
+        </p:nvSpPr>
+        <p:spPr>
+          <a:xfrm>
+            <a:off x="609598" y="3136892"/>
+            <a:ext cx="10972773" cy="0"/>
+          </a:xfrm>
+          <a:prstGeom prst="line">
+            <a:avLst/>
+          </a:prstGeom>
+          <a:noFill/>
+          <a:ln w="9525">
+            <a:solidFill>
+              <a:srgbClr val="3A4152"/>
+            </a:solidFill>
+            <a:prstDash val="solid"/>
+          </a:ln>
+        </p:spPr>
+      </p:sp>
+      <p:sp>
+        <p:nvSpPr>
+          <p:cNvPr id="13" name="Text 11"/>
+          <p:cNvSpPr txBox="1"/>
+          <p:nvPr/>
+        </p:nvSpPr>
+        <p:spPr>
+          <a:xfrm>
+            <a:off x="888998" y="3136892"/>
+            <a:ext cx="2920993" cy="628648"/>
+          </a:xfrm>
+          <a:prstGeom prst="rect">
+            <a:avLst/>
+          </a:prstGeom>
+          <a:noFill/>
+          <a:ln/>
+        </p:spPr>
+        <p:txBody>
+          <a:bodyPr wrap="square" lIns="0" tIns="0" rIns="0" bIns="0" rtlCol="0" anchor="ctr"/>
+          <a:lstStyle/>
+          <a:p>
+            <a:pPr indent="0" marL="0">
+              <a:buNone/>
+            </a:pPr>
+            <a:r>
+              <a:rPr lang="en-US" sz="1250" b="1" dirty="0">
+                <a:solidFill>
+                  <a:srgbClr val="F2EFE6"/>
+                </a:solidFill>
+                <a:latin typeface="Arial" pitchFamily="34" charset="0"/>
+                <a:ea typeface="Arial" pitchFamily="34" charset="-122"/>
+                <a:cs typeface="Arial" pitchFamily="34" charset="-120"/>
+              </a:rPr>
+              <a:t>4 beldagen</a:t>
+            </a:r>
+            <a:endParaRPr lang="en-US" sz="1250" dirty="0"/>
+          </a:p>
+        </p:txBody>
+      </p:sp>
+      <p:sp>
+        <p:nvSpPr>
+          <p:cNvPr id="14" name="Text 12"/>
+          <p:cNvSpPr txBox="1"/>
+          <p:nvPr/>
+        </p:nvSpPr>
+        <p:spPr>
+          <a:xfrm>
+            <a:off x="3886190" y="3136892"/>
+            <a:ext cx="2349494" cy="628648"/>
+          </a:xfrm>
+          <a:prstGeom prst="rect">
+            <a:avLst/>
+          </a:prstGeom>
+          <a:noFill/>
+          <a:ln/>
+        </p:spPr>
+        <p:txBody>
+          <a:bodyPr wrap="square" lIns="0" tIns="0" rIns="0" bIns="0" rtlCol="0" anchor="ctr"/>
+          <a:lstStyle/>
+          <a:p>
+            <a:pPr indent="0" marL="0">
+              <a:buNone/>
+            </a:pPr>
+            <a:r>
+              <a:rPr lang="en-US" sz="1250" b="1" dirty="0">
+                <a:solidFill>
+                  <a:srgbClr val="F2EFE6"/>
+                </a:solidFill>
+                <a:latin typeface="Arial" pitchFamily="34" charset="0"/>
+                <a:ea typeface="Arial" pitchFamily="34" charset="-122"/>
+                <a:cs typeface="Arial" pitchFamily="34" charset="-120"/>
+              </a:rPr>
+              <a:t>€ 600</a:t>
+            </a:r>
+            <a:endParaRPr lang="en-US" sz="1250" dirty="0"/>
+          </a:p>
+        </p:txBody>
+      </p:sp>
+      <p:sp>
+        <p:nvSpPr>
+          <p:cNvPr id="15" name="Text 13"/>
+          <p:cNvSpPr txBox="1"/>
+          <p:nvPr/>
+        </p:nvSpPr>
+        <p:spPr>
+          <a:xfrm>
+            <a:off x="6324584" y="3136892"/>
+            <a:ext cx="2349494" cy="628648"/>
+          </a:xfrm>
+          <a:prstGeom prst="rect">
+            <a:avLst/>
+          </a:prstGeom>
+          <a:noFill/>
+          <a:ln/>
+        </p:spPr>
+        <p:txBody>
+          <a:bodyPr wrap="square" lIns="0" tIns="0" rIns="0" bIns="0" rtlCol="0" anchor="ctr"/>
+          <a:lstStyle/>
+          <a:p>
+            <a:pPr indent="0" marL="0">
+              <a:buNone/>
+            </a:pPr>
+            <a:r>
+              <a:rPr lang="en-US" sz="1250" b="1" dirty="0">
+                <a:solidFill>
+                  <a:srgbClr val="F2EFE6"/>
+                </a:solidFill>
+                <a:latin typeface="Arial" pitchFamily="34" charset="0"/>
+                <a:ea typeface="Arial" pitchFamily="34" charset="-122"/>
+                <a:cs typeface="Arial" pitchFamily="34" charset="-120"/>
+              </a:rPr>
+              <a:t>€ 2.400</a:t>
+            </a:r>
+            <a:endParaRPr lang="en-US" sz="1250" dirty="0"/>
+          </a:p>
+        </p:txBody>
+      </p:sp>
+      <p:sp>
+        <p:nvSpPr>
+          <p:cNvPr id="16" name="Text 14"/>
+          <p:cNvSpPr txBox="1"/>
+          <p:nvPr/>
+        </p:nvSpPr>
+        <p:spPr>
+          <a:xfrm>
+            <a:off x="8737578" y="3136892"/>
+            <a:ext cx="2539994" cy="628648"/>
+          </a:xfrm>
+          <a:prstGeom prst="rect">
+            <a:avLst/>
+          </a:prstGeom>
+          <a:noFill/>
+          <a:ln/>
+        </p:spPr>
+        <p:txBody>
+          <a:bodyPr wrap="square" lIns="0" tIns="0" rIns="0" bIns="0" rtlCol="0" anchor="ctr"/>
+          <a:lstStyle/>
+          <a:p>
+            <a:pPr indent="0" marL="0">
+              <a:buNone/>
+            </a:pPr>
+            <a:r>
+              <a:rPr lang="en-US" sz="1250" b="1" dirty="0">
+                <a:solidFill>
+                  <a:srgbClr val="F2EFE6"/>
+                </a:solidFill>
+                <a:latin typeface="Arial" pitchFamily="34" charset="0"/>
+                <a:ea typeface="Arial" pitchFamily="34" charset="-122"/>
+                <a:cs typeface="Arial" pitchFamily="34" charset="-120"/>
+              </a:rPr>
+              <a:t>± 9 leads</a:t>
+            </a:r>
+            <a:endParaRPr lang="en-US" sz="1250" dirty="0"/>
+          </a:p>
+        </p:txBody>
+      </p:sp>
+      <p:sp>
+        <p:nvSpPr>
+          <p:cNvPr id="17" name="Shape 15"/>
+          <p:cNvSpPr/>
+          <p:nvPr/>
+        </p:nvSpPr>
+        <p:spPr>
+          <a:xfrm>
+            <a:off x="609598" y="3765541"/>
+            <a:ext cx="10972773" cy="0"/>
+          </a:xfrm>
+          <a:prstGeom prst="line">
+            <a:avLst/>
+          </a:prstGeom>
+          <a:noFill/>
+          <a:ln w="9525">
+            <a:solidFill>
+              <a:srgbClr val="3A4152"/>
+            </a:solidFill>
+            <a:prstDash val="solid"/>
+          </a:ln>
+        </p:spPr>
+      </p:sp>
+      <p:sp>
+        <p:nvSpPr>
+          <p:cNvPr id="18" name="Text 16"/>
+          <p:cNvSpPr txBox="1"/>
+          <p:nvPr/>
+        </p:nvSpPr>
+        <p:spPr>
+          <a:xfrm>
+            <a:off x="888998" y="3765541"/>
+            <a:ext cx="2920993" cy="628648"/>
+          </a:xfrm>
+          <a:prstGeom prst="rect">
+            <a:avLst/>
+          </a:prstGeom>
+          <a:noFill/>
+          <a:ln/>
+        </p:spPr>
+        <p:txBody>
+          <a:bodyPr wrap="square" lIns="0" tIns="0" rIns="0" bIns="0" rtlCol="0" anchor="ctr"/>
+          <a:lstStyle/>
+          <a:p>
+            <a:pPr indent="0" marL="0">
+              <a:buNone/>
+            </a:pPr>
+            <a:r>
+              <a:rPr lang="en-US" sz="1250" b="1" dirty="0">
+                <a:solidFill>
+                  <a:srgbClr val="F2EFE6"/>
+                </a:solidFill>
+                <a:latin typeface="Arial" pitchFamily="34" charset="0"/>
+                <a:ea typeface="Arial" pitchFamily="34" charset="-122"/>
+                <a:cs typeface="Arial" pitchFamily="34" charset="-120"/>
+              </a:rPr>
+              <a:t>5 tot 7 beldagen</a:t>
+            </a:r>
+            <a:endParaRPr lang="en-US" sz="1250" dirty="0"/>
+          </a:p>
+        </p:txBody>
+      </p:sp>
+      <p:sp>
+        <p:nvSpPr>
+          <p:cNvPr id="19" name="Text 17"/>
+          <p:cNvSpPr txBox="1"/>
+          <p:nvPr/>
+        </p:nvSpPr>
+        <p:spPr>
+          <a:xfrm>
+            <a:off x="3886190" y="3765541"/>
+            <a:ext cx="2349494" cy="628648"/>
+          </a:xfrm>
+          <a:prstGeom prst="rect">
+            <a:avLst/>
+          </a:prstGeom>
+          <a:noFill/>
+          <a:ln/>
+        </p:spPr>
+        <p:txBody>
+          <a:bodyPr wrap="square" lIns="0" tIns="0" rIns="0" bIns="0" rtlCol="0" anchor="ctr"/>
+          <a:lstStyle/>
+          <a:p>
+            <a:pPr indent="0" marL="0">
+              <a:buNone/>
+            </a:pPr>
+            <a:r>
+              <a:rPr lang="en-US" sz="1250" b="1" dirty="0">
+                <a:solidFill>
+                  <a:srgbClr val="F2EFE6"/>
+                </a:solidFill>
+                <a:latin typeface="Arial" pitchFamily="34" charset="0"/>
+                <a:ea typeface="Arial" pitchFamily="34" charset="-122"/>
+                <a:cs typeface="Arial" pitchFamily="34" charset="-120"/>
+              </a:rPr>
+              <a:t>€ 550</a:t>
+            </a:r>
+            <a:endParaRPr lang="en-US" sz="1250" dirty="0"/>
+          </a:p>
+        </p:txBody>
+      </p:sp>
+      <p:sp>
+        <p:nvSpPr>
+          <p:cNvPr id="20" name="Text 18"/>
+          <p:cNvSpPr txBox="1"/>
+          <p:nvPr/>
+        </p:nvSpPr>
+        <p:spPr>
+          <a:xfrm>
+            <a:off x="6324584" y="3765541"/>
+            <a:ext cx="2349494" cy="628648"/>
+          </a:xfrm>
+          <a:prstGeom prst="rect">
+            <a:avLst/>
+          </a:prstGeom>
+          <a:noFill/>
+          <a:ln/>
+        </p:spPr>
+        <p:txBody>
+          <a:bodyPr wrap="square" lIns="0" tIns="0" rIns="0" bIns="0" rtlCol="0" anchor="ctr"/>
+          <a:lstStyle/>
+          <a:p>
+            <a:pPr indent="0" marL="0">
+              <a:buNone/>
+            </a:pPr>
+            <a:r>
+              <a:rPr lang="en-US" sz="1250" b="1" dirty="0">
+                <a:solidFill>
+                  <a:srgbClr val="F2EFE6"/>
+                </a:solidFill>
+                <a:latin typeface="Arial" pitchFamily="34" charset="0"/>
+                <a:ea typeface="Arial" pitchFamily="34" charset="-122"/>
+                <a:cs typeface="Arial" pitchFamily="34" charset="-120"/>
+              </a:rPr>
+              <a:t>€ 2.750 tot € 3.850</a:t>
+            </a:r>
+            <a:endParaRPr lang="en-US" sz="1250" dirty="0"/>
+          </a:p>
+        </p:txBody>
+      </p:sp>
+      <p:sp>
+        <p:nvSpPr>
+          <p:cNvPr id="21" name="Text 19"/>
+          <p:cNvSpPr txBox="1"/>
+          <p:nvPr/>
+        </p:nvSpPr>
+        <p:spPr>
+          <a:xfrm>
+            <a:off x="8737578" y="3765541"/>
+            <a:ext cx="2539994" cy="628648"/>
+          </a:xfrm>
+          <a:prstGeom prst="rect">
+            <a:avLst/>
+          </a:prstGeom>
+          <a:noFill/>
+          <a:ln/>
+        </p:spPr>
+        <p:txBody>
+          <a:bodyPr wrap="square" lIns="0" tIns="0" rIns="0" bIns="0" rtlCol="0" anchor="ctr"/>
+          <a:lstStyle/>
+          <a:p>
+            <a:pPr indent="0" marL="0">
+              <a:buNone/>
+            </a:pPr>
+            <a:r>
+              <a:rPr lang="en-US" sz="1250" b="1" dirty="0">
+                <a:solidFill>
+                  <a:srgbClr val="F2EFE6"/>
+                </a:solidFill>
+                <a:latin typeface="Arial" pitchFamily="34" charset="0"/>
+                <a:ea typeface="Arial" pitchFamily="34" charset="-122"/>
+                <a:cs typeface="Arial" pitchFamily="34" charset="-120"/>
+              </a:rPr>
+              <a:t>± 12 tot 16 leads</a:t>
+            </a:r>
+            <a:endParaRPr lang="en-US" sz="1250" dirty="0"/>
+          </a:p>
+        </p:txBody>
+      </p:sp>
+      <p:sp>
+        <p:nvSpPr>
+          <p:cNvPr id="22" name="Shape 20"/>
+          <p:cNvSpPr/>
+          <p:nvPr/>
+        </p:nvSpPr>
+        <p:spPr>
+          <a:xfrm>
+            <a:off x="615948" y="4394189"/>
+            <a:ext cx="10960073" cy="628648"/>
+          </a:xfrm>
+          <a:prstGeom prst="rect">
+            <a:avLst/>
+          </a:prstGeom>
+          <a:solidFill>
+            <a:srgbClr val="38B6FF">
+              <a:alpha val="11000"/>
+            </a:srgbClr>
+          </a:solidFill>
+          <a:ln/>
+        </p:spPr>
+      </p:sp>
+      <p:sp>
+        <p:nvSpPr>
+          <p:cNvPr id="23" name="Shape 21"/>
+          <p:cNvSpPr/>
+          <p:nvPr/>
+        </p:nvSpPr>
+        <p:spPr>
+          <a:xfrm>
+            <a:off x="609598" y="4394189"/>
+            <a:ext cx="10972773" cy="0"/>
+          </a:xfrm>
+          <a:prstGeom prst="line">
+            <a:avLst/>
+          </a:prstGeom>
+          <a:noFill/>
+          <a:ln w="9525">
+            <a:solidFill>
+              <a:srgbClr val="3A4152"/>
+            </a:solidFill>
+            <a:prstDash val="solid"/>
+          </a:ln>
+        </p:spPr>
+      </p:sp>
+      <p:sp>
+        <p:nvSpPr>
+          <p:cNvPr id="24" name="Text 22"/>
+          <p:cNvSpPr txBox="1"/>
+          <p:nvPr/>
+        </p:nvSpPr>
+        <p:spPr>
+          <a:xfrm>
+            <a:off x="888998" y="4394189"/>
+            <a:ext cx="2920993" cy="628648"/>
+          </a:xfrm>
+          <a:prstGeom prst="rect">
+            <a:avLst/>
+          </a:prstGeom>
+          <a:noFill/>
+          <a:ln/>
+        </p:spPr>
+        <p:txBody>
+          <a:bodyPr wrap="square" lIns="0" tIns="0" rIns="0" bIns="0" rtlCol="0" anchor="ctr"/>
+          <a:lstStyle/>
+          <a:p>
+            <a:pPr indent="0" marL="0">
+              <a:buNone/>
+            </a:pPr>
+            <a:r>
+              <a:rPr lang="en-US" sz="1250" b="1" dirty="0">
+                <a:solidFill>
+                  <a:srgbClr val="F2EFE6"/>
+                </a:solidFill>
+                <a:latin typeface="Arial" pitchFamily="34" charset="0"/>
+                <a:ea typeface="Arial" pitchFamily="34" charset="-122"/>
+                <a:cs typeface="Arial" pitchFamily="34" charset="-120"/>
+              </a:rPr>
+              <a:t>8 beldagen of meer</a:t>
+            </a:r>
+            <a:pPr indent="0" marL="0">
+              <a:buNone/>
+            </a:pPr>
+            <a:r>
+              <a:rPr lang="en-US" sz="1000" i="1" dirty="0">
+                <a:solidFill>
+                  <a:srgbClr val="38B6FF"/>
+                </a:solidFill>
+                <a:latin typeface="Georgia" pitchFamily="34" charset="0"/>
+                <a:ea typeface="Georgia" pitchFamily="34" charset="-122"/>
+                <a:cs typeface="Georgia" pitchFamily="34" charset="-120"/>
+              </a:rPr>
+              <a:t>   ons advies</a:t>
+            </a:r>
+            <a:endParaRPr lang="en-US" sz="1250" dirty="0"/>
+          </a:p>
+        </p:txBody>
+      </p:sp>
+      <p:sp>
+        <p:nvSpPr>
+          <p:cNvPr id="25" name="Text 23"/>
+          <p:cNvSpPr txBox="1"/>
+          <p:nvPr/>
+        </p:nvSpPr>
+        <p:spPr>
+          <a:xfrm>
+            <a:off x="3886190" y="4394189"/>
+            <a:ext cx="2349494" cy="628648"/>
+          </a:xfrm>
+          <a:prstGeom prst="rect">
+            <a:avLst/>
+          </a:prstGeom>
+          <a:noFill/>
+          <a:ln/>
+        </p:spPr>
+        <p:txBody>
+          <a:bodyPr wrap="square" lIns="0" tIns="0" rIns="0" bIns="0" rtlCol="0" anchor="ctr"/>
+          <a:lstStyle/>
+          <a:p>
+            <a:pPr indent="0" marL="0">
+              <a:buNone/>
+            </a:pPr>
+            <a:r>
+              <a:rPr lang="en-US" sz="1250" b="1" dirty="0">
+                <a:solidFill>
+                  <a:srgbClr val="F2EFE6"/>
+                </a:solidFill>
+                <a:latin typeface="Arial" pitchFamily="34" charset="0"/>
+                <a:ea typeface="Arial" pitchFamily="34" charset="-122"/>
+                <a:cs typeface="Arial" pitchFamily="34" charset="-120"/>
+              </a:rPr>
+              <a:t>€ 500</a:t>
+            </a:r>
+            <a:endParaRPr lang="en-US" sz="1250" dirty="0"/>
+          </a:p>
+        </p:txBody>
+      </p:sp>
+      <p:sp>
+        <p:nvSpPr>
+          <p:cNvPr id="26" name="Text 24"/>
+          <p:cNvSpPr txBox="1"/>
+          <p:nvPr/>
+        </p:nvSpPr>
+        <p:spPr>
+          <a:xfrm>
+            <a:off x="6324584" y="4394189"/>
+            <a:ext cx="2349494" cy="628648"/>
+          </a:xfrm>
+          <a:prstGeom prst="rect">
+            <a:avLst/>
+          </a:prstGeom>
+          <a:noFill/>
+          <a:ln/>
+        </p:spPr>
+        <p:txBody>
+          <a:bodyPr wrap="square" lIns="0" tIns="0" rIns="0" bIns="0" rtlCol="0" anchor="ctr"/>
+          <a:lstStyle/>
+          <a:p>
+            <a:pPr indent="0" marL="0">
+              <a:buNone/>
+            </a:pPr>
+            <a:r>
+              <a:rPr lang="en-US" sz="1250" b="1" dirty="0">
+                <a:solidFill>
+                  <a:srgbClr val="F2EFE6"/>
+                </a:solidFill>
+                <a:latin typeface="Arial" pitchFamily="34" charset="0"/>
+                <a:ea typeface="Arial" pitchFamily="34" charset="-122"/>
+                <a:cs typeface="Arial" pitchFamily="34" charset="-120"/>
+              </a:rPr>
+              <a:t>vanaf € 4.000</a:t>
+            </a:r>
+            <a:endParaRPr lang="en-US" sz="1250" dirty="0"/>
+          </a:p>
+        </p:txBody>
+      </p:sp>
+      <p:sp>
+        <p:nvSpPr>
+          <p:cNvPr id="27" name="Text 25"/>
+          <p:cNvSpPr txBox="1"/>
+          <p:nvPr/>
+        </p:nvSpPr>
+        <p:spPr>
+          <a:xfrm>
+            <a:off x="8737578" y="4394189"/>
+            <a:ext cx="2539994" cy="628648"/>
+          </a:xfrm>
+          <a:prstGeom prst="rect">
+            <a:avLst/>
+          </a:prstGeom>
+          <a:noFill/>
+          <a:ln/>
+        </p:spPr>
+        <p:txBody>
+          <a:bodyPr wrap="square" lIns="0" tIns="0" rIns="0" bIns="0" rtlCol="0" anchor="ctr"/>
+          <a:lstStyle/>
+          <a:p>
+            <a:pPr indent="0" marL="0">
+              <a:buNone/>
+            </a:pPr>
+            <a:r>
+              <a:rPr lang="en-US" sz="1250" b="1" dirty="0">
+                <a:solidFill>
+                  <a:srgbClr val="F2EFE6"/>
+                </a:solidFill>
+                <a:latin typeface="Arial" pitchFamily="34" charset="0"/>
+                <a:ea typeface="Arial" pitchFamily="34" charset="-122"/>
+                <a:cs typeface="Arial" pitchFamily="34" charset="-120"/>
+              </a:rPr>
+              <a:t>vanaf ± 19 leads</a:t>
+            </a:r>
+            <a:endParaRPr lang="en-US" sz="1250" dirty="0"/>
+          </a:p>
+        </p:txBody>
+      </p:sp>
+      <p:sp>
+        <p:nvSpPr>
+          <p:cNvPr id="28" name="Shape 26"/>
+          <p:cNvSpPr/>
+          <p:nvPr/>
+        </p:nvSpPr>
+        <p:spPr>
+          <a:xfrm>
+            <a:off x="609598" y="5854685"/>
+            <a:ext cx="76200" cy="76200"/>
+          </a:xfrm>
+          <a:prstGeom prst="ellipse">
+            <a:avLst/>
+          </a:prstGeom>
+          <a:solidFill>
+            <a:srgbClr val="38B6FF"/>
+          </a:solidFill>
+          <a:ln/>
+        </p:spPr>
+      </p:sp>
+      <p:sp>
+        <p:nvSpPr>
+          <p:cNvPr id="29" name="Text 27"/>
+          <p:cNvSpPr txBox="1"/>
+          <p:nvPr/>
+        </p:nvSpPr>
+        <p:spPr>
+          <a:xfrm>
+            <a:off x="800098" y="5651486"/>
+            <a:ext cx="9905975" cy="482599"/>
+          </a:xfrm>
+          <a:prstGeom prst="rect">
+            <a:avLst/>
+          </a:prstGeom>
+          <a:noFill/>
+          <a:ln/>
+        </p:spPr>
+        <p:txBody>
+          <a:bodyPr wrap="square" lIns="0" tIns="0" rIns="0" bIns="0" rtlCol="0" anchor="ctr"/>
+          <a:lstStyle/>
+          <a:p>
+            <a:pPr indent="0" marL="0">
+              <a:buNone/>
+            </a:pPr>
+            <a:r>
+              <a:rPr lang="en-US" sz="1200" b="1" dirty="0">
+                <a:solidFill>
+                  <a:srgbClr val="F2EFE6"/>
+                </a:solidFill>
+                <a:latin typeface="Arial" pitchFamily="34" charset="0"/>
+                <a:ea typeface="Arial" pitchFamily="34" charset="-122"/>
+                <a:cs typeface="Arial" pitchFamily="34" charset="-120"/>
+              </a:rPr>
+              <a:t>Een beldag is minimaal 100 gesprekspogingen. Bij 23,2 leads per duizend pogingen, het cijfer over 2.629 gesprekken voor Moyee, komt dat neer op 2,3 leads per beldag. Minimaal vier beldagen per periode, prijzen excl. btw.</a:t>
+            </a:r>
+            <a:endParaRPr lang="en-US" sz="1200" dirty="0"/>
+          </a:p>
+        </p:txBody>
+      </p:sp>
+    </p:spTree>
+  </p:cSld>
+  <p:clrMapOvr>
+    <a:masterClrMapping/>
+  </p:clrMapOvr>
+</p:sld>
+</file>
+
+<file path=ppt/slides/slide11.xml><?xml version="1.0" encoding="utf-8"?>
+<p:sld xmlns:a="http://schemas.openxmlformats.org/drawingml/2006/main" xmlns:r="http://schemas.openxmlformats.org/officeDocument/2006/relationships" xmlns:p="http://schemas.openxmlformats.org/presentationml/2006/main">
+  <p:cSld name="Slide 11">
     <p:bg>
       <p:bgPr>
         <a:solidFill>
@@ -3104,7 +4283,7 @@
                 <a:ea typeface="Arial" pitchFamily="34" charset="-122"/>
                 <a:cs typeface="Arial" pitchFamily="34" charset="-120"/>
               </a:rPr>
-              <a:t>10 / 13</a:t>
+              <a:t>11 / 14</a:t>
             </a:r>
             <a:endParaRPr lang="en-US" sz="750" dirty="0"/>
           </a:p>
@@ -3185,7 +4364,7 @@
                 <a:ea typeface="Arial" pitchFamily="34" charset="-122"/>
                 <a:cs typeface="Arial" pitchFamily="34" charset="-120"/>
               </a:rPr>
-              <a:t>Meer beldagen, en toch een lagere prijs </a:t>
+              <a:t>Bijna twee keer zoveel gesprekken, voor </a:t>
             </a:r>
             <a:pPr algn="l" indent="0" marL="0">
               <a:lnSpc>
@@ -3202,7 +4381,7 @@
                 <a:ea typeface="Georgia" pitchFamily="34" charset="-122"/>
                 <a:cs typeface="Georgia" pitchFamily="34" charset="-120"/>
               </a:rPr>
-              <a:t>per lead</a:t>
+              <a:t>dezelfde prijs</a:t>
             </a:r>
             <a:pPr algn="l" indent="0" marL="0">
               <a:lnSpc>
@@ -3219,7 +4398,7 @@
                 <a:ea typeface="Arial" pitchFamily="34" charset="-122"/>
                 <a:cs typeface="Arial" pitchFamily="34" charset="-120"/>
               </a:rPr>
-              <a:t>.</a:t>
+              <a:t> per lead.</a:t>
             </a:r>
             <a:endParaRPr lang="en-US" sz="3200" dirty="0"/>
           </a:p>
@@ -3233,12 +4412,12 @@
         </p:nvSpPr>
         <p:spPr>
           <a:xfrm>
-            <a:off x="609598" y="2539994"/>
-            <a:ext cx="5384787" cy="2920993"/>
+            <a:off x="609598" y="2489194"/>
+            <a:ext cx="5384787" cy="2768593"/>
           </a:xfrm>
           <a:prstGeom prst="roundRect">
             <a:avLst>
-              <a:gd name="adj" fmla="val 3478"/>
+              <a:gd name="adj" fmla="val 3670"/>
             </a:avLst>
           </a:prstGeom>
           <a:solidFill>
@@ -3255,7 +4434,7 @@
         </p:nvSpPr>
         <p:spPr>
           <a:xfrm>
-            <a:off x="939798" y="2819393"/>
+            <a:off x="939798" y="2768593"/>
             <a:ext cx="4724388" cy="190500"/>
           </a:xfrm>
           <a:prstGeom prst="rect">
@@ -3280,7 +4459,7 @@
                 <a:ea typeface="Arial" pitchFamily="34" charset="-122"/>
                 <a:cs typeface="Arial" pitchFamily="34" charset="-120"/>
               </a:rPr>
-              <a:t>NU · VIER BELDAGEN</a:t>
+              <a:t>NU · ± 4,1 BELDAGEN</a:t>
             </a:r>
             <a:endParaRPr lang="en-US" sz="800" dirty="0"/>
           </a:p>
@@ -3294,7 +4473,7 @@
         </p:nvSpPr>
         <p:spPr>
           <a:xfrm>
-            <a:off x="939798" y="3035292"/>
+            <a:off x="939798" y="2984493"/>
             <a:ext cx="4724388" cy="330199"/>
           </a:xfrm>
           <a:prstGeom prst="rect">
@@ -3333,8 +4512,8 @@
         </p:nvSpPr>
         <p:spPr>
           <a:xfrm>
-            <a:off x="939798" y="3479791"/>
-            <a:ext cx="3479791" cy="469899"/>
+            <a:off x="939798" y="3378192"/>
+            <a:ext cx="3479791" cy="419099"/>
           </a:xfrm>
           <a:prstGeom prst="rect">
             <a:avLst/>
@@ -3372,8 +4551,8 @@
         </p:nvSpPr>
         <p:spPr>
           <a:xfrm>
-            <a:off x="4419589" y="3479791"/>
-            <a:ext cx="1244597" cy="469899"/>
+            <a:off x="4419589" y="3378192"/>
+            <a:ext cx="1244597" cy="419099"/>
           </a:xfrm>
           <a:prstGeom prst="rect">
             <a:avLst/>
@@ -3397,7 +4576,7 @@
                 <a:ea typeface="Arial" pitchFamily="34" charset="-122"/>
                 <a:cs typeface="Arial" pitchFamily="34" charset="-120"/>
               </a:rPr>
-              <a:t>± € 2.400</a:t>
+              <a:t>± € 2.040</a:t>
             </a:r>
             <a:endParaRPr lang="en-US" sz="1350" dirty="0"/>
           </a:p>
@@ -3411,7 +4590,7 @@
         </p:nvSpPr>
         <p:spPr>
           <a:xfrm>
-            <a:off x="939798" y="3949690"/>
+            <a:off x="939798" y="3797291"/>
             <a:ext cx="4724388" cy="0"/>
           </a:xfrm>
           <a:prstGeom prst="line">
@@ -3434,8 +4613,8 @@
         </p:nvSpPr>
         <p:spPr>
           <a:xfrm>
-            <a:off x="939798" y="3949690"/>
-            <a:ext cx="3479791" cy="469899"/>
+            <a:off x="939798" y="3797291"/>
+            <a:ext cx="3479791" cy="419099"/>
           </a:xfrm>
           <a:prstGeom prst="rect">
             <a:avLst/>
@@ -3459,7 +4638,7 @@
                 <a:ea typeface="Arial" pitchFamily="34" charset="-122"/>
                 <a:cs typeface="Arial" pitchFamily="34" charset="-120"/>
               </a:rPr>
-              <a:t>Waarvan tastingfees</a:t>
+              <a:t>Gesprekspogingen</a:t>
             </a:r>
             <a:endParaRPr lang="en-US" sz="1100" dirty="0"/>
           </a:p>
@@ -3473,8 +4652,8 @@
         </p:nvSpPr>
         <p:spPr>
           <a:xfrm>
-            <a:off x="4419589" y="3949690"/>
-            <a:ext cx="1244597" cy="469899"/>
+            <a:off x="4419589" y="3797291"/>
+            <a:ext cx="1244597" cy="419099"/>
           </a:xfrm>
           <a:prstGeom prst="rect">
             <a:avLst/>
@@ -3498,7 +4677,7 @@
                 <a:ea typeface="Arial" pitchFamily="34" charset="-122"/>
                 <a:cs typeface="Arial" pitchFamily="34" charset="-120"/>
               </a:rPr>
-              <a:t>± € 900</a:t>
+              <a:t>± 414</a:t>
             </a:r>
             <a:endParaRPr lang="en-US" sz="1350" dirty="0"/>
           </a:p>
@@ -3512,7 +4691,7 @@
         </p:nvSpPr>
         <p:spPr>
           <a:xfrm>
-            <a:off x="939798" y="4419589"/>
+            <a:off x="939798" y="4216389"/>
             <a:ext cx="4724388" cy="0"/>
           </a:xfrm>
           <a:prstGeom prst="line">
@@ -3535,8 +4714,8 @@
         </p:nvSpPr>
         <p:spPr>
           <a:xfrm>
-            <a:off x="939798" y="4419589"/>
-            <a:ext cx="3479791" cy="469899"/>
+            <a:off x="939798" y="4216389"/>
+            <a:ext cx="3479791" cy="419099"/>
           </a:xfrm>
           <a:prstGeom prst="rect">
             <a:avLst/>
@@ -3574,8 +4753,8 @@
         </p:nvSpPr>
         <p:spPr>
           <a:xfrm>
-            <a:off x="4419589" y="4419589"/>
-            <a:ext cx="1244597" cy="469899"/>
+            <a:off x="4419589" y="4216389"/>
+            <a:ext cx="1244597" cy="419099"/>
           </a:xfrm>
           <a:prstGeom prst="rect">
             <a:avLst/>
@@ -3613,7 +4792,7 @@
         </p:nvSpPr>
         <p:spPr>
           <a:xfrm>
-            <a:off x="939798" y="4889488"/>
+            <a:off x="939798" y="4635488"/>
             <a:ext cx="4724388" cy="0"/>
           </a:xfrm>
           <a:prstGeom prst="line">
@@ -3636,8 +4815,8 @@
         </p:nvSpPr>
         <p:spPr>
           <a:xfrm>
-            <a:off x="939798" y="4889488"/>
-            <a:ext cx="3479791" cy="469899"/>
+            <a:off x="939798" y="4635488"/>
+            <a:ext cx="3479791" cy="419099"/>
           </a:xfrm>
           <a:prstGeom prst="rect">
             <a:avLst/>
@@ -3675,8 +4854,8 @@
         </p:nvSpPr>
         <p:spPr>
           <a:xfrm>
-            <a:off x="4419589" y="4889488"/>
-            <a:ext cx="1244597" cy="469899"/>
+            <a:off x="4419589" y="4635488"/>
+            <a:ext cx="1244597" cy="419099"/>
           </a:xfrm>
           <a:prstGeom prst="rect">
             <a:avLst/>
@@ -3700,7 +4879,7 @@
                 <a:ea typeface="Arial" pitchFamily="34" charset="-122"/>
                 <a:cs typeface="Arial" pitchFamily="34" charset="-120"/>
               </a:rPr>
-              <a:t>± € 250</a:t>
+              <a:t>± € 212</a:t>
             </a:r>
             <a:endParaRPr lang="en-US" sz="1350" dirty="0"/>
           </a:p>
@@ -3714,12 +4893,12 @@
         </p:nvSpPr>
         <p:spPr>
           <a:xfrm>
-            <a:off x="6197585" y="2539994"/>
-            <a:ext cx="5384787" cy="2920993"/>
+            <a:off x="6197585" y="2489194"/>
+            <a:ext cx="5384787" cy="2768593"/>
           </a:xfrm>
           <a:prstGeom prst="roundRect">
             <a:avLst>
-              <a:gd name="adj" fmla="val 3478"/>
+              <a:gd name="adj" fmla="val 3670"/>
             </a:avLst>
           </a:prstGeom>
           <a:solidFill>
@@ -3736,7 +4915,7 @@
         </p:nvSpPr>
         <p:spPr>
           <a:xfrm>
-            <a:off x="6527784" y="2819393"/>
+            <a:off x="6527784" y="2768593"/>
             <a:ext cx="4724388" cy="190500"/>
           </a:xfrm>
           <a:prstGeom prst="rect">
@@ -3775,7 +4954,7 @@
         </p:nvSpPr>
         <p:spPr>
           <a:xfrm>
-            <a:off x="6527784" y="3035292"/>
+            <a:off x="6527784" y="2984493"/>
             <a:ext cx="4724388" cy="330199"/>
           </a:xfrm>
           <a:prstGeom prst="rect">
@@ -3814,8 +4993,8 @@
         </p:nvSpPr>
         <p:spPr>
           <a:xfrm>
-            <a:off x="6527784" y="3479791"/>
-            <a:ext cx="3479791" cy="469899"/>
+            <a:off x="6527784" y="3378192"/>
+            <a:ext cx="3479791" cy="419099"/>
           </a:xfrm>
           <a:prstGeom prst="rect">
             <a:avLst/>
@@ -3853,8 +5032,8 @@
         </p:nvSpPr>
         <p:spPr>
           <a:xfrm>
-            <a:off x="10007575" y="3479791"/>
-            <a:ext cx="1244597" cy="469899"/>
+            <a:off x="10007575" y="3378192"/>
+            <a:ext cx="1244597" cy="419099"/>
           </a:xfrm>
           <a:prstGeom prst="rect">
             <a:avLst/>
@@ -3892,7 +5071,7 @@
         </p:nvSpPr>
         <p:spPr>
           <a:xfrm>
-            <a:off x="6527784" y="3949690"/>
+            <a:off x="6527784" y="3797291"/>
             <a:ext cx="4724388" cy="0"/>
           </a:xfrm>
           <a:prstGeom prst="line">
@@ -3915,8 +5094,8 @@
         </p:nvSpPr>
         <p:spPr>
           <a:xfrm>
-            <a:off x="6527784" y="3949690"/>
-            <a:ext cx="3479791" cy="469899"/>
+            <a:off x="6527784" y="3797291"/>
+            <a:ext cx="3479791" cy="419099"/>
           </a:xfrm>
           <a:prstGeom prst="rect">
             <a:avLst/>
@@ -3940,7 +5119,7 @@
                 <a:ea typeface="Arial" pitchFamily="34" charset="-122"/>
                 <a:cs typeface="Arial" pitchFamily="34" charset="-120"/>
               </a:rPr>
-              <a:t>Waarvan tastingfees</a:t>
+              <a:t>Gesprekspogingen</a:t>
             </a:r>
             <a:endParaRPr lang="en-US" sz="1100" dirty="0"/>
           </a:p>
@@ -3954,8 +5133,8 @@
         </p:nvSpPr>
         <p:spPr>
           <a:xfrm>
-            <a:off x="10007575" y="3949690"/>
-            <a:ext cx="1244597" cy="469899"/>
+            <a:off x="10007575" y="3797291"/>
+            <a:ext cx="1244597" cy="419099"/>
           </a:xfrm>
           <a:prstGeom prst="rect">
             <a:avLst/>
@@ -3979,7 +5158,7 @@
                 <a:ea typeface="Arial" pitchFamily="34" charset="-122"/>
                 <a:cs typeface="Arial" pitchFamily="34" charset="-120"/>
               </a:rPr>
-              <a:t>€ 0</a:t>
+              <a:t>800</a:t>
             </a:r>
             <a:endParaRPr lang="en-US" sz="1350" dirty="0"/>
           </a:p>
@@ -3993,7 +5172,7 @@
         </p:nvSpPr>
         <p:spPr>
           <a:xfrm>
-            <a:off x="6527784" y="4419589"/>
+            <a:off x="6527784" y="4216389"/>
             <a:ext cx="4724388" cy="0"/>
           </a:xfrm>
           <a:prstGeom prst="line">
@@ -4016,8 +5195,8 @@
         </p:nvSpPr>
         <p:spPr>
           <a:xfrm>
-            <a:off x="6527784" y="4419589"/>
-            <a:ext cx="3479791" cy="469899"/>
+            <a:off x="6527784" y="4216389"/>
+            <a:ext cx="3479791" cy="419099"/>
           </a:xfrm>
           <a:prstGeom prst="rect">
             <a:avLst/>
@@ -4055,8 +5234,8 @@
         </p:nvSpPr>
         <p:spPr>
           <a:xfrm>
-            <a:off x="10007575" y="4419589"/>
-            <a:ext cx="1244597" cy="469899"/>
+            <a:off x="10007575" y="4216389"/>
+            <a:ext cx="1244597" cy="419099"/>
           </a:xfrm>
           <a:prstGeom prst="rect">
             <a:avLst/>
@@ -4094,7 +5273,7 @@
         </p:nvSpPr>
         <p:spPr>
           <a:xfrm>
-            <a:off x="6527784" y="4889488"/>
+            <a:off x="6527784" y="4635488"/>
             <a:ext cx="4724388" cy="0"/>
           </a:xfrm>
           <a:prstGeom prst="line">
@@ -4117,8 +5296,8 @@
         </p:nvSpPr>
         <p:spPr>
           <a:xfrm>
-            <a:off x="6527784" y="4889488"/>
-            <a:ext cx="3479791" cy="469899"/>
+            <a:off x="6527784" y="4635488"/>
+            <a:ext cx="3479791" cy="419099"/>
           </a:xfrm>
           <a:prstGeom prst="rect">
             <a:avLst/>
@@ -4156,8 +5335,8 @@
         </p:nvSpPr>
         <p:spPr>
           <a:xfrm>
-            <a:off x="10007575" y="4889488"/>
-            <a:ext cx="1244597" cy="469899"/>
+            <a:off x="10007575" y="4635488"/>
+            <a:ext cx="1244597" cy="419099"/>
           </a:xfrm>
           <a:prstGeom prst="rect">
             <a:avLst/>
@@ -4181,7 +5360,7 @@
                 <a:ea typeface="Arial" pitchFamily="34" charset="-122"/>
                 <a:cs typeface="Arial" pitchFamily="34" charset="-120"/>
               </a:rPr>
-              <a:t>€ 208</a:t>
+              <a:t>€ 215</a:t>
             </a:r>
             <a:endParaRPr lang="en-US" sz="1350" dirty="0"/>
           </a:p>
@@ -4240,7 +5419,7 @@
                 <a:ea typeface="Arial" pitchFamily="34" charset="-122"/>
                 <a:cs typeface="Arial" pitchFamily="34" charset="-120"/>
               </a:rPr>
-              <a:t>Bij vier beldagen betalen jullie ongeveer hetzelfde als nu, vanaf vijf beldagen zakt de prijs per lead.</a:t>
+              <a:t>Acht beldagen is 93 procent meer gesprekken dan we nu per periode voeren, tegen vrijwel dezelfde prijs per lead. En jullie weten vooraf wat een periode kost, in plaats van achteraf.</a:t>
             </a:r>
             <a:endParaRPr lang="en-US" sz="1200" dirty="0"/>
           </a:p>
@@ -4254,9 +5433,9 @@
 </p:sld>
 </file>
 
-<file path=ppt/slides/slide11.xml><?xml version="1.0" encoding="utf-8"?>
+<file path=ppt/slides/slide12.xml><?xml version="1.0" encoding="utf-8"?>
 <p:sld xmlns:a="http://schemas.openxmlformats.org/drawingml/2006/main" xmlns:r="http://schemas.openxmlformats.org/officeDocument/2006/relationships" xmlns:p="http://schemas.openxmlformats.org/presentationml/2006/main">
-  <p:cSld name="Slide 11">
+  <p:cSld name="Slide 12">
     <p:bg>
       <p:bgPr>
         <a:solidFill>
@@ -4403,7 +5582,7 @@
                 <a:ea typeface="Arial" pitchFamily="34" charset="-122"/>
                 <a:cs typeface="Arial" pitchFamily="34" charset="-120"/>
               </a:rPr>
-              <a:t>11 / 13</a:t>
+              <a:t>12 / 14</a:t>
             </a:r>
             <a:endParaRPr lang="en-US" sz="750" dirty="0"/>
           </a:p>
@@ -5279,9 +6458,9 @@
 </p:sld>
 </file>
 
-<file path=ppt/slides/slide12.xml><?xml version="1.0" encoding="utf-8"?>
+<file path=ppt/slides/slide13.xml><?xml version="1.0" encoding="utf-8"?>
 <p:sld xmlns:a="http://schemas.openxmlformats.org/drawingml/2006/main" xmlns:r="http://schemas.openxmlformats.org/officeDocument/2006/relationships" xmlns:p="http://schemas.openxmlformats.org/presentationml/2006/main">
-  <p:cSld name="Slide 12">
+  <p:cSld name="Slide 13">
     <p:bg>
       <p:bgPr>
         <a:solidFill>
@@ -5428,7 +6607,7 @@
                 <a:ea typeface="Arial" pitchFamily="34" charset="-122"/>
                 <a:cs typeface="Arial" pitchFamily="34" charset="-120"/>
               </a:rPr>
-              <a:t>12 / 13</a:t>
+              <a:t>13 / 14</a:t>
             </a:r>
             <a:endParaRPr lang="en-US" sz="750" dirty="0"/>
           </a:p>
@@ -6711,9 +7890,9 @@
 </p:sld>
 </file>
 
-<file path=ppt/slides/slide13.xml><?xml version="1.0" encoding="utf-8"?>
+<file path=ppt/slides/slide14.xml><?xml version="1.0" encoding="utf-8"?>
 <p:sld xmlns:a="http://schemas.openxmlformats.org/drawingml/2006/main" xmlns:r="http://schemas.openxmlformats.org/officeDocument/2006/relationships" xmlns:p="http://schemas.openxmlformats.org/presentationml/2006/main">
-  <p:cSld name="Slide 13">
+  <p:cSld name="Slide 14">
     <p:bg>
       <p:bgPr>
         <a:solidFill>
@@ -6860,7 +8039,7 @@
                 <a:ea typeface="Arial" pitchFamily="34" charset="-122"/>
                 <a:cs typeface="Arial" pitchFamily="34" charset="-120"/>
               </a:rPr>
-              <a:t>13 / 13</a:t>
+              <a:t>14 / 14</a:t>
             </a:r>
             <a:endParaRPr lang="en-US" sz="750" dirty="0"/>
           </a:p>
@@ -7786,7 +8965,7 @@
                 <a:ea typeface="Arial" pitchFamily="34" charset="-122"/>
                 <a:cs typeface="Arial" pitchFamily="34" charset="-120"/>
               </a:rPr>
-              <a:t>2 / 13</a:t>
+              <a:t>2 / 14</a:t>
             </a:r>
             <a:endParaRPr lang="en-US" sz="750" dirty="0"/>
           </a:p>
@@ -7966,7 +9145,7 @@
                 <a:ea typeface="Arial" pitchFamily="34" charset="-122"/>
                 <a:cs typeface="Arial" pitchFamily="34" charset="-120"/>
               </a:rPr>
-              <a:t>Voor Moyee bellen we sinds mei. In die tijd hebben we geleerd welke bedrijven openstaan voor een gesprek, welke ingang werkt en wanneer de juiste persoon bereikbaar is. Die kennis zit nu in de bellijst en in het script.</a:t>
+              <a:t>Voor Moyee bellen we sinds eind maart. In die tijd hebben we geleerd welke bedrijven openstaan voor een gesprek, welke ingang werkt en wanneer de juiste persoon bereikbaar is. Die kennis zit nu in de bellijst en in het script.</a:t>
             </a:r>
             <a:endParaRPr lang="en-US" sz="1350" dirty="0"/>
           </a:p>
@@ -8169,7 +9348,7 @@
                 <a:ea typeface="Arial" pitchFamily="34" charset="-122"/>
                 <a:cs typeface="Arial" pitchFamily="34" charset="-120"/>
               </a:rPr>
-              <a:t>19</a:t>
+              <a:t>25</a:t>
             </a:r>
             <a:endParaRPr lang="en-US" sz="3400" dirty="0"/>
           </a:p>
@@ -8250,7 +9429,7 @@
                 <a:ea typeface="Arial" pitchFamily="34" charset="-122"/>
                 <a:cs typeface="Arial" pitchFamily="34" charset="-120"/>
               </a:rPr>
-              <a:t>Mei tot en met september 2026, elke week gebeld en elke week teruggekoppeld.</a:t>
+              <a:t>Van eind maart tot en met september 2026, elke week gebeld en elke week teruggekoppeld.</a:t>
             </a:r>
             <a:endParaRPr lang="en-US" sz="950" dirty="0"/>
           </a:p>
@@ -8413,7 +9592,7 @@
                 <a:ea typeface="Arial" pitchFamily="34" charset="-122"/>
                 <a:cs typeface="Arial" pitchFamily="34" charset="-120"/>
               </a:rPr>
-              <a:t>3 / 13</a:t>
+              <a:t>3 / 14</a:t>
             </a:r>
             <a:endParaRPr lang="en-US" sz="750" dirty="0"/>
           </a:p>
@@ -9299,7 +10478,7 @@
                 <a:ea typeface="Arial" pitchFamily="34" charset="-122"/>
                 <a:cs typeface="Arial" pitchFamily="34" charset="-120"/>
               </a:rPr>
-              <a:t>4 / 13</a:t>
+              <a:t>4 / 14</a:t>
             </a:r>
             <a:endParaRPr lang="en-US" sz="750" dirty="0"/>
           </a:p>
@@ -10538,7 +11717,7 @@
                 <a:ea typeface="Arial" pitchFamily="34" charset="-122"/>
                 <a:cs typeface="Arial" pitchFamily="34" charset="-120"/>
               </a:rPr>
-              <a:t>5 / 13</a:t>
+              <a:t>5 / 14</a:t>
             </a:r>
             <a:endParaRPr lang="en-US" sz="750" dirty="0"/>
           </a:p>
@@ -10577,7 +11756,7 @@
                 <a:ea typeface="Arial" pitchFamily="34" charset="-122"/>
                 <a:cs typeface="Arial" pitchFamily="34" charset="-120"/>
               </a:rPr>
-              <a:t>NEGENTIEN WEKEN MOYEE IN CIJFERS</a:t>
+              <a:t>WAT ER TOT NU TOE GEBELD IS</a:t>
             </a:r>
             <a:endParaRPr lang="en-US" sz="950" dirty="0"/>
           </a:p>
@@ -10714,7 +11893,7 @@
                 <a:ea typeface="Arial" pitchFamily="34" charset="-122"/>
                 <a:cs typeface="Arial" pitchFamily="34" charset="-120"/>
               </a:rPr>
-              <a:t>45</a:t>
+              <a:t>2.629</a:t>
             </a:r>
             <a:endParaRPr lang="en-US" sz="3600" dirty="0"/>
           </a:p>
@@ -10753,7 +11932,7 @@
                 <a:ea typeface="Arial" pitchFamily="34" charset="-122"/>
                 <a:cs typeface="Arial" pitchFamily="34" charset="-120"/>
               </a:rPr>
-              <a:t>GEKWALIFICEERDE LEADS</a:t>
+              <a:t>GESPREKSPOGINGEN</a:t>
             </a:r>
             <a:endParaRPr lang="en-US" sz="900" dirty="0"/>
           </a:p>
@@ -10795,7 +11974,7 @@
                 <a:ea typeface="Arial" pitchFamily="34" charset="-122"/>
                 <a:cs typeface="Arial" pitchFamily="34" charset="-120"/>
               </a:rPr>
-              <a:t>Opgeleverd tussen mei en september 2026, over negentien weken bellen.</a:t>
+              <a:t>Tussen maart en september 2026, verdeeld over 24 volle beldagen.</a:t>
             </a:r>
             <a:endParaRPr lang="en-US" sz="950" dirty="0"/>
           </a:p>
@@ -10856,7 +12035,7 @@
                 <a:ea typeface="Arial" pitchFamily="34" charset="-122"/>
                 <a:cs typeface="Arial" pitchFamily="34" charset="-120"/>
               </a:rPr>
-              <a:t>1.572</a:t>
+              <a:t>1.470</a:t>
             </a:r>
             <a:endParaRPr lang="en-US" sz="3600" dirty="0"/>
           </a:p>
@@ -10895,7 +12074,7 @@
                 <a:ea typeface="Arial" pitchFamily="34" charset="-122"/>
                 <a:cs typeface="Arial" pitchFamily="34" charset="-120"/>
               </a:rPr>
-              <a:t>GEBELDE CONTACTEN</a:t>
+              <a:t>BEDRIJVEN GESPROKEN</a:t>
             </a:r>
             <a:endParaRPr lang="en-US" sz="900" dirty="0"/>
           </a:p>
@@ -10937,7 +12116,7 @@
                 <a:ea typeface="Arial" pitchFamily="34" charset="-122"/>
                 <a:cs typeface="Arial" pitchFamily="34" charset="-120"/>
               </a:rPr>
-              <a:t>Bedrijven die we in die periode aan de lijn hebben geprobeerd te krijgen.</a:t>
+              <a:t>Van de 2.100 benaderde bedrijven kregen we bij zeven op de tien de juiste persoon aan de lijn.</a:t>
             </a:r>
             <a:endParaRPr lang="en-US" sz="950" dirty="0"/>
           </a:p>
@@ -10998,7 +12177,7 @@
                 <a:ea typeface="Arial" pitchFamily="34" charset="-122"/>
                 <a:cs typeface="Arial" pitchFamily="34" charset="-120"/>
               </a:rPr>
-              <a:t>38%</a:t>
+              <a:t>61</a:t>
             </a:r>
             <a:endParaRPr lang="en-US" sz="3600" dirty="0"/>
           </a:p>
@@ -11037,7 +12216,7 @@
                 <a:ea typeface="Arial" pitchFamily="34" charset="-122"/>
                 <a:cs typeface="Arial" pitchFamily="34" charset="-120"/>
               </a:rPr>
-              <a:t>BEREIKBAARHEID</a:t>
+              <a:t>GEKWALIFICEERDE LEADS</a:t>
             </a:r>
             <a:endParaRPr lang="en-US" sz="900" dirty="0"/>
           </a:p>
@@ -11079,7 +12258,7 @@
                 <a:ea typeface="Arial" pitchFamily="34" charset="-122"/>
                 <a:cs typeface="Arial" pitchFamily="34" charset="-120"/>
               </a:rPr>
-              <a:t>Van de gebelde contacten kregen we de juiste persoon daadwerkelijk te spreken.</a:t>
+              <a:t>16 tastingafspraken en 45 bedrijven die wilden proeven of bestellen.</a:t>
             </a:r>
             <a:endParaRPr lang="en-US" sz="950" dirty="0"/>
           </a:p>
@@ -11140,7 +12319,7 @@
                 <a:ea typeface="Arial" pitchFamily="34" charset="-122"/>
                 <a:cs typeface="Arial" pitchFamily="34" charset="-120"/>
               </a:rPr>
-              <a:t>2,4</a:t>
+              <a:t>23</a:t>
             </a:r>
             <a:endParaRPr lang="en-US" sz="3600" dirty="0"/>
           </a:p>
@@ -11179,7 +12358,7 @@
                 <a:ea typeface="Arial" pitchFamily="34" charset="-122"/>
                 <a:cs typeface="Arial" pitchFamily="34" charset="-120"/>
               </a:rPr>
-              <a:t>LEADS PER BELDAG</a:t>
+              <a:t>TASTINGS INGEPLAND</a:t>
             </a:r>
             <a:endParaRPr lang="en-US" sz="900" dirty="0"/>
           </a:p>
@@ -11221,7 +12400,7 @@
                 <a:ea typeface="Arial" pitchFamily="34" charset="-122"/>
                 <a:cs typeface="Arial" pitchFamily="34" charset="-120"/>
               </a:rPr>
-              <a:t>Gemiddeld over negentien weken, bij één beldag per week. Dit getal is de basis onder het voorstel.</a:t>
+              <a:t>Waarvan er 7 onder de overdrachten stonden. Samen 0,9 tasting per beldag.</a:t>
             </a:r>
             <a:endParaRPr lang="en-US" sz="950" dirty="0"/>
           </a:p>
@@ -11280,7 +12459,7 @@
                 <a:ea typeface="Arial" pitchFamily="34" charset="-122"/>
                 <a:cs typeface="Arial" pitchFamily="34" charset="-120"/>
               </a:rPr>
-              <a:t>Gemiddeld één tasting per beldag. De overige leads willen bestellen en hoeven alleen nog opgevolgd te worden.</a:t>
+              <a:t>Uit die 2.629 pogingen komt het kengetal waar het voorstel op rust: 23,2 gekwalificeerde leads per duizend gesprekspogingen.</a:t>
             </a:r>
             <a:endParaRPr lang="en-US" sz="1200" dirty="0"/>
           </a:p>
@@ -11443,7 +12622,7 @@
                 <a:ea typeface="Arial" pitchFamily="34" charset="-122"/>
                 <a:cs typeface="Arial" pitchFamily="34" charset="-120"/>
               </a:rPr>
-              <a:t>6 / 13</a:t>
+              <a:t>6 / 14</a:t>
             </a:r>
             <a:endParaRPr lang="en-US" sz="750" dirty="0"/>
           </a:p>
@@ -11730,7 +12909,7 @@
                 <a:ea typeface="Arial" pitchFamily="34" charset="-122"/>
                 <a:cs typeface="Arial" pitchFamily="34" charset="-120"/>
               </a:rPr>
-              <a:t>Van elk gesprek leggen we vast wanneer het gevoerd is en wat het opleverde. Per dag, per dagdeel en per soort bedrijf.</a:t>
+              <a:t>Van elke van de 2.629 pogingen ligt vast wanneer hij gevoerd is en wat hij opleverde. Per dag, per dagdeel en per soort bedrijf.</a:t>
             </a:r>
             <a:endParaRPr lang="en-US" sz="875" dirty="0"/>
           </a:p>
@@ -11860,7 +13039,7 @@
                 <a:ea typeface="Arial" pitchFamily="34" charset="-122"/>
                 <a:cs typeface="Arial" pitchFamily="34" charset="-120"/>
               </a:rPr>
-              <a:t>Wanneer zit de beslisser er</a:t>
+              <a:t>'s Ochtends zit de beslisser er</a:t>
             </a:r>
             <a:endParaRPr lang="en-US" sz="1150" dirty="0"/>
           </a:p>
@@ -11902,7 +13081,7 @@
                 <a:ea typeface="Arial" pitchFamily="34" charset="-122"/>
                 <a:cs typeface="Arial" pitchFamily="34" charset="-120"/>
               </a:rPr>
-              <a:t>Uit negentien weken Moyee-data halen we op welke dagen en dagdelen we de beslisser ook daadwerkelijk aan de lijn krijgen.</a:t>
+              <a:t>Tussen 8 en 12 uur krijgen we 71,9 procent van de gebelde bedrijven te spreken. Na 15 uur zakt dat naar 54,2 procent.</a:t>
             </a:r>
             <a:endParaRPr lang="en-US" sz="875" dirty="0"/>
           </a:p>
@@ -12032,7 +13211,7 @@
                 <a:ea typeface="Arial" pitchFamily="34" charset="-122"/>
                 <a:cs typeface="Arial" pitchFamily="34" charset="-120"/>
               </a:rPr>
-              <a:t>Beldagen op de beste dagen</a:t>
+              <a:t>Ook de dag maakt verschil</a:t>
             </a:r>
             <a:endParaRPr lang="en-US" sz="1150" dirty="0"/>
           </a:p>
@@ -12074,7 +13253,7 @@
                 <a:ea typeface="Arial" pitchFamily="34" charset="-122"/>
                 <a:cs typeface="Arial" pitchFamily="34" charset="-120"/>
               </a:rPr>
-              <a:t>We plannen de beldagen niet op de dagen die ons uitkomen, maar op de dagen die in jullie cijfers het hoogste scoren.</a:t>
+              <a:t>Woensdag levert de hoogste bereikbaarheid op met 71,8 procent, donderdag de laagste met 57,2 procent.</a:t>
             </a:r>
             <a:endParaRPr lang="en-US" sz="875" dirty="0"/>
           </a:p>
@@ -12204,7 +13383,7 @@
                 <a:ea typeface="Arial" pitchFamily="34" charset="-122"/>
                 <a:cs typeface="Arial" pitchFamily="34" charset="-120"/>
               </a:rPr>
-              <a:t>Elke periode scherper</a:t>
+              <a:t>Beldagen op de beste momenten</a:t>
             </a:r>
             <a:endParaRPr lang="en-US" sz="1150" dirty="0"/>
           </a:p>
@@ -12246,7 +13425,7 @@
                 <a:ea typeface="Arial" pitchFamily="34" charset="-122"/>
                 <a:cs typeface="Arial" pitchFamily="34" charset="-120"/>
               </a:rPr>
-              <a:t>Elke werkperiode levert nieuwe data op. De indeling van de beldagen past zich daarop aan, zonder dat de prijs verandert.</a:t>
+              <a:t>We plannen de beldagen op de dagen en dagdelen die in jullie eigen cijfers het hoogste scoren, en na elke periode kijken we of dat nog klopt.</a:t>
             </a:r>
             <a:endParaRPr lang="en-US" sz="875" dirty="0"/>
           </a:p>
@@ -12305,7 +13484,7 @@
                 <a:ea typeface="Arial" pitchFamily="34" charset="-122"/>
                 <a:cs typeface="Arial" pitchFamily="34" charset="-120"/>
               </a:rPr>
-              <a:t>De concrete dagen en dagdelen lopen we maandag samen door, met de cijfers erbij.</a:t>
+              <a:t>Per duizend pogingen levert de ochtend 26,2 leads op en het eind van de middag 15,1. Daar plannen we op.</a:t>
             </a:r>
             <a:endParaRPr lang="en-US" sz="1200" dirty="0"/>
           </a:p>
@@ -12468,7 +13647,7 @@
                 <a:ea typeface="Arial" pitchFamily="34" charset="-122"/>
                 <a:cs typeface="Arial" pitchFamily="34" charset="-120"/>
               </a:rPr>
-              <a:t>7 / 13</a:t>
+              <a:t>7 / 14</a:t>
             </a:r>
             <a:endParaRPr lang="en-US" sz="750" dirty="0"/>
           </a:p>
@@ -13252,7 +14431,7 @@
                 <a:ea typeface="Arial" pitchFamily="34" charset="-122"/>
                 <a:cs typeface="Arial" pitchFamily="34" charset="-120"/>
               </a:rPr>
-              <a:t>8 / 13</a:t>
+              <a:t>8 / 14</a:t>
             </a:r>
             <a:endParaRPr lang="en-US" sz="750" dirty="0"/>
           </a:p>
@@ -13516,7 +14695,7 @@
                 <a:ea typeface="Arial" pitchFamily="34" charset="-122"/>
                 <a:cs typeface="Arial" pitchFamily="34" charset="-120"/>
               </a:rPr>
-              <a:t>In negentien weken hebben we 1.572 bedrijven gebeld. Dat is nog maar een fractie van de markt, dus we kunnen hier nog lang op doorbellen.</a:t>
+              <a:t>In een half jaar hebben we 2.100 bedrijven benaderd en 2.629 keer gebeld. Dat is nog maar een fractie van de markt, en elk gesprek is ook een moment waarop iemand de naam Moyee hoort.</a:t>
             </a:r>
             <a:endParaRPr lang="en-US" sz="1050" dirty="0"/>
           </a:p>
@@ -13983,7 +15162,7 @@
     <p:bg>
       <p:bgPr>
         <a:solidFill>
-          <a:srgbClr val="141821"/>
+          <a:srgbClr val="E9E0CD"/>
         </a:solidFill>
       </p:bgPr>
     </p:bg>
@@ -14028,7 +15207,7 @@
             <a:r>
               <a:rPr lang="en-US" sz="1800" b="1" dirty="0">
                 <a:solidFill>
-                  <a:srgbClr val="F2EFE6"/>
+                  <a:srgbClr val="1C2230"/>
                 </a:solidFill>
                 <a:latin typeface="Arial" pitchFamily="34" charset="0"/>
                 <a:ea typeface="Arial" pitchFamily="34" charset="-122"/>
@@ -14081,7 +15260,7 @@
             <a:r>
               <a:rPr lang="en-US" sz="750" b="1" spc="100" kern="0" dirty="0">
                 <a:solidFill>
-                  <a:srgbClr val="BDC3CE"/>
+                  <a:srgbClr val="6F6A5C"/>
                 </a:solidFill>
                 <a:latin typeface="Arial" pitchFamily="34" charset="0"/>
                 <a:ea typeface="Arial" pitchFamily="34" charset="-122"/>
@@ -14120,13 +15299,13 @@
             <a:r>
               <a:rPr lang="en-US" sz="750" b="1" spc="100" kern="0" dirty="0">
                 <a:solidFill>
-                  <a:srgbClr val="BDC3CE"/>
-                </a:solidFill>
-                <a:latin typeface="Arial" pitchFamily="34" charset="0"/>
-                <a:ea typeface="Arial" pitchFamily="34" charset="-122"/>
-                <a:cs typeface="Arial" pitchFamily="34" charset="-120"/>
-              </a:rPr>
-              <a:t>9 / 13</a:t>
+                  <a:srgbClr val="6F6A5C"/>
+                </a:solidFill>
+                <a:latin typeface="Arial" pitchFamily="34" charset="0"/>
+                <a:ea typeface="Arial" pitchFamily="34" charset="-122"/>
+                <a:cs typeface="Arial" pitchFamily="34" charset="-120"/>
+              </a:rPr>
+              <a:t>9 / 14</a:t>
             </a:r>
             <a:endParaRPr lang="en-US" sz="750" dirty="0"/>
           </a:p>
@@ -14165,7 +15344,7 @@
                 <a:ea typeface="Arial" pitchFamily="34" charset="-122"/>
                 <a:cs typeface="Arial" pitchFamily="34" charset="-120"/>
               </a:rPr>
-              <a:t>HET VOORSTEL</a:t>
+              <a:t>WAT ER NOG KLAARSTAAT</a:t>
             </a:r>
             <a:endParaRPr lang="en-US" sz="950" dirty="0"/>
           </a:p>
@@ -14201,13 +15380,13 @@
             <a:r>
               <a:rPr lang="en-US" sz="3200" b="1" dirty="0">
                 <a:solidFill>
-                  <a:srgbClr val="F2EFE6"/>
-                </a:solidFill>
-                <a:latin typeface="Arial" pitchFamily="34" charset="0"/>
-                <a:ea typeface="Arial" pitchFamily="34" charset="-122"/>
-                <a:cs typeface="Arial" pitchFamily="34" charset="-120"/>
-              </a:rPr>
-              <a:t>Vaste beldagen per vier weken, </a:t>
+                  <a:srgbClr val="1C2230"/>
+                </a:solidFill>
+                <a:latin typeface="Arial" pitchFamily="34" charset="0"/>
+                <a:ea typeface="Arial" pitchFamily="34" charset="-122"/>
+                <a:cs typeface="Arial" pitchFamily="34" charset="-120"/>
+              </a:rPr>
+              <a:t>De pijplijn is nog lang niet </a:t>
             </a:r>
             <a:pPr algn="l" indent="0" marL="0">
               <a:lnSpc>
@@ -14218,13 +15397,13 @@
             <a:r>
               <a:rPr lang="en-US" sz="3000" i="1" dirty="0">
                 <a:solidFill>
-                  <a:srgbClr val="F2EFE6"/>
+                  <a:srgbClr val="1C2230"/>
                 </a:solidFill>
                 <a:latin typeface="Georgia" pitchFamily="34" charset="0"/>
                 <a:ea typeface="Georgia" pitchFamily="34" charset="-122"/>
                 <a:cs typeface="Georgia" pitchFamily="34" charset="-120"/>
               </a:rPr>
-              <a:t>één dagprijs</a:t>
+              <a:t>leeg</a:t>
             </a:r>
             <a:pPr algn="l" indent="0" marL="0">
               <a:lnSpc>
@@ -14235,7 +15414,7 @@
             <a:r>
               <a:rPr lang="en-US" sz="3200" b="1" dirty="0">
                 <a:solidFill>
-                  <a:srgbClr val="F2EFE6"/>
+                  <a:srgbClr val="1C2230"/>
                 </a:solidFill>
                 <a:latin typeface="Arial" pitchFamily="34" charset="0"/>
                 <a:ea typeface="Arial" pitchFamily="34" charset="-122"/>
@@ -14255,20 +15434,18 @@
         </p:nvSpPr>
         <p:spPr>
           <a:xfrm>
-            <a:off x="609598" y="2666993"/>
-            <a:ext cx="10972773" cy="2355844"/>
+            <a:off x="609598" y="2730493"/>
+            <a:ext cx="2628893" cy="2222494"/>
           </a:xfrm>
           <a:prstGeom prst="roundRect">
             <a:avLst>
-              <a:gd name="adj" fmla="val 4313"/>
+              <a:gd name="adj" fmla="val 4571"/>
             </a:avLst>
           </a:prstGeom>
-          <a:ln w="9525">
-            <a:solidFill>
-              <a:srgbClr val="3A4152"/>
-            </a:solidFill>
-            <a:prstDash val="solid"/>
-          </a:ln>
+          <a:solidFill>
+            <a:srgbClr val="F8F4EB"/>
+          </a:solidFill>
+          <a:ln/>
         </p:spPr>
       </p:sp>
       <p:sp>
@@ -14279,8 +15456,8 @@
         </p:nvSpPr>
         <p:spPr>
           <a:xfrm>
-            <a:off x="888998" y="2666993"/>
-            <a:ext cx="2920993" cy="469899"/>
+            <a:off x="850898" y="2997193"/>
+            <a:ext cx="2146295" cy="507999"/>
           </a:xfrm>
           <a:prstGeom prst="rect">
             <a:avLst/>
@@ -14296,7 +15473,514 @@
               <a:buNone/>
             </a:pPr>
             <a:r>
-              <a:rPr lang="en-US" sz="800" b="1" spc="160" kern="0" dirty="0">
+              <a:rPr lang="en-US" sz="3600" b="1" dirty="0">
+                <a:solidFill>
+                  <a:srgbClr val="1C2230"/>
+                </a:solidFill>
+                <a:latin typeface="Arial" pitchFamily="34" charset="0"/>
+                <a:ea typeface="Arial" pitchFamily="34" charset="-122"/>
+                <a:cs typeface="Arial" pitchFamily="34" charset="-120"/>
+              </a:rPr>
+              <a:t>217</a:t>
+            </a:r>
+            <a:endParaRPr lang="en-US" sz="3600" dirty="0"/>
+          </a:p>
+        </p:txBody>
+      </p:sp>
+      <p:sp>
+        <p:nvSpPr>
+          <p:cNvPr id="9" name="Text 7"/>
+          <p:cNvSpPr txBox="1"/>
+          <p:nvPr/>
+        </p:nvSpPr>
+        <p:spPr>
+          <a:xfrm>
+            <a:off x="850898" y="3555991"/>
+            <a:ext cx="2146295" cy="215899"/>
+          </a:xfrm>
+          <a:prstGeom prst="rect">
+            <a:avLst/>
+          </a:prstGeom>
+          <a:noFill/>
+          <a:ln/>
+        </p:spPr>
+        <p:txBody>
+          <a:bodyPr wrap="square" lIns="0" tIns="0" rIns="0" bIns="0" rtlCol="0" anchor="ctr"/>
+          <a:lstStyle/>
+          <a:p>
+            <a:pPr indent="0" marL="0">
+              <a:buNone/>
+            </a:pPr>
+            <a:r>
+              <a:rPr lang="en-US" sz="900" b="1" spc="120" kern="0" dirty="0">
+                <a:solidFill>
+                  <a:srgbClr val="38B6FF"/>
+                </a:solidFill>
+                <a:latin typeface="Arial" pitchFamily="34" charset="0"/>
+                <a:ea typeface="Arial" pitchFamily="34" charset="-122"/>
+                <a:cs typeface="Arial" pitchFamily="34" charset="-120"/>
+              </a:rPr>
+              <a:t>WARME CONTACTEN OPEN</a:t>
+            </a:r>
+            <a:endParaRPr lang="en-US" sz="900" dirty="0"/>
+          </a:p>
+        </p:txBody>
+      </p:sp>
+      <p:sp>
+        <p:nvSpPr>
+          <p:cNvPr id="10" name="Text 8"/>
+          <p:cNvSpPr txBox="1"/>
+          <p:nvPr/>
+        </p:nvSpPr>
+        <p:spPr>
+          <a:xfrm>
+            <a:off x="850898" y="3975090"/>
+            <a:ext cx="2146295" cy="888998"/>
+          </a:xfrm>
+          <a:prstGeom prst="rect">
+            <a:avLst/>
+          </a:prstGeom>
+          <a:noFill/>
+          <a:ln/>
+        </p:spPr>
+        <p:txBody>
+          <a:bodyPr wrap="square" lIns="0" tIns="0" rIns="0" bIns="0" rtlCol="0" anchor="t"/>
+          <a:lstStyle/>
+          <a:p>
+            <a:pPr indent="0" marL="0">
+              <a:lnSpc>
+                <a:spcPct val="135000"/>
+              </a:lnSpc>
+              <a:buNone/>
+            </a:pPr>
+            <a:r>
+              <a:rPr lang="en-US" sz="950" dirty="0">
+                <a:solidFill>
+                  <a:srgbClr val="6F6A5C"/>
+                </a:solidFill>
+                <a:latin typeface="Arial" pitchFamily="34" charset="0"/>
+                <a:ea typeface="Arial" pitchFamily="34" charset="-122"/>
+                <a:cs typeface="Arial" pitchFamily="34" charset="-120"/>
+              </a:rPr>
+              <a:t>148 terugbelafspraken en 68 bedrijven die informatie kregen.</a:t>
+            </a:r>
+            <a:endParaRPr lang="en-US" sz="950" dirty="0"/>
+          </a:p>
+        </p:txBody>
+      </p:sp>
+      <p:sp>
+        <p:nvSpPr>
+          <p:cNvPr id="11" name="Shape 9"/>
+          <p:cNvSpPr/>
+          <p:nvPr/>
+        </p:nvSpPr>
+        <p:spPr>
+          <a:xfrm>
+            <a:off x="3390892" y="2730493"/>
+            <a:ext cx="2628893" cy="2222494"/>
+          </a:xfrm>
+          <a:prstGeom prst="roundRect">
+            <a:avLst>
+              <a:gd name="adj" fmla="val 4571"/>
+            </a:avLst>
+          </a:prstGeom>
+          <a:solidFill>
+            <a:srgbClr val="F8F4EB"/>
+          </a:solidFill>
+          <a:ln/>
+        </p:spPr>
+      </p:sp>
+      <p:sp>
+        <p:nvSpPr>
+          <p:cNvPr id="12" name="Text 10"/>
+          <p:cNvSpPr txBox="1"/>
+          <p:nvPr/>
+        </p:nvSpPr>
+        <p:spPr>
+          <a:xfrm>
+            <a:off x="3632191" y="2997193"/>
+            <a:ext cx="2146295" cy="507999"/>
+          </a:xfrm>
+          <a:prstGeom prst="rect">
+            <a:avLst/>
+          </a:prstGeom>
+          <a:noFill/>
+          <a:ln/>
+        </p:spPr>
+        <p:txBody>
+          <a:bodyPr wrap="square" lIns="0" tIns="0" rIns="0" bIns="0" rtlCol="0" anchor="ctr"/>
+          <a:lstStyle/>
+          <a:p>
+            <a:pPr indent="0" marL="0">
+              <a:buNone/>
+            </a:pPr>
+            <a:r>
+              <a:rPr lang="en-US" sz="3600" b="1" dirty="0">
+                <a:solidFill>
+                  <a:srgbClr val="1C2230"/>
+                </a:solidFill>
+                <a:latin typeface="Arial" pitchFamily="34" charset="0"/>
+                <a:ea typeface="Arial" pitchFamily="34" charset="-122"/>
+                <a:cs typeface="Arial" pitchFamily="34" charset="-120"/>
+              </a:rPr>
+              <a:t>235</a:t>
+            </a:r>
+            <a:endParaRPr lang="en-US" sz="3600" dirty="0"/>
+          </a:p>
+        </p:txBody>
+      </p:sp>
+      <p:sp>
+        <p:nvSpPr>
+          <p:cNvPr id="13" name="Text 11"/>
+          <p:cNvSpPr txBox="1"/>
+          <p:nvPr/>
+        </p:nvSpPr>
+        <p:spPr>
+          <a:xfrm>
+            <a:off x="3632191" y="3555991"/>
+            <a:ext cx="2146295" cy="215899"/>
+          </a:xfrm>
+          <a:prstGeom prst="rect">
+            <a:avLst/>
+          </a:prstGeom>
+          <a:noFill/>
+          <a:ln/>
+        </p:spPr>
+        <p:txBody>
+          <a:bodyPr wrap="square" lIns="0" tIns="0" rIns="0" bIns="0" rtlCol="0" anchor="ctr"/>
+          <a:lstStyle/>
+          <a:p>
+            <a:pPr indent="0" marL="0">
+              <a:buNone/>
+            </a:pPr>
+            <a:r>
+              <a:rPr lang="en-US" sz="900" b="1" spc="120" kern="0" dirty="0">
+                <a:solidFill>
+                  <a:srgbClr val="38B6FF"/>
+                </a:solidFill>
+                <a:latin typeface="Arial" pitchFamily="34" charset="0"/>
+                <a:ea typeface="Arial" pitchFamily="34" charset="-122"/>
+                <a:cs typeface="Arial" pitchFamily="34" charset="-120"/>
+              </a:rPr>
+              <a:t>ZITTEN AAN EEN CONTRACT</a:t>
+            </a:r>
+            <a:endParaRPr lang="en-US" sz="900" dirty="0"/>
+          </a:p>
+        </p:txBody>
+      </p:sp>
+      <p:sp>
+        <p:nvSpPr>
+          <p:cNvPr id="14" name="Text 12"/>
+          <p:cNvSpPr txBox="1"/>
+          <p:nvPr/>
+        </p:nvSpPr>
+        <p:spPr>
+          <a:xfrm>
+            <a:off x="3632191" y="3975090"/>
+            <a:ext cx="2146295" cy="888998"/>
+          </a:xfrm>
+          <a:prstGeom prst="rect">
+            <a:avLst/>
+          </a:prstGeom>
+          <a:noFill/>
+          <a:ln/>
+        </p:spPr>
+        <p:txBody>
+          <a:bodyPr wrap="square" lIns="0" tIns="0" rIns="0" bIns="0" rtlCol="0" anchor="t"/>
+          <a:lstStyle/>
+          <a:p>
+            <a:pPr indent="0" marL="0">
+              <a:lnSpc>
+                <a:spcPct val="135000"/>
+              </a:lnSpc>
+              <a:buNone/>
+            </a:pPr>
+            <a:r>
+              <a:rPr lang="en-US" sz="950" dirty="0">
+                <a:solidFill>
+                  <a:srgbClr val="6F6A5C"/>
+                </a:solidFill>
+                <a:latin typeface="Arial" pitchFamily="34" charset="0"/>
+                <a:ea typeface="Arial" pitchFamily="34" charset="-122"/>
+                <a:cs typeface="Arial" pitchFamily="34" charset="-120"/>
+              </a:rPr>
+              <a:t>Die zijn nu voorzien, maar hun contract loopt een keer af. Wij houden ze vast.</a:t>
+            </a:r>
+            <a:endParaRPr lang="en-US" sz="950" dirty="0"/>
+          </a:p>
+        </p:txBody>
+      </p:sp>
+      <p:sp>
+        <p:nvSpPr>
+          <p:cNvPr id="15" name="Shape 13"/>
+          <p:cNvSpPr/>
+          <p:nvPr/>
+        </p:nvSpPr>
+        <p:spPr>
+          <a:xfrm>
+            <a:off x="6172185" y="2730493"/>
+            <a:ext cx="2628893" cy="2222494"/>
+          </a:xfrm>
+          <a:prstGeom prst="roundRect">
+            <a:avLst>
+              <a:gd name="adj" fmla="val 4571"/>
+            </a:avLst>
+          </a:prstGeom>
+          <a:solidFill>
+            <a:srgbClr val="F8F4EB"/>
+          </a:solidFill>
+          <a:ln/>
+        </p:spPr>
+      </p:sp>
+      <p:sp>
+        <p:nvSpPr>
+          <p:cNvPr id="16" name="Text 14"/>
+          <p:cNvSpPr txBox="1"/>
+          <p:nvPr/>
+        </p:nvSpPr>
+        <p:spPr>
+          <a:xfrm>
+            <a:off x="6413484" y="2997193"/>
+            <a:ext cx="2146295" cy="507999"/>
+          </a:xfrm>
+          <a:prstGeom prst="rect">
+            <a:avLst/>
+          </a:prstGeom>
+          <a:noFill/>
+          <a:ln/>
+        </p:spPr>
+        <p:txBody>
+          <a:bodyPr wrap="square" lIns="0" tIns="0" rIns="0" bIns="0" rtlCol="0" anchor="ctr"/>
+          <a:lstStyle/>
+          <a:p>
+            <a:pPr indent="0" marL="0">
+              <a:buNone/>
+            </a:pPr>
+            <a:r>
+              <a:rPr lang="en-US" sz="3600" b="1" dirty="0">
+                <a:solidFill>
+                  <a:srgbClr val="1C2230"/>
+                </a:solidFill>
+                <a:latin typeface="Arial" pitchFamily="34" charset="0"/>
+                <a:ea typeface="Arial" pitchFamily="34" charset="-122"/>
+                <a:cs typeface="Arial" pitchFamily="34" charset="-120"/>
+              </a:rPr>
+              <a:t>372</a:t>
+            </a:r>
+            <a:endParaRPr lang="en-US" sz="3600" dirty="0"/>
+          </a:p>
+        </p:txBody>
+      </p:sp>
+      <p:sp>
+        <p:nvSpPr>
+          <p:cNvPr id="17" name="Text 15"/>
+          <p:cNvSpPr txBox="1"/>
+          <p:nvPr/>
+        </p:nvSpPr>
+        <p:spPr>
+          <a:xfrm>
+            <a:off x="6413484" y="3555991"/>
+            <a:ext cx="2146295" cy="215899"/>
+          </a:xfrm>
+          <a:prstGeom prst="rect">
+            <a:avLst/>
+          </a:prstGeom>
+          <a:noFill/>
+          <a:ln/>
+        </p:spPr>
+        <p:txBody>
+          <a:bodyPr wrap="square" lIns="0" tIns="0" rIns="0" bIns="0" rtlCol="0" anchor="ctr"/>
+          <a:lstStyle/>
+          <a:p>
+            <a:pPr indent="0" marL="0">
+              <a:buNone/>
+            </a:pPr>
+            <a:r>
+              <a:rPr lang="en-US" sz="900" b="1" spc="120" kern="0" dirty="0">
+                <a:solidFill>
+                  <a:srgbClr val="38B6FF"/>
+                </a:solidFill>
+                <a:latin typeface="Arial" pitchFamily="34" charset="0"/>
+                <a:ea typeface="Arial" pitchFamily="34" charset="-122"/>
+                <a:cs typeface="Arial" pitchFamily="34" charset="-120"/>
+              </a:rPr>
+              <a:t>NOG NIET BEREIKT</a:t>
+            </a:r>
+            <a:endParaRPr lang="en-US" sz="900" dirty="0"/>
+          </a:p>
+        </p:txBody>
+      </p:sp>
+      <p:sp>
+        <p:nvSpPr>
+          <p:cNvPr id="18" name="Text 16"/>
+          <p:cNvSpPr txBox="1"/>
+          <p:nvPr/>
+        </p:nvSpPr>
+        <p:spPr>
+          <a:xfrm>
+            <a:off x="6413484" y="3975090"/>
+            <a:ext cx="2146295" cy="888998"/>
+          </a:xfrm>
+          <a:prstGeom prst="rect">
+            <a:avLst/>
+          </a:prstGeom>
+          <a:noFill/>
+          <a:ln/>
+        </p:spPr>
+        <p:txBody>
+          <a:bodyPr wrap="square" lIns="0" tIns="0" rIns="0" bIns="0" rtlCol="0" anchor="t"/>
+          <a:lstStyle/>
+          <a:p>
+            <a:pPr indent="0" marL="0">
+              <a:lnSpc>
+                <a:spcPct val="135000"/>
+              </a:lnSpc>
+              <a:buNone/>
+            </a:pPr>
+            <a:r>
+              <a:rPr lang="en-US" sz="950" dirty="0">
+                <a:solidFill>
+                  <a:srgbClr val="6F6A5C"/>
+                </a:solidFill>
+                <a:latin typeface="Arial" pitchFamily="34" charset="0"/>
+                <a:ea typeface="Arial" pitchFamily="34" charset="-122"/>
+                <a:cs typeface="Arial" pitchFamily="34" charset="-120"/>
+              </a:rPr>
+              <a:t>Wel benaderd, nog geen contact gehad. Daar is nog volledige winst te halen.</a:t>
+            </a:r>
+            <a:endParaRPr lang="en-US" sz="950" dirty="0"/>
+          </a:p>
+        </p:txBody>
+      </p:sp>
+      <p:sp>
+        <p:nvSpPr>
+          <p:cNvPr id="19" name="Shape 17"/>
+          <p:cNvSpPr/>
+          <p:nvPr/>
+        </p:nvSpPr>
+        <p:spPr>
+          <a:xfrm>
+            <a:off x="8953478" y="2730493"/>
+            <a:ext cx="2628893" cy="2222494"/>
+          </a:xfrm>
+          <a:prstGeom prst="roundRect">
+            <a:avLst>
+              <a:gd name="adj" fmla="val 4571"/>
+            </a:avLst>
+          </a:prstGeom>
+          <a:solidFill>
+            <a:srgbClr val="000000"/>
+          </a:solidFill>
+          <a:ln/>
+        </p:spPr>
+      </p:sp>
+      <p:sp>
+        <p:nvSpPr>
+          <p:cNvPr id="20" name="Text 18"/>
+          <p:cNvSpPr txBox="1"/>
+          <p:nvPr/>
+        </p:nvSpPr>
+        <p:spPr>
+          <a:xfrm>
+            <a:off x="9194777" y="2997193"/>
+            <a:ext cx="2146295" cy="507999"/>
+          </a:xfrm>
+          <a:prstGeom prst="rect">
+            <a:avLst/>
+          </a:prstGeom>
+          <a:noFill/>
+          <a:ln/>
+        </p:spPr>
+        <p:txBody>
+          <a:bodyPr wrap="square" lIns="0" tIns="0" rIns="0" bIns="0" rtlCol="0" anchor="ctr"/>
+          <a:lstStyle/>
+          <a:p>
+            <a:pPr indent="0" marL="0">
+              <a:buNone/>
+            </a:pPr>
+            <a:r>
+              <a:rPr lang="en-US" sz="3600" b="1" dirty="0">
+                <a:solidFill>
+                  <a:srgbClr val="38B6FF"/>
+                </a:solidFill>
+                <a:latin typeface="Arial" pitchFamily="34" charset="0"/>
+                <a:ea typeface="Arial" pitchFamily="34" charset="-122"/>
+                <a:cs typeface="Arial" pitchFamily="34" charset="-120"/>
+              </a:rPr>
+              <a:t>2.100</a:t>
+            </a:r>
+            <a:endParaRPr lang="en-US" sz="3600" dirty="0"/>
+          </a:p>
+        </p:txBody>
+      </p:sp>
+      <p:sp>
+        <p:nvSpPr>
+          <p:cNvPr id="21" name="Text 19"/>
+          <p:cNvSpPr txBox="1"/>
+          <p:nvPr/>
+        </p:nvSpPr>
+        <p:spPr>
+          <a:xfrm>
+            <a:off x="9194777" y="3555991"/>
+            <a:ext cx="2146295" cy="215899"/>
+          </a:xfrm>
+          <a:prstGeom prst="rect">
+            <a:avLst/>
+          </a:prstGeom>
+          <a:noFill/>
+          <a:ln/>
+        </p:spPr>
+        <p:txBody>
+          <a:bodyPr wrap="square" lIns="0" tIns="0" rIns="0" bIns="0" rtlCol="0" anchor="ctr"/>
+          <a:lstStyle/>
+          <a:p>
+            <a:pPr indent="0" marL="0">
+              <a:buNone/>
+            </a:pPr>
+            <a:r>
+              <a:rPr lang="en-US" sz="900" b="1" spc="120" kern="0" dirty="0">
+                <a:solidFill>
+                  <a:srgbClr val="38B6FF"/>
+                </a:solidFill>
+                <a:latin typeface="Arial" pitchFamily="34" charset="0"/>
+                <a:ea typeface="Arial" pitchFamily="34" charset="-122"/>
+                <a:cs typeface="Arial" pitchFamily="34" charset="-120"/>
+              </a:rPr>
+              <a:t>BEDRIJVEN BENADERD</a:t>
+            </a:r>
+            <a:endParaRPr lang="en-US" sz="900" dirty="0"/>
+          </a:p>
+        </p:txBody>
+      </p:sp>
+      <p:sp>
+        <p:nvSpPr>
+          <p:cNvPr id="22" name="Text 20"/>
+          <p:cNvSpPr txBox="1"/>
+          <p:nvPr/>
+        </p:nvSpPr>
+        <p:spPr>
+          <a:xfrm>
+            <a:off x="9194777" y="3975090"/>
+            <a:ext cx="2146295" cy="888998"/>
+          </a:xfrm>
+          <a:prstGeom prst="rect">
+            <a:avLst/>
+          </a:prstGeom>
+          <a:noFill/>
+          <a:ln/>
+        </p:spPr>
+        <p:txBody>
+          <a:bodyPr wrap="square" lIns="0" tIns="0" rIns="0" bIns="0" rtlCol="0" anchor="t"/>
+          <a:lstStyle/>
+          <a:p>
+            <a:pPr indent="0" marL="0">
+              <a:lnSpc>
+                <a:spcPct val="135000"/>
+              </a:lnSpc>
+              <a:buNone/>
+            </a:pPr>
+            <a:r>
+              <a:rPr lang="en-US" sz="950" dirty="0">
                 <a:solidFill>
                   <a:srgbClr val="C2C8D2"/>
                 </a:solidFill>
@@ -14304,705 +15988,15 @@
                 <a:ea typeface="Arial" pitchFamily="34" charset="-122"/>
                 <a:cs typeface="Arial" pitchFamily="34" charset="-120"/>
               </a:rPr>
-              <a:t>BELDAGEN PER 4 WEKEN</a:t>
-            </a:r>
-            <a:endParaRPr lang="en-US" sz="800" dirty="0"/>
-          </a:p>
-        </p:txBody>
-      </p:sp>
-      <p:sp>
-        <p:nvSpPr>
-          <p:cNvPr id="9" name="Text 7"/>
-          <p:cNvSpPr txBox="1"/>
-          <p:nvPr/>
-        </p:nvSpPr>
-        <p:spPr>
-          <a:xfrm>
-            <a:off x="3886190" y="2666993"/>
-            <a:ext cx="2349494" cy="469899"/>
-          </a:xfrm>
-          <a:prstGeom prst="rect">
-            <a:avLst/>
-          </a:prstGeom>
-          <a:noFill/>
-          <a:ln/>
-        </p:spPr>
-        <p:txBody>
-          <a:bodyPr wrap="square" lIns="0" tIns="0" rIns="0" bIns="0" rtlCol="0" anchor="ctr"/>
-          <a:lstStyle/>
-          <a:p>
-            <a:pPr indent="0" marL="0">
-              <a:buNone/>
-            </a:pPr>
-            <a:r>
-              <a:rPr lang="en-US" sz="800" b="1" spc="160" kern="0" dirty="0">
-                <a:solidFill>
-                  <a:srgbClr val="C2C8D2"/>
-                </a:solidFill>
-                <a:latin typeface="Arial" pitchFamily="34" charset="0"/>
-                <a:ea typeface="Arial" pitchFamily="34" charset="-122"/>
-                <a:cs typeface="Arial" pitchFamily="34" charset="-120"/>
-              </a:rPr>
-              <a:t>PRIJS PER BELDAG</a:t>
-            </a:r>
-            <a:endParaRPr lang="en-US" sz="800" dirty="0"/>
-          </a:p>
-        </p:txBody>
-      </p:sp>
-      <p:sp>
-        <p:nvSpPr>
-          <p:cNvPr id="10" name="Text 8"/>
-          <p:cNvSpPr txBox="1"/>
-          <p:nvPr/>
-        </p:nvSpPr>
-        <p:spPr>
-          <a:xfrm>
-            <a:off x="6324584" y="2666993"/>
-            <a:ext cx="2349494" cy="469899"/>
-          </a:xfrm>
-          <a:prstGeom prst="rect">
-            <a:avLst/>
-          </a:prstGeom>
-          <a:noFill/>
-          <a:ln/>
-        </p:spPr>
-        <p:txBody>
-          <a:bodyPr wrap="square" lIns="0" tIns="0" rIns="0" bIns="0" rtlCol="0" anchor="ctr"/>
-          <a:lstStyle/>
-          <a:p>
-            <a:pPr indent="0" marL="0">
-              <a:buNone/>
-            </a:pPr>
-            <a:r>
-              <a:rPr lang="en-US" sz="800" b="1" spc="160" kern="0" dirty="0">
-                <a:solidFill>
-                  <a:srgbClr val="C2C8D2"/>
-                </a:solidFill>
-                <a:latin typeface="Arial" pitchFamily="34" charset="0"/>
-                <a:ea typeface="Arial" pitchFamily="34" charset="-122"/>
-                <a:cs typeface="Arial" pitchFamily="34" charset="-120"/>
-              </a:rPr>
-              <a:t>PER 4 WEKEN</a:t>
-            </a:r>
-            <a:endParaRPr lang="en-US" sz="800" dirty="0"/>
-          </a:p>
-        </p:txBody>
-      </p:sp>
-      <p:sp>
-        <p:nvSpPr>
-          <p:cNvPr id="11" name="Text 9"/>
-          <p:cNvSpPr txBox="1"/>
-          <p:nvPr/>
-        </p:nvSpPr>
-        <p:spPr>
-          <a:xfrm>
-            <a:off x="8737578" y="2666993"/>
-            <a:ext cx="2539994" cy="469899"/>
-          </a:xfrm>
-          <a:prstGeom prst="rect">
-            <a:avLst/>
-          </a:prstGeom>
-          <a:noFill/>
-          <a:ln/>
-        </p:spPr>
-        <p:txBody>
-          <a:bodyPr wrap="square" lIns="0" tIns="0" rIns="0" bIns="0" rtlCol="0" anchor="ctr"/>
-          <a:lstStyle/>
-          <a:p>
-            <a:pPr indent="0" marL="0">
-              <a:buNone/>
-            </a:pPr>
-            <a:r>
-              <a:rPr lang="en-US" sz="800" b="1" spc="160" kern="0" dirty="0">
-                <a:solidFill>
-                  <a:srgbClr val="C2C8D2"/>
-                </a:solidFill>
-                <a:latin typeface="Arial" pitchFamily="34" charset="0"/>
-                <a:ea typeface="Arial" pitchFamily="34" charset="-122"/>
-                <a:cs typeface="Arial" pitchFamily="34" charset="-120"/>
-              </a:rPr>
-              <a:t>VERWACHTE LEADS</a:t>
-            </a:r>
-            <a:endParaRPr lang="en-US" sz="800" dirty="0"/>
-          </a:p>
-        </p:txBody>
-      </p:sp>
-      <p:sp>
-        <p:nvSpPr>
-          <p:cNvPr id="12" name="Shape 10"/>
-          <p:cNvSpPr/>
-          <p:nvPr/>
-        </p:nvSpPr>
-        <p:spPr>
-          <a:xfrm>
-            <a:off x="609598" y="3136892"/>
-            <a:ext cx="10972773" cy="0"/>
-          </a:xfrm>
-          <a:prstGeom prst="line">
-            <a:avLst/>
-          </a:prstGeom>
-          <a:noFill/>
-          <a:ln w="9525">
-            <a:solidFill>
-              <a:srgbClr val="3A4152"/>
-            </a:solidFill>
-            <a:prstDash val="solid"/>
-          </a:ln>
-        </p:spPr>
-      </p:sp>
-      <p:sp>
-        <p:nvSpPr>
-          <p:cNvPr id="13" name="Text 11"/>
-          <p:cNvSpPr txBox="1"/>
-          <p:nvPr/>
-        </p:nvSpPr>
-        <p:spPr>
-          <a:xfrm>
-            <a:off x="888998" y="3136892"/>
-            <a:ext cx="2920993" cy="628648"/>
-          </a:xfrm>
-          <a:prstGeom prst="rect">
-            <a:avLst/>
-          </a:prstGeom>
-          <a:noFill/>
-          <a:ln/>
-        </p:spPr>
-        <p:txBody>
-          <a:bodyPr wrap="square" lIns="0" tIns="0" rIns="0" bIns="0" rtlCol="0" anchor="ctr"/>
-          <a:lstStyle/>
-          <a:p>
-            <a:pPr indent="0" marL="0">
-              <a:buNone/>
-            </a:pPr>
-            <a:r>
-              <a:rPr lang="en-US" sz="1250" b="1" dirty="0">
-                <a:solidFill>
-                  <a:srgbClr val="F2EFE6"/>
-                </a:solidFill>
-                <a:latin typeface="Arial" pitchFamily="34" charset="0"/>
-                <a:ea typeface="Arial" pitchFamily="34" charset="-122"/>
-                <a:cs typeface="Arial" pitchFamily="34" charset="-120"/>
-              </a:rPr>
-              <a:t>4 beldagen</a:t>
-            </a:r>
-            <a:endParaRPr lang="en-US" sz="1250" dirty="0"/>
-          </a:p>
-        </p:txBody>
-      </p:sp>
-      <p:sp>
-        <p:nvSpPr>
-          <p:cNvPr id="14" name="Text 12"/>
-          <p:cNvSpPr txBox="1"/>
-          <p:nvPr/>
-        </p:nvSpPr>
-        <p:spPr>
-          <a:xfrm>
-            <a:off x="3886190" y="3136892"/>
-            <a:ext cx="2349494" cy="628648"/>
-          </a:xfrm>
-          <a:prstGeom prst="rect">
-            <a:avLst/>
-          </a:prstGeom>
-          <a:noFill/>
-          <a:ln/>
-        </p:spPr>
-        <p:txBody>
-          <a:bodyPr wrap="square" lIns="0" tIns="0" rIns="0" bIns="0" rtlCol="0" anchor="ctr"/>
-          <a:lstStyle/>
-          <a:p>
-            <a:pPr indent="0" marL="0">
-              <a:buNone/>
-            </a:pPr>
-            <a:r>
-              <a:rPr lang="en-US" sz="1250" b="1" dirty="0">
-                <a:solidFill>
-                  <a:srgbClr val="F2EFE6"/>
-                </a:solidFill>
-                <a:latin typeface="Arial" pitchFamily="34" charset="0"/>
-                <a:ea typeface="Arial" pitchFamily="34" charset="-122"/>
-                <a:cs typeface="Arial" pitchFamily="34" charset="-120"/>
-              </a:rPr>
-              <a:t>€ 600</a:t>
-            </a:r>
-            <a:endParaRPr lang="en-US" sz="1250" dirty="0"/>
-          </a:p>
-        </p:txBody>
-      </p:sp>
-      <p:sp>
-        <p:nvSpPr>
-          <p:cNvPr id="15" name="Text 13"/>
-          <p:cNvSpPr txBox="1"/>
-          <p:nvPr/>
-        </p:nvSpPr>
-        <p:spPr>
-          <a:xfrm>
-            <a:off x="6324584" y="3136892"/>
-            <a:ext cx="2349494" cy="628648"/>
-          </a:xfrm>
-          <a:prstGeom prst="rect">
-            <a:avLst/>
-          </a:prstGeom>
-          <a:noFill/>
-          <a:ln/>
-        </p:spPr>
-        <p:txBody>
-          <a:bodyPr wrap="square" lIns="0" tIns="0" rIns="0" bIns="0" rtlCol="0" anchor="ctr"/>
-          <a:lstStyle/>
-          <a:p>
-            <a:pPr indent="0" marL="0">
-              <a:buNone/>
-            </a:pPr>
-            <a:r>
-              <a:rPr lang="en-US" sz="1250" b="1" dirty="0">
-                <a:solidFill>
-                  <a:srgbClr val="F2EFE6"/>
-                </a:solidFill>
-                <a:latin typeface="Arial" pitchFamily="34" charset="0"/>
-                <a:ea typeface="Arial" pitchFamily="34" charset="-122"/>
-                <a:cs typeface="Arial" pitchFamily="34" charset="-120"/>
-              </a:rPr>
-              <a:t>€ 2.400</a:t>
-            </a:r>
-            <a:endParaRPr lang="en-US" sz="1250" dirty="0"/>
-          </a:p>
-        </p:txBody>
-      </p:sp>
-      <p:sp>
-        <p:nvSpPr>
-          <p:cNvPr id="16" name="Text 14"/>
-          <p:cNvSpPr txBox="1"/>
-          <p:nvPr/>
-        </p:nvSpPr>
-        <p:spPr>
-          <a:xfrm>
-            <a:off x="8737578" y="3136892"/>
-            <a:ext cx="2539994" cy="628648"/>
-          </a:xfrm>
-          <a:prstGeom prst="rect">
-            <a:avLst/>
-          </a:prstGeom>
-          <a:noFill/>
-          <a:ln/>
-        </p:spPr>
-        <p:txBody>
-          <a:bodyPr wrap="square" lIns="0" tIns="0" rIns="0" bIns="0" rtlCol="0" anchor="ctr"/>
-          <a:lstStyle/>
-          <a:p>
-            <a:pPr indent="0" marL="0">
-              <a:buNone/>
-            </a:pPr>
-            <a:r>
-              <a:rPr lang="en-US" sz="1250" b="1" dirty="0">
-                <a:solidFill>
-                  <a:srgbClr val="F2EFE6"/>
-                </a:solidFill>
-                <a:latin typeface="Arial" pitchFamily="34" charset="0"/>
-                <a:ea typeface="Arial" pitchFamily="34" charset="-122"/>
-                <a:cs typeface="Arial" pitchFamily="34" charset="-120"/>
-              </a:rPr>
-              <a:t>± 10 leads</a:t>
-            </a:r>
-            <a:endParaRPr lang="en-US" sz="1250" dirty="0"/>
-          </a:p>
-        </p:txBody>
-      </p:sp>
-      <p:sp>
-        <p:nvSpPr>
-          <p:cNvPr id="17" name="Shape 15"/>
-          <p:cNvSpPr/>
-          <p:nvPr/>
-        </p:nvSpPr>
-        <p:spPr>
-          <a:xfrm>
-            <a:off x="609598" y="3765541"/>
-            <a:ext cx="10972773" cy="0"/>
-          </a:xfrm>
-          <a:prstGeom prst="line">
-            <a:avLst/>
-          </a:prstGeom>
-          <a:noFill/>
-          <a:ln w="9525">
-            <a:solidFill>
-              <a:srgbClr val="3A4152"/>
-            </a:solidFill>
-            <a:prstDash val="solid"/>
-          </a:ln>
-        </p:spPr>
-      </p:sp>
-      <p:sp>
-        <p:nvSpPr>
-          <p:cNvPr id="18" name="Text 16"/>
-          <p:cNvSpPr txBox="1"/>
-          <p:nvPr/>
-        </p:nvSpPr>
-        <p:spPr>
-          <a:xfrm>
-            <a:off x="888998" y="3765541"/>
-            <a:ext cx="2920993" cy="628648"/>
-          </a:xfrm>
-          <a:prstGeom prst="rect">
-            <a:avLst/>
-          </a:prstGeom>
-          <a:noFill/>
-          <a:ln/>
-        </p:spPr>
-        <p:txBody>
-          <a:bodyPr wrap="square" lIns="0" tIns="0" rIns="0" bIns="0" rtlCol="0" anchor="ctr"/>
-          <a:lstStyle/>
-          <a:p>
-            <a:pPr indent="0" marL="0">
-              <a:buNone/>
-            </a:pPr>
-            <a:r>
-              <a:rPr lang="en-US" sz="1250" b="1" dirty="0">
-                <a:solidFill>
-                  <a:srgbClr val="F2EFE6"/>
-                </a:solidFill>
-                <a:latin typeface="Arial" pitchFamily="34" charset="0"/>
-                <a:ea typeface="Arial" pitchFamily="34" charset="-122"/>
-                <a:cs typeface="Arial" pitchFamily="34" charset="-120"/>
-              </a:rPr>
-              <a:t>5 tot 7 beldagen</a:t>
-            </a:r>
-            <a:endParaRPr lang="en-US" sz="1250" dirty="0"/>
-          </a:p>
-        </p:txBody>
-      </p:sp>
-      <p:sp>
-        <p:nvSpPr>
-          <p:cNvPr id="19" name="Text 17"/>
-          <p:cNvSpPr txBox="1"/>
-          <p:nvPr/>
-        </p:nvSpPr>
-        <p:spPr>
-          <a:xfrm>
-            <a:off x="3886190" y="3765541"/>
-            <a:ext cx="2349494" cy="628648"/>
-          </a:xfrm>
-          <a:prstGeom prst="rect">
-            <a:avLst/>
-          </a:prstGeom>
-          <a:noFill/>
-          <a:ln/>
-        </p:spPr>
-        <p:txBody>
-          <a:bodyPr wrap="square" lIns="0" tIns="0" rIns="0" bIns="0" rtlCol="0" anchor="ctr"/>
-          <a:lstStyle/>
-          <a:p>
-            <a:pPr indent="0" marL="0">
-              <a:buNone/>
-            </a:pPr>
-            <a:r>
-              <a:rPr lang="en-US" sz="1250" b="1" dirty="0">
-                <a:solidFill>
-                  <a:srgbClr val="F2EFE6"/>
-                </a:solidFill>
-                <a:latin typeface="Arial" pitchFamily="34" charset="0"/>
-                <a:ea typeface="Arial" pitchFamily="34" charset="-122"/>
-                <a:cs typeface="Arial" pitchFamily="34" charset="-120"/>
-              </a:rPr>
-              <a:t>€ 550</a:t>
-            </a:r>
-            <a:endParaRPr lang="en-US" sz="1250" dirty="0"/>
-          </a:p>
-        </p:txBody>
-      </p:sp>
-      <p:sp>
-        <p:nvSpPr>
-          <p:cNvPr id="20" name="Text 18"/>
-          <p:cNvSpPr txBox="1"/>
-          <p:nvPr/>
-        </p:nvSpPr>
-        <p:spPr>
-          <a:xfrm>
-            <a:off x="6324584" y="3765541"/>
-            <a:ext cx="2349494" cy="628648"/>
-          </a:xfrm>
-          <a:prstGeom prst="rect">
-            <a:avLst/>
-          </a:prstGeom>
-          <a:noFill/>
-          <a:ln/>
-        </p:spPr>
-        <p:txBody>
-          <a:bodyPr wrap="square" lIns="0" tIns="0" rIns="0" bIns="0" rtlCol="0" anchor="ctr"/>
-          <a:lstStyle/>
-          <a:p>
-            <a:pPr indent="0" marL="0">
-              <a:buNone/>
-            </a:pPr>
-            <a:r>
-              <a:rPr lang="en-US" sz="1250" b="1" dirty="0">
-                <a:solidFill>
-                  <a:srgbClr val="F2EFE6"/>
-                </a:solidFill>
-                <a:latin typeface="Arial" pitchFamily="34" charset="0"/>
-                <a:ea typeface="Arial" pitchFamily="34" charset="-122"/>
-                <a:cs typeface="Arial" pitchFamily="34" charset="-120"/>
-              </a:rPr>
-              <a:t>€ 2.750 tot € 3.850</a:t>
-            </a:r>
-            <a:endParaRPr lang="en-US" sz="1250" dirty="0"/>
-          </a:p>
-        </p:txBody>
-      </p:sp>
-      <p:sp>
-        <p:nvSpPr>
-          <p:cNvPr id="21" name="Text 19"/>
-          <p:cNvSpPr txBox="1"/>
-          <p:nvPr/>
-        </p:nvSpPr>
-        <p:spPr>
-          <a:xfrm>
-            <a:off x="8737578" y="3765541"/>
-            <a:ext cx="2539994" cy="628648"/>
-          </a:xfrm>
-          <a:prstGeom prst="rect">
-            <a:avLst/>
-          </a:prstGeom>
-          <a:noFill/>
-          <a:ln/>
-        </p:spPr>
-        <p:txBody>
-          <a:bodyPr wrap="square" lIns="0" tIns="0" rIns="0" bIns="0" rtlCol="0" anchor="ctr"/>
-          <a:lstStyle/>
-          <a:p>
-            <a:pPr indent="0" marL="0">
-              <a:buNone/>
-            </a:pPr>
-            <a:r>
-              <a:rPr lang="en-US" sz="1250" b="1" dirty="0">
-                <a:solidFill>
-                  <a:srgbClr val="F2EFE6"/>
-                </a:solidFill>
-                <a:latin typeface="Arial" pitchFamily="34" charset="0"/>
-                <a:ea typeface="Arial" pitchFamily="34" charset="-122"/>
-                <a:cs typeface="Arial" pitchFamily="34" charset="-120"/>
-              </a:rPr>
-              <a:t>± 12 tot 17 leads</a:t>
-            </a:r>
-            <a:endParaRPr lang="en-US" sz="1250" dirty="0"/>
-          </a:p>
-        </p:txBody>
-      </p:sp>
-      <p:sp>
-        <p:nvSpPr>
-          <p:cNvPr id="22" name="Shape 20"/>
-          <p:cNvSpPr/>
-          <p:nvPr/>
-        </p:nvSpPr>
-        <p:spPr>
-          <a:xfrm>
-            <a:off x="615948" y="4394189"/>
-            <a:ext cx="10960073" cy="628648"/>
-          </a:xfrm>
-          <a:prstGeom prst="rect">
-            <a:avLst/>
-          </a:prstGeom>
-          <a:solidFill>
-            <a:srgbClr val="38B6FF">
-              <a:alpha val="11000"/>
-            </a:srgbClr>
-          </a:solidFill>
-          <a:ln/>
-        </p:spPr>
+              <a:t>En dat is nog maar een fractie van de markt. Er kan hier nog jaren op gebeld worden.</a:t>
+            </a:r>
+            <a:endParaRPr lang="en-US" sz="950" dirty="0"/>
+          </a:p>
+        </p:txBody>
       </p:sp>
       <p:sp>
         <p:nvSpPr>
           <p:cNvPr id="23" name="Shape 21"/>
-          <p:cNvSpPr/>
-          <p:nvPr/>
-        </p:nvSpPr>
-        <p:spPr>
-          <a:xfrm>
-            <a:off x="609598" y="4394189"/>
-            <a:ext cx="10972773" cy="0"/>
-          </a:xfrm>
-          <a:prstGeom prst="line">
-            <a:avLst/>
-          </a:prstGeom>
-          <a:noFill/>
-          <a:ln w="9525">
-            <a:solidFill>
-              <a:srgbClr val="3A4152"/>
-            </a:solidFill>
-            <a:prstDash val="solid"/>
-          </a:ln>
-        </p:spPr>
-      </p:sp>
-      <p:sp>
-        <p:nvSpPr>
-          <p:cNvPr id="24" name="Text 22"/>
-          <p:cNvSpPr txBox="1"/>
-          <p:nvPr/>
-        </p:nvSpPr>
-        <p:spPr>
-          <a:xfrm>
-            <a:off x="888998" y="4394189"/>
-            <a:ext cx="2920993" cy="628648"/>
-          </a:xfrm>
-          <a:prstGeom prst="rect">
-            <a:avLst/>
-          </a:prstGeom>
-          <a:noFill/>
-          <a:ln/>
-        </p:spPr>
-        <p:txBody>
-          <a:bodyPr wrap="square" lIns="0" tIns="0" rIns="0" bIns="0" rtlCol="0" anchor="ctr"/>
-          <a:lstStyle/>
-          <a:p>
-            <a:pPr indent="0" marL="0">
-              <a:buNone/>
-            </a:pPr>
-            <a:r>
-              <a:rPr lang="en-US" sz="1250" b="1" dirty="0">
-                <a:solidFill>
-                  <a:srgbClr val="F2EFE6"/>
-                </a:solidFill>
-                <a:latin typeface="Arial" pitchFamily="34" charset="0"/>
-                <a:ea typeface="Arial" pitchFamily="34" charset="-122"/>
-                <a:cs typeface="Arial" pitchFamily="34" charset="-120"/>
-              </a:rPr>
-              <a:t>8 beldagen of meer</a:t>
-            </a:r>
-            <a:pPr indent="0" marL="0">
-              <a:buNone/>
-            </a:pPr>
-            <a:r>
-              <a:rPr lang="en-US" sz="1000" i="1" dirty="0">
-                <a:solidFill>
-                  <a:srgbClr val="38B6FF"/>
-                </a:solidFill>
-                <a:latin typeface="Georgia" pitchFamily="34" charset="0"/>
-                <a:ea typeface="Georgia" pitchFamily="34" charset="-122"/>
-                <a:cs typeface="Georgia" pitchFamily="34" charset="-120"/>
-              </a:rPr>
-              <a:t>   ons advies</a:t>
-            </a:r>
-            <a:endParaRPr lang="en-US" sz="1250" dirty="0"/>
-          </a:p>
-        </p:txBody>
-      </p:sp>
-      <p:sp>
-        <p:nvSpPr>
-          <p:cNvPr id="25" name="Text 23"/>
-          <p:cNvSpPr txBox="1"/>
-          <p:nvPr/>
-        </p:nvSpPr>
-        <p:spPr>
-          <a:xfrm>
-            <a:off x="3886190" y="4394189"/>
-            <a:ext cx="2349494" cy="628648"/>
-          </a:xfrm>
-          <a:prstGeom prst="rect">
-            <a:avLst/>
-          </a:prstGeom>
-          <a:noFill/>
-          <a:ln/>
-        </p:spPr>
-        <p:txBody>
-          <a:bodyPr wrap="square" lIns="0" tIns="0" rIns="0" bIns="0" rtlCol="0" anchor="ctr"/>
-          <a:lstStyle/>
-          <a:p>
-            <a:pPr indent="0" marL="0">
-              <a:buNone/>
-            </a:pPr>
-            <a:r>
-              <a:rPr lang="en-US" sz="1250" b="1" dirty="0">
-                <a:solidFill>
-                  <a:srgbClr val="F2EFE6"/>
-                </a:solidFill>
-                <a:latin typeface="Arial" pitchFamily="34" charset="0"/>
-                <a:ea typeface="Arial" pitchFamily="34" charset="-122"/>
-                <a:cs typeface="Arial" pitchFamily="34" charset="-120"/>
-              </a:rPr>
-              <a:t>€ 500</a:t>
-            </a:r>
-            <a:endParaRPr lang="en-US" sz="1250" dirty="0"/>
-          </a:p>
-        </p:txBody>
-      </p:sp>
-      <p:sp>
-        <p:nvSpPr>
-          <p:cNvPr id="26" name="Text 24"/>
-          <p:cNvSpPr txBox="1"/>
-          <p:nvPr/>
-        </p:nvSpPr>
-        <p:spPr>
-          <a:xfrm>
-            <a:off x="6324584" y="4394189"/>
-            <a:ext cx="2349494" cy="628648"/>
-          </a:xfrm>
-          <a:prstGeom prst="rect">
-            <a:avLst/>
-          </a:prstGeom>
-          <a:noFill/>
-          <a:ln/>
-        </p:spPr>
-        <p:txBody>
-          <a:bodyPr wrap="square" lIns="0" tIns="0" rIns="0" bIns="0" rtlCol="0" anchor="ctr"/>
-          <a:lstStyle/>
-          <a:p>
-            <a:pPr indent="0" marL="0">
-              <a:buNone/>
-            </a:pPr>
-            <a:r>
-              <a:rPr lang="en-US" sz="1250" b="1" dirty="0">
-                <a:solidFill>
-                  <a:srgbClr val="F2EFE6"/>
-                </a:solidFill>
-                <a:latin typeface="Arial" pitchFamily="34" charset="0"/>
-                <a:ea typeface="Arial" pitchFamily="34" charset="-122"/>
-                <a:cs typeface="Arial" pitchFamily="34" charset="-120"/>
-              </a:rPr>
-              <a:t>vanaf € 4.000</a:t>
-            </a:r>
-            <a:endParaRPr lang="en-US" sz="1250" dirty="0"/>
-          </a:p>
-        </p:txBody>
-      </p:sp>
-      <p:sp>
-        <p:nvSpPr>
-          <p:cNvPr id="27" name="Text 25"/>
-          <p:cNvSpPr txBox="1"/>
-          <p:nvPr/>
-        </p:nvSpPr>
-        <p:spPr>
-          <a:xfrm>
-            <a:off x="8737578" y="4394189"/>
-            <a:ext cx="2539994" cy="628648"/>
-          </a:xfrm>
-          <a:prstGeom prst="rect">
-            <a:avLst/>
-          </a:prstGeom>
-          <a:noFill/>
-          <a:ln/>
-        </p:spPr>
-        <p:txBody>
-          <a:bodyPr wrap="square" lIns="0" tIns="0" rIns="0" bIns="0" rtlCol="0" anchor="ctr"/>
-          <a:lstStyle/>
-          <a:p>
-            <a:pPr indent="0" marL="0">
-              <a:buNone/>
-            </a:pPr>
-            <a:r>
-              <a:rPr lang="en-US" sz="1250" b="1" dirty="0">
-                <a:solidFill>
-                  <a:srgbClr val="F2EFE6"/>
-                </a:solidFill>
-                <a:latin typeface="Arial" pitchFamily="34" charset="0"/>
-                <a:ea typeface="Arial" pitchFamily="34" charset="-122"/>
-                <a:cs typeface="Arial" pitchFamily="34" charset="-120"/>
-              </a:rPr>
-              <a:t>vanaf ± 19 leads</a:t>
-            </a:r>
-            <a:endParaRPr lang="en-US" sz="1250" dirty="0"/>
-          </a:p>
-        </p:txBody>
-      </p:sp>
-      <p:sp>
-        <p:nvSpPr>
-          <p:cNvPr id="28" name="Shape 26"/>
           <p:cNvSpPr/>
           <p:nvPr/>
         </p:nvSpPr>
@@ -15022,14 +16016,14 @@
       </p:sp>
       <p:sp>
         <p:nvSpPr>
-          <p:cNvPr id="29" name="Text 27"/>
-          <p:cNvSpPr txBox="1"/>
-          <p:nvPr/>
-        </p:nvSpPr>
-        <p:spPr>
-          <a:xfrm>
-            <a:off x="800098" y="5651486"/>
-            <a:ext cx="9905975" cy="482599"/>
+          <p:cNvPr id="24" name="Text 22"/>
+          <p:cNvSpPr txBox="1"/>
+          <p:nvPr/>
+        </p:nvSpPr>
+        <p:spPr>
+          <a:xfrm>
+            <a:off x="800098" y="5714986"/>
+            <a:ext cx="9905975" cy="355599"/>
           </a:xfrm>
           <a:prstGeom prst="rect">
             <a:avLst/>
@@ -15047,13 +16041,13 @@
             <a:r>
               <a:rPr lang="en-US" sz="1200" b="1" dirty="0">
                 <a:solidFill>
-                  <a:srgbClr val="F2EFE6"/>
-                </a:solidFill>
-                <a:latin typeface="Arial" pitchFamily="34" charset="0"/>
-                <a:ea typeface="Arial" pitchFamily="34" charset="-122"/>
-                <a:cs typeface="Arial" pitchFamily="34" charset="-120"/>
-              </a:rPr>
-              <a:t>Gerekend met 2,4 gekwalificeerde leads per beldag, het gemiddelde over negentien weken Moyee. Daarvan is er gemiddeld één per beldag een tasting. Minimaal vier beldagen per periode, prijzen excl. btw.</a:t>
+                  <a:srgbClr val="1C2230"/>
+                </a:solidFill>
+                <a:latin typeface="Arial" pitchFamily="34" charset="0"/>
+                <a:ea typeface="Arial" pitchFamily="34" charset="-122"/>
+                <a:cs typeface="Arial" pitchFamily="34" charset="-120"/>
+              </a:rPr>
+              <a:t>Elke periode die we bellen groeit deze lijst mee. Opschalen betekent dus ook sneller terug bij de bedrijven die er al in zitten.</a:t>
             </a:r>
             <a:endParaRPr lang="en-US" sz="1200" dirty="0"/>
           </a:p>

</xml_diff>

<commit_message>
Moyee: verwachte aantallen als indicatie, beldagnorm niet meer als belofte
Co-Authored-By: Claude Opus 5 <noreply@anthropic.com>
Claude-Session: https://claude.ai/code/session_0141FN3f3hHkYQHTyvTJJGrw
</commit_message>
<xml_diff>
--- a/output/LINK. voorstel Moyee Coffee.pptx
+++ b/output/LINK. voorstel Moyee Coffee.pptx
@@ -4120,7 +4120,7 @@
                 <a:ea typeface="Arial" pitchFamily="34" charset="-122"/>
                 <a:cs typeface="Arial" pitchFamily="34" charset="-120"/>
               </a:rPr>
-              <a:t>Een beldag is minimaal 100 gesprekspogingen. Bij 23,2 leads per duizend pogingen, het cijfer over 2.629 gesprekken voor Moyee, komt dat neer op 2,3 leads per beldag. Minimaal vier beldagen per periode, prijzen excl. btw.</a:t>
+              <a:t>De aantallen zijn een indicatie, gebaseerd op 23,2 gekwalificeerde leads per duizend gesprekspogingen over 2.629 gesprekken voor Moyee, bij ongeveer 100 pogingen per beldag. Minimaal vier beldagen per periode, prijzen excl. btw.</a:t>
             </a:r>
             <a:endParaRPr lang="en-US" sz="1200" dirty="0"/>
           </a:p>
@@ -5158,7 +5158,7 @@
                 <a:ea typeface="Arial" pitchFamily="34" charset="-122"/>
                 <a:cs typeface="Arial" pitchFamily="34" charset="-120"/>
               </a:rPr>
-              <a:t>800</a:t>
+              <a:t>± 800</a:t>
             </a:r>
             <a:endParaRPr lang="en-US" sz="1350" dirty="0"/>
           </a:p>

</xml_diff>

<commit_message>
Moyee: opschalen naar de voorgrond, advieslabel eruit
- staffel zonder ons advies, band loopt door tot twaalf beldagen
- vergelijking wordt driekoloms: nu, twee keer, drie keer
- compare-renderer in template en pptx ondersteunt meerdere kolommen

Co-Authored-By: Claude Opus 5 <noreply@anthropic.com>
Claude-Session: https://claude.ai/code/session_0141FN3f3hHkYQHTyvTJJGrw
</commit_message>
<xml_diff>
--- a/output/LINK. voorstel Moyee Coffee.pptx
+++ b/output/LINK. voorstel Moyee Coffee.pptx
@@ -3860,28 +3860,6 @@
         </p:nvSpPr>
         <p:spPr>
           <a:xfrm>
-            <a:off x="615948" y="4394189"/>
-            <a:ext cx="10960073" cy="628648"/>
-          </a:xfrm>
-          <a:prstGeom prst="rect">
-            <a:avLst/>
-          </a:prstGeom>
-          <a:solidFill>
-            <a:srgbClr val="38B6FF">
-              <a:alpha val="11000"/>
-            </a:srgbClr>
-          </a:solidFill>
-          <a:ln/>
-        </p:spPr>
-      </p:sp>
-      <p:sp>
-        <p:nvSpPr>
-          <p:cNvPr id="23" name="Shape 21"/>
-          <p:cNvSpPr/>
-          <p:nvPr/>
-        </p:nvSpPr>
-        <p:spPr>
-          <a:xfrm>
             <a:off x="609598" y="4394189"/>
             <a:ext cx="10972773" cy="0"/>
           </a:xfrm>
@@ -3899,7 +3877,7 @@
       </p:sp>
       <p:sp>
         <p:nvSpPr>
-          <p:cNvPr id="24" name="Text 22"/>
+          <p:cNvPr id="23" name="Text 21"/>
           <p:cNvSpPr txBox="1"/>
           <p:nvPr/>
         </p:nvSpPr>
@@ -3930,21 +3908,7 @@
                 <a:ea typeface="Arial" pitchFamily="34" charset="-122"/>
                 <a:cs typeface="Arial" pitchFamily="34" charset="-120"/>
               </a:rPr>
-              <a:t>8 beldagen of meer</a:t>
-            </a:r>
-            <a:pPr indent="0" marL="0">
-              <a:buNone/>
-            </a:pPr>
-            <a:r>
-              <a:rPr lang="en-US" sz="1000" i="1" dirty="0">
-                <a:solidFill>
-                  <a:srgbClr val="38B6FF"/>
-                </a:solidFill>
-                <a:latin typeface="Georgia" pitchFamily="34" charset="0"/>
-                <a:ea typeface="Georgia" pitchFamily="34" charset="-122"/>
-                <a:cs typeface="Georgia" pitchFamily="34" charset="-120"/>
-              </a:rPr>
-              <a:t>   ons advies</a:t>
+              <a:t>8 tot 12 beldagen</a:t>
             </a:r>
             <a:endParaRPr lang="en-US" sz="1250" dirty="0"/>
           </a:p>
@@ -3952,7 +3916,7 @@
       </p:sp>
       <p:sp>
         <p:nvSpPr>
-          <p:cNvPr id="25" name="Text 23"/>
+          <p:cNvPr id="24" name="Text 22"/>
           <p:cNvSpPr txBox="1"/>
           <p:nvPr/>
         </p:nvSpPr>
@@ -3991,7 +3955,7 @@
       </p:sp>
       <p:sp>
         <p:nvSpPr>
-          <p:cNvPr id="26" name="Text 24"/>
+          <p:cNvPr id="25" name="Text 23"/>
           <p:cNvSpPr txBox="1"/>
           <p:nvPr/>
         </p:nvSpPr>
@@ -4022,7 +3986,7 @@
                 <a:ea typeface="Arial" pitchFamily="34" charset="-122"/>
                 <a:cs typeface="Arial" pitchFamily="34" charset="-120"/>
               </a:rPr>
-              <a:t>vanaf € 4.000</a:t>
+              <a:t>€ 4.000 tot € 6.000</a:t>
             </a:r>
             <a:endParaRPr lang="en-US" sz="1250" dirty="0"/>
           </a:p>
@@ -4030,7 +3994,7 @@
       </p:sp>
       <p:sp>
         <p:nvSpPr>
-          <p:cNvPr id="27" name="Text 25"/>
+          <p:cNvPr id="26" name="Text 24"/>
           <p:cNvSpPr txBox="1"/>
           <p:nvPr/>
         </p:nvSpPr>
@@ -4061,7 +4025,7 @@
                 <a:ea typeface="Arial" pitchFamily="34" charset="-122"/>
                 <a:cs typeface="Arial" pitchFamily="34" charset="-120"/>
               </a:rPr>
-              <a:t>vanaf ± 19 leads</a:t>
+              <a:t>± 19 tot 28 leads</a:t>
             </a:r>
             <a:endParaRPr lang="en-US" sz="1250" dirty="0"/>
           </a:p>
@@ -4069,7 +4033,7 @@
       </p:sp>
       <p:sp>
         <p:nvSpPr>
-          <p:cNvPr id="28" name="Shape 26"/>
+          <p:cNvPr id="27" name="Shape 25"/>
           <p:cNvSpPr/>
           <p:nvPr/>
         </p:nvSpPr>
@@ -4089,7 +4053,7 @@
       </p:sp>
       <p:sp>
         <p:nvSpPr>
-          <p:cNvPr id="29" name="Text 27"/>
+          <p:cNvPr id="28" name="Text 26"/>
           <p:cNvSpPr txBox="1"/>
           <p:nvPr/>
         </p:nvSpPr>
@@ -4322,7 +4286,7 @@
                 <a:ea typeface="Arial" pitchFamily="34" charset="-122"/>
                 <a:cs typeface="Arial" pitchFamily="34" charset="-120"/>
               </a:rPr>
-              <a:t>WAT DIT VOOR JULLIE BETEKENT</a:t>
+              <a:t>OPSCHALEN</a:t>
             </a:r>
             <a:endParaRPr lang="en-US" sz="950" dirty="0"/>
           </a:p>
@@ -4364,7 +4328,7 @@
                 <a:ea typeface="Arial" pitchFamily="34" charset="-122"/>
                 <a:cs typeface="Arial" pitchFamily="34" charset="-120"/>
               </a:rPr>
-              <a:t>Bijna twee keer zoveel gesprekken, voor </a:t>
+              <a:t>Twee keer zoveel kan nu al. </a:t>
             </a:r>
             <a:pPr algn="l" indent="0" marL="0">
               <a:lnSpc>
@@ -4381,7 +4345,7 @@
                 <a:ea typeface="Georgia" pitchFamily="34" charset="-122"/>
                 <a:cs typeface="Georgia" pitchFamily="34" charset="-120"/>
               </a:rPr>
-              <a:t>dezelfde prijs</a:t>
+              <a:t>Drie keer</a:t>
             </a:r>
             <a:pPr algn="l" indent="0" marL="0">
               <a:lnSpc>
@@ -4398,7 +4362,7 @@
                 <a:ea typeface="Arial" pitchFamily="34" charset="-122"/>
                 <a:cs typeface="Arial" pitchFamily="34" charset="-120"/>
               </a:rPr>
-              <a:t> per lead.</a:t>
+              <a:t> ook.</a:t>
             </a:r>
             <a:endParaRPr lang="en-US" sz="3200" dirty="0"/>
           </a:p>
@@ -4413,7 +4377,7 @@
         <p:spPr>
           <a:xfrm>
             <a:off x="609598" y="2489194"/>
-            <a:ext cx="5384787" cy="2768593"/>
+            <a:ext cx="3555991" cy="2768593"/>
           </a:xfrm>
           <a:prstGeom prst="roundRect">
             <a:avLst>
@@ -4434,8 +4398,8 @@
         </p:nvSpPr>
         <p:spPr>
           <a:xfrm>
-            <a:off x="939798" y="2768593"/>
-            <a:ext cx="4724388" cy="190500"/>
+            <a:off x="825498" y="2743193"/>
+            <a:ext cx="3124192" cy="190500"/>
           </a:xfrm>
           <a:prstGeom prst="rect">
             <a:avLst/>
@@ -4459,7 +4423,7 @@
                 <a:ea typeface="Arial" pitchFamily="34" charset="-122"/>
                 <a:cs typeface="Arial" pitchFamily="34" charset="-120"/>
               </a:rPr>
-              <a:t>NU · ± 4,1 BELDAGEN</a:t>
+              <a:t>NU</a:t>
             </a:r>
             <a:endParaRPr lang="en-US" sz="800" dirty="0"/>
           </a:p>
@@ -4473,8 +4437,8 @@
         </p:nvSpPr>
         <p:spPr>
           <a:xfrm>
-            <a:off x="939798" y="2984493"/>
-            <a:ext cx="4724388" cy="330199"/>
+            <a:off x="825498" y="2959093"/>
+            <a:ext cx="3124192" cy="355599"/>
           </a:xfrm>
           <a:prstGeom prst="rect">
             <a:avLst/>
@@ -4487,10 +4451,13 @@
           <a:lstStyle/>
           <a:p>
             <a:pPr indent="0" marL="0">
-              <a:buNone/>
-            </a:pPr>
-            <a:r>
-              <a:rPr lang="en-US" sz="1500" b="1" dirty="0">
+              <a:lnSpc>
+                <a:spcPct val="115000"/>
+              </a:lnSpc>
+              <a:buNone/>
+            </a:pPr>
+            <a:r>
+              <a:rPr lang="en-US" sz="1250" b="1" dirty="0">
                 <a:solidFill>
                   <a:srgbClr val="1C2230"/>
                 </a:solidFill>
@@ -4500,7 +4467,7 @@
               </a:rPr>
               <a:t>€ 1.500 per maand plus € 150 per tasting</a:t>
             </a:r>
-            <a:endParaRPr lang="en-US" sz="1500" dirty="0"/>
+            <a:endParaRPr lang="en-US" sz="1250" dirty="0"/>
           </a:p>
         </p:txBody>
       </p:sp>
@@ -4512,8 +4479,8 @@
         </p:nvSpPr>
         <p:spPr>
           <a:xfrm>
-            <a:off x="939798" y="3378192"/>
-            <a:ext cx="3479791" cy="419099"/>
+            <a:off x="825498" y="3378192"/>
+            <a:ext cx="2578094" cy="406399"/>
           </a:xfrm>
           <a:prstGeom prst="rect">
             <a:avLst/>
@@ -4529,7 +4496,7 @@
               <a:buNone/>
             </a:pPr>
             <a:r>
-              <a:rPr lang="en-US" sz="1100" dirty="0">
+              <a:rPr lang="en-US" sz="950" dirty="0">
                 <a:solidFill>
                   <a:srgbClr val="6F6A5C"/>
                 </a:solidFill>
@@ -4539,7 +4506,7 @@
               </a:rPr>
               <a:t>Kosten per 4 weken</a:t>
             </a:r>
-            <a:endParaRPr lang="en-US" sz="1100" dirty="0"/>
+            <a:endParaRPr lang="en-US" sz="950" dirty="0"/>
           </a:p>
         </p:txBody>
       </p:sp>
@@ -4551,8 +4518,8 @@
         </p:nvSpPr>
         <p:spPr>
           <a:xfrm>
-            <a:off x="4419589" y="3378192"/>
-            <a:ext cx="1244597" cy="419099"/>
+            <a:off x="3124192" y="3378192"/>
+            <a:ext cx="825498" cy="406399"/>
           </a:xfrm>
           <a:prstGeom prst="rect">
             <a:avLst/>
@@ -4568,7 +4535,7 @@
               <a:buNone/>
             </a:pPr>
             <a:r>
-              <a:rPr lang="en-US" sz="1350" b="1" dirty="0">
+              <a:rPr lang="en-US" sz="1150" b="1" dirty="0">
                 <a:solidFill>
                   <a:srgbClr val="1C2230"/>
                 </a:solidFill>
@@ -4578,7 +4545,7 @@
               </a:rPr>
               <a:t>± € 2.040</a:t>
             </a:r>
-            <a:endParaRPr lang="en-US" sz="1350" dirty="0"/>
+            <a:endParaRPr lang="en-US" sz="1150" dirty="0"/>
           </a:p>
         </p:txBody>
       </p:sp>
@@ -4590,8 +4557,8 @@
         </p:nvSpPr>
         <p:spPr>
           <a:xfrm>
-            <a:off x="939798" y="3797291"/>
-            <a:ext cx="4724388" cy="0"/>
+            <a:off x="825498" y="3784591"/>
+            <a:ext cx="3124192" cy="0"/>
           </a:xfrm>
           <a:prstGeom prst="line">
             <a:avLst/>
@@ -4613,8 +4580,8 @@
         </p:nvSpPr>
         <p:spPr>
           <a:xfrm>
-            <a:off x="939798" y="3797291"/>
-            <a:ext cx="3479791" cy="419099"/>
+            <a:off x="825498" y="3784591"/>
+            <a:ext cx="2578094" cy="406399"/>
           </a:xfrm>
           <a:prstGeom prst="rect">
             <a:avLst/>
@@ -4630,7 +4597,7 @@
               <a:buNone/>
             </a:pPr>
             <a:r>
-              <a:rPr lang="en-US" sz="1100" dirty="0">
+              <a:rPr lang="en-US" sz="950" dirty="0">
                 <a:solidFill>
                   <a:srgbClr val="6F6A5C"/>
                 </a:solidFill>
@@ -4640,7 +4607,7 @@
               </a:rPr>
               <a:t>Gesprekspogingen</a:t>
             </a:r>
-            <a:endParaRPr lang="en-US" sz="1100" dirty="0"/>
+            <a:endParaRPr lang="en-US" sz="950" dirty="0"/>
           </a:p>
         </p:txBody>
       </p:sp>
@@ -4652,8 +4619,8 @@
         </p:nvSpPr>
         <p:spPr>
           <a:xfrm>
-            <a:off x="4419589" y="3797291"/>
-            <a:ext cx="1244597" cy="419099"/>
+            <a:off x="3124192" y="3784591"/>
+            <a:ext cx="825498" cy="406399"/>
           </a:xfrm>
           <a:prstGeom prst="rect">
             <a:avLst/>
@@ -4669,7 +4636,7 @@
               <a:buNone/>
             </a:pPr>
             <a:r>
-              <a:rPr lang="en-US" sz="1350" b="1" dirty="0">
+              <a:rPr lang="en-US" sz="1150" b="1" dirty="0">
                 <a:solidFill>
                   <a:srgbClr val="1C2230"/>
                 </a:solidFill>
@@ -4679,7 +4646,7 @@
               </a:rPr>
               <a:t>± 414</a:t>
             </a:r>
-            <a:endParaRPr lang="en-US" sz="1350" dirty="0"/>
+            <a:endParaRPr lang="en-US" sz="1150" dirty="0"/>
           </a:p>
         </p:txBody>
       </p:sp>
@@ -4691,8 +4658,8 @@
         </p:nvSpPr>
         <p:spPr>
           <a:xfrm>
-            <a:off x="939798" y="4216389"/>
-            <a:ext cx="4724388" cy="0"/>
+            <a:off x="825498" y="4190990"/>
+            <a:ext cx="3124192" cy="0"/>
           </a:xfrm>
           <a:prstGeom prst="line">
             <a:avLst/>
@@ -4714,8 +4681,8 @@
         </p:nvSpPr>
         <p:spPr>
           <a:xfrm>
-            <a:off x="939798" y="4216389"/>
-            <a:ext cx="3479791" cy="419099"/>
+            <a:off x="825498" y="4190990"/>
+            <a:ext cx="2578094" cy="406399"/>
           </a:xfrm>
           <a:prstGeom prst="rect">
             <a:avLst/>
@@ -4731,7 +4698,7 @@
               <a:buNone/>
             </a:pPr>
             <a:r>
-              <a:rPr lang="en-US" sz="1100" dirty="0">
+              <a:rPr lang="en-US" sz="950" dirty="0">
                 <a:solidFill>
                   <a:srgbClr val="6F6A5C"/>
                 </a:solidFill>
@@ -4741,7 +4708,7 @@
               </a:rPr>
               <a:t>Verwachte leads</a:t>
             </a:r>
-            <a:endParaRPr lang="en-US" sz="1100" dirty="0"/>
+            <a:endParaRPr lang="en-US" sz="950" dirty="0"/>
           </a:p>
         </p:txBody>
       </p:sp>
@@ -4753,8 +4720,8 @@
         </p:nvSpPr>
         <p:spPr>
           <a:xfrm>
-            <a:off x="4419589" y="4216389"/>
-            <a:ext cx="1244597" cy="419099"/>
+            <a:off x="3124192" y="4190990"/>
+            <a:ext cx="825498" cy="406399"/>
           </a:xfrm>
           <a:prstGeom prst="rect">
             <a:avLst/>
@@ -4770,7 +4737,7 @@
               <a:buNone/>
             </a:pPr>
             <a:r>
-              <a:rPr lang="en-US" sz="1350" b="1" dirty="0">
+              <a:rPr lang="en-US" sz="1150" b="1" dirty="0">
                 <a:solidFill>
                   <a:srgbClr val="1C2230"/>
                 </a:solidFill>
@@ -4780,7 +4747,7 @@
               </a:rPr>
               <a:t>± 10</a:t>
             </a:r>
-            <a:endParaRPr lang="en-US" sz="1350" dirty="0"/>
+            <a:endParaRPr lang="en-US" sz="1150" dirty="0"/>
           </a:p>
         </p:txBody>
       </p:sp>
@@ -4792,8 +4759,8 @@
         </p:nvSpPr>
         <p:spPr>
           <a:xfrm>
-            <a:off x="939798" y="4635488"/>
-            <a:ext cx="4724388" cy="0"/>
+            <a:off x="825498" y="4597389"/>
+            <a:ext cx="3124192" cy="0"/>
           </a:xfrm>
           <a:prstGeom prst="line">
             <a:avLst/>
@@ -4815,8 +4782,8 @@
         </p:nvSpPr>
         <p:spPr>
           <a:xfrm>
-            <a:off x="939798" y="4635488"/>
-            <a:ext cx="3479791" cy="419099"/>
+            <a:off x="825498" y="4597389"/>
+            <a:ext cx="2578094" cy="406399"/>
           </a:xfrm>
           <a:prstGeom prst="rect">
             <a:avLst/>
@@ -4832,7 +4799,7 @@
               <a:buNone/>
             </a:pPr>
             <a:r>
-              <a:rPr lang="en-US" sz="1100" dirty="0">
+              <a:rPr lang="en-US" sz="950" dirty="0">
                 <a:solidFill>
                   <a:srgbClr val="6F6A5C"/>
                 </a:solidFill>
@@ -4840,9 +4807,9 @@
                 <a:ea typeface="Arial" pitchFamily="34" charset="-122"/>
                 <a:cs typeface="Arial" pitchFamily="34" charset="-120"/>
               </a:rPr>
-              <a:t>Prijs per lead</a:t>
-            </a:r>
-            <a:endParaRPr lang="en-US" sz="1100" dirty="0"/>
+              <a:t>Waarvan tastings</a:t>
+            </a:r>
+            <a:endParaRPr lang="en-US" sz="950" dirty="0"/>
           </a:p>
         </p:txBody>
       </p:sp>
@@ -4854,8 +4821,8 @@
         </p:nvSpPr>
         <p:spPr>
           <a:xfrm>
-            <a:off x="4419589" y="4635488"/>
-            <a:ext cx="1244597" cy="419099"/>
+            <a:off x="3124192" y="4597389"/>
+            <a:ext cx="825498" cy="406399"/>
           </a:xfrm>
           <a:prstGeom prst="rect">
             <a:avLst/>
@@ -4871,7 +4838,7 @@
               <a:buNone/>
             </a:pPr>
             <a:r>
-              <a:rPr lang="en-US" sz="1350" b="1" dirty="0">
+              <a:rPr lang="en-US" sz="1150" b="1" dirty="0">
                 <a:solidFill>
                   <a:srgbClr val="1C2230"/>
                 </a:solidFill>
@@ -4879,9 +4846,9 @@
                 <a:ea typeface="Arial" pitchFamily="34" charset="-122"/>
                 <a:cs typeface="Arial" pitchFamily="34" charset="-120"/>
               </a:rPr>
-              <a:t>± € 212</a:t>
-            </a:r>
-            <a:endParaRPr lang="en-US" sz="1350" dirty="0"/>
+              <a:t>± 4</a:t>
+            </a:r>
+            <a:endParaRPr lang="en-US" sz="1150" dirty="0"/>
           </a:p>
         </p:txBody>
       </p:sp>
@@ -4893,8 +4860,109 @@
         </p:nvSpPr>
         <p:spPr>
           <a:xfrm>
-            <a:off x="6197585" y="2489194"/>
-            <a:ext cx="5384787" cy="2768593"/>
+            <a:off x="825498" y="5003787"/>
+            <a:ext cx="3124192" cy="0"/>
+          </a:xfrm>
+          <a:prstGeom prst="line">
+            <a:avLst/>
+          </a:prstGeom>
+          <a:noFill/>
+          <a:ln w="9525">
+            <a:solidFill>
+              <a:srgbClr val="D8D2C4"/>
+            </a:solidFill>
+            <a:prstDash val="solid"/>
+          </a:ln>
+        </p:spPr>
+      </p:sp>
+      <p:sp>
+        <p:nvSpPr>
+          <p:cNvPr id="22" name="Text 20"/>
+          <p:cNvSpPr txBox="1"/>
+          <p:nvPr/>
+        </p:nvSpPr>
+        <p:spPr>
+          <a:xfrm>
+            <a:off x="825498" y="5003787"/>
+            <a:ext cx="2578094" cy="406399"/>
+          </a:xfrm>
+          <a:prstGeom prst="rect">
+            <a:avLst/>
+          </a:prstGeom>
+          <a:noFill/>
+          <a:ln/>
+        </p:spPr>
+        <p:txBody>
+          <a:bodyPr wrap="square" lIns="0" tIns="0" rIns="0" bIns="0" rtlCol="0" anchor="ctr"/>
+          <a:lstStyle/>
+          <a:p>
+            <a:pPr indent="0" marL="0">
+              <a:buNone/>
+            </a:pPr>
+            <a:r>
+              <a:rPr lang="en-US" sz="950" dirty="0">
+                <a:solidFill>
+                  <a:srgbClr val="6F6A5C"/>
+                </a:solidFill>
+                <a:latin typeface="Arial" pitchFamily="34" charset="0"/>
+                <a:ea typeface="Arial" pitchFamily="34" charset="-122"/>
+                <a:cs typeface="Arial" pitchFamily="34" charset="-120"/>
+              </a:rPr>
+              <a:t>Prijs per lead</a:t>
+            </a:r>
+            <a:endParaRPr lang="en-US" sz="950" dirty="0"/>
+          </a:p>
+        </p:txBody>
+      </p:sp>
+      <p:sp>
+        <p:nvSpPr>
+          <p:cNvPr id="23" name="Text 21"/>
+          <p:cNvSpPr txBox="1"/>
+          <p:nvPr/>
+        </p:nvSpPr>
+        <p:spPr>
+          <a:xfrm>
+            <a:off x="3124192" y="5003787"/>
+            <a:ext cx="825498" cy="406399"/>
+          </a:xfrm>
+          <a:prstGeom prst="rect">
+            <a:avLst/>
+          </a:prstGeom>
+          <a:noFill/>
+          <a:ln/>
+        </p:spPr>
+        <p:txBody>
+          <a:bodyPr wrap="square" lIns="0" tIns="0" rIns="0" bIns="0" rtlCol="0" anchor="ctr"/>
+          <a:lstStyle/>
+          <a:p>
+            <a:pPr algn="r" indent="0" marL="0">
+              <a:buNone/>
+            </a:pPr>
+            <a:r>
+              <a:rPr lang="en-US" sz="1150" b="1" dirty="0">
+                <a:solidFill>
+                  <a:srgbClr val="1C2230"/>
+                </a:solidFill>
+                <a:latin typeface="Arial" pitchFamily="34" charset="0"/>
+                <a:ea typeface="Arial" pitchFamily="34" charset="-122"/>
+                <a:cs typeface="Arial" pitchFamily="34" charset="-120"/>
+              </a:rPr>
+              <a:t>± € 212</a:t>
+            </a:r>
+            <a:endParaRPr lang="en-US" sz="1150" dirty="0"/>
+          </a:p>
+        </p:txBody>
+      </p:sp>
+      <p:sp>
+        <p:nvSpPr>
+          <p:cNvPr id="24" name="Shape 22"/>
+          <p:cNvSpPr/>
+          <p:nvPr/>
+        </p:nvSpPr>
+        <p:spPr>
+          <a:xfrm>
+            <a:off x="4317989" y="2489194"/>
+            <a:ext cx="3555991" cy="2768593"/>
           </a:xfrm>
           <a:prstGeom prst="roundRect">
             <a:avLst>
@@ -4902,6 +4970,591 @@
             </a:avLst>
           </a:prstGeom>
           <a:solidFill>
+            <a:srgbClr val="F8F4EB"/>
+          </a:solidFill>
+          <a:ln/>
+        </p:spPr>
+      </p:sp>
+      <p:sp>
+        <p:nvSpPr>
+          <p:cNvPr id="25" name="Text 23"/>
+          <p:cNvSpPr txBox="1"/>
+          <p:nvPr/>
+        </p:nvSpPr>
+        <p:spPr>
+          <a:xfrm>
+            <a:off x="4533889" y="2743193"/>
+            <a:ext cx="3124192" cy="190500"/>
+          </a:xfrm>
+          <a:prstGeom prst="rect">
+            <a:avLst/>
+          </a:prstGeom>
+          <a:noFill/>
+          <a:ln/>
+        </p:spPr>
+        <p:txBody>
+          <a:bodyPr wrap="square" lIns="0" tIns="0" rIns="0" bIns="0" rtlCol="0" anchor="ctr"/>
+          <a:lstStyle/>
+          <a:p>
+            <a:pPr indent="0" marL="0">
+              <a:buNone/>
+            </a:pPr>
+            <a:r>
+              <a:rPr lang="en-US" sz="800" b="1" spc="180" kern="0" dirty="0">
+                <a:solidFill>
+                  <a:srgbClr val="6F6A5C"/>
+                </a:solidFill>
+                <a:latin typeface="Arial" pitchFamily="34" charset="0"/>
+                <a:ea typeface="Arial" pitchFamily="34" charset="-122"/>
+                <a:cs typeface="Arial" pitchFamily="34" charset="-120"/>
+              </a:rPr>
+              <a:t>TWEE KEER</a:t>
+            </a:r>
+            <a:endParaRPr lang="en-US" sz="800" dirty="0"/>
+          </a:p>
+        </p:txBody>
+      </p:sp>
+      <p:sp>
+        <p:nvSpPr>
+          <p:cNvPr id="26" name="Text 24"/>
+          <p:cNvSpPr txBox="1"/>
+          <p:nvPr/>
+        </p:nvSpPr>
+        <p:spPr>
+          <a:xfrm>
+            <a:off x="4533889" y="2959093"/>
+            <a:ext cx="3124192" cy="355599"/>
+          </a:xfrm>
+          <a:prstGeom prst="rect">
+            <a:avLst/>
+          </a:prstGeom>
+          <a:noFill/>
+          <a:ln/>
+        </p:spPr>
+        <p:txBody>
+          <a:bodyPr wrap="square" lIns="0" tIns="0" rIns="0" bIns="0" rtlCol="0" anchor="ctr"/>
+          <a:lstStyle/>
+          <a:p>
+            <a:pPr indent="0" marL="0">
+              <a:lnSpc>
+                <a:spcPct val="115000"/>
+              </a:lnSpc>
+              <a:buNone/>
+            </a:pPr>
+            <a:r>
+              <a:rPr lang="en-US" sz="1250" b="1" dirty="0">
+                <a:solidFill>
+                  <a:srgbClr val="1C2230"/>
+                </a:solidFill>
+                <a:latin typeface="Arial" pitchFamily="34" charset="0"/>
+                <a:ea typeface="Arial" pitchFamily="34" charset="-122"/>
+                <a:cs typeface="Arial" pitchFamily="34" charset="-120"/>
+              </a:rPr>
+              <a:t>8 beldagen per 4 weken</a:t>
+            </a:r>
+            <a:endParaRPr lang="en-US" sz="1250" dirty="0"/>
+          </a:p>
+        </p:txBody>
+      </p:sp>
+      <p:sp>
+        <p:nvSpPr>
+          <p:cNvPr id="27" name="Text 25"/>
+          <p:cNvSpPr txBox="1"/>
+          <p:nvPr/>
+        </p:nvSpPr>
+        <p:spPr>
+          <a:xfrm>
+            <a:off x="4533889" y="3378192"/>
+            <a:ext cx="2578094" cy="406399"/>
+          </a:xfrm>
+          <a:prstGeom prst="rect">
+            <a:avLst/>
+          </a:prstGeom>
+          <a:noFill/>
+          <a:ln/>
+        </p:spPr>
+        <p:txBody>
+          <a:bodyPr wrap="square" lIns="0" tIns="0" rIns="0" bIns="0" rtlCol="0" anchor="ctr"/>
+          <a:lstStyle/>
+          <a:p>
+            <a:pPr indent="0" marL="0">
+              <a:buNone/>
+            </a:pPr>
+            <a:r>
+              <a:rPr lang="en-US" sz="950" dirty="0">
+                <a:solidFill>
+                  <a:srgbClr val="6F6A5C"/>
+                </a:solidFill>
+                <a:latin typeface="Arial" pitchFamily="34" charset="0"/>
+                <a:ea typeface="Arial" pitchFamily="34" charset="-122"/>
+                <a:cs typeface="Arial" pitchFamily="34" charset="-120"/>
+              </a:rPr>
+              <a:t>Kosten per 4 weken</a:t>
+            </a:r>
+            <a:endParaRPr lang="en-US" sz="950" dirty="0"/>
+          </a:p>
+        </p:txBody>
+      </p:sp>
+      <p:sp>
+        <p:nvSpPr>
+          <p:cNvPr id="28" name="Text 26"/>
+          <p:cNvSpPr txBox="1"/>
+          <p:nvPr/>
+        </p:nvSpPr>
+        <p:spPr>
+          <a:xfrm>
+            <a:off x="6832583" y="3378192"/>
+            <a:ext cx="825498" cy="406399"/>
+          </a:xfrm>
+          <a:prstGeom prst="rect">
+            <a:avLst/>
+          </a:prstGeom>
+          <a:noFill/>
+          <a:ln/>
+        </p:spPr>
+        <p:txBody>
+          <a:bodyPr wrap="square" lIns="0" tIns="0" rIns="0" bIns="0" rtlCol="0" anchor="ctr"/>
+          <a:lstStyle/>
+          <a:p>
+            <a:pPr algn="r" indent="0" marL="0">
+              <a:buNone/>
+            </a:pPr>
+            <a:r>
+              <a:rPr lang="en-US" sz="1150" b="1" dirty="0">
+                <a:solidFill>
+                  <a:srgbClr val="1C2230"/>
+                </a:solidFill>
+                <a:latin typeface="Arial" pitchFamily="34" charset="0"/>
+                <a:ea typeface="Arial" pitchFamily="34" charset="-122"/>
+                <a:cs typeface="Arial" pitchFamily="34" charset="-120"/>
+              </a:rPr>
+              <a:t>€ 4.000</a:t>
+            </a:r>
+            <a:endParaRPr lang="en-US" sz="1150" dirty="0"/>
+          </a:p>
+        </p:txBody>
+      </p:sp>
+      <p:sp>
+        <p:nvSpPr>
+          <p:cNvPr id="29" name="Shape 27"/>
+          <p:cNvSpPr/>
+          <p:nvPr/>
+        </p:nvSpPr>
+        <p:spPr>
+          <a:xfrm>
+            <a:off x="4533889" y="3784591"/>
+            <a:ext cx="3124192" cy="0"/>
+          </a:xfrm>
+          <a:prstGeom prst="line">
+            <a:avLst/>
+          </a:prstGeom>
+          <a:noFill/>
+          <a:ln w="9525">
+            <a:solidFill>
+              <a:srgbClr val="D8D2C4"/>
+            </a:solidFill>
+            <a:prstDash val="solid"/>
+          </a:ln>
+        </p:spPr>
+      </p:sp>
+      <p:sp>
+        <p:nvSpPr>
+          <p:cNvPr id="30" name="Text 28"/>
+          <p:cNvSpPr txBox="1"/>
+          <p:nvPr/>
+        </p:nvSpPr>
+        <p:spPr>
+          <a:xfrm>
+            <a:off x="4533889" y="3784591"/>
+            <a:ext cx="2578094" cy="406399"/>
+          </a:xfrm>
+          <a:prstGeom prst="rect">
+            <a:avLst/>
+          </a:prstGeom>
+          <a:noFill/>
+          <a:ln/>
+        </p:spPr>
+        <p:txBody>
+          <a:bodyPr wrap="square" lIns="0" tIns="0" rIns="0" bIns="0" rtlCol="0" anchor="ctr"/>
+          <a:lstStyle/>
+          <a:p>
+            <a:pPr indent="0" marL="0">
+              <a:buNone/>
+            </a:pPr>
+            <a:r>
+              <a:rPr lang="en-US" sz="950" dirty="0">
+                <a:solidFill>
+                  <a:srgbClr val="6F6A5C"/>
+                </a:solidFill>
+                <a:latin typeface="Arial" pitchFamily="34" charset="0"/>
+                <a:ea typeface="Arial" pitchFamily="34" charset="-122"/>
+                <a:cs typeface="Arial" pitchFamily="34" charset="-120"/>
+              </a:rPr>
+              <a:t>Gesprekspogingen</a:t>
+            </a:r>
+            <a:endParaRPr lang="en-US" sz="950" dirty="0"/>
+          </a:p>
+        </p:txBody>
+      </p:sp>
+      <p:sp>
+        <p:nvSpPr>
+          <p:cNvPr id="31" name="Text 29"/>
+          <p:cNvSpPr txBox="1"/>
+          <p:nvPr/>
+        </p:nvSpPr>
+        <p:spPr>
+          <a:xfrm>
+            <a:off x="6832583" y="3784591"/>
+            <a:ext cx="825498" cy="406399"/>
+          </a:xfrm>
+          <a:prstGeom prst="rect">
+            <a:avLst/>
+          </a:prstGeom>
+          <a:noFill/>
+          <a:ln/>
+        </p:spPr>
+        <p:txBody>
+          <a:bodyPr wrap="square" lIns="0" tIns="0" rIns="0" bIns="0" rtlCol="0" anchor="ctr"/>
+          <a:lstStyle/>
+          <a:p>
+            <a:pPr algn="r" indent="0" marL="0">
+              <a:buNone/>
+            </a:pPr>
+            <a:r>
+              <a:rPr lang="en-US" sz="1150" b="1" dirty="0">
+                <a:solidFill>
+                  <a:srgbClr val="1C2230"/>
+                </a:solidFill>
+                <a:latin typeface="Arial" pitchFamily="34" charset="0"/>
+                <a:ea typeface="Arial" pitchFamily="34" charset="-122"/>
+                <a:cs typeface="Arial" pitchFamily="34" charset="-120"/>
+              </a:rPr>
+              <a:t>± 800</a:t>
+            </a:r>
+            <a:endParaRPr lang="en-US" sz="1150" dirty="0"/>
+          </a:p>
+        </p:txBody>
+      </p:sp>
+      <p:sp>
+        <p:nvSpPr>
+          <p:cNvPr id="32" name="Shape 30"/>
+          <p:cNvSpPr/>
+          <p:nvPr/>
+        </p:nvSpPr>
+        <p:spPr>
+          <a:xfrm>
+            <a:off x="4533889" y="4190990"/>
+            <a:ext cx="3124192" cy="0"/>
+          </a:xfrm>
+          <a:prstGeom prst="line">
+            <a:avLst/>
+          </a:prstGeom>
+          <a:noFill/>
+          <a:ln w="9525">
+            <a:solidFill>
+              <a:srgbClr val="D8D2C4"/>
+            </a:solidFill>
+            <a:prstDash val="solid"/>
+          </a:ln>
+        </p:spPr>
+      </p:sp>
+      <p:sp>
+        <p:nvSpPr>
+          <p:cNvPr id="33" name="Text 31"/>
+          <p:cNvSpPr txBox="1"/>
+          <p:nvPr/>
+        </p:nvSpPr>
+        <p:spPr>
+          <a:xfrm>
+            <a:off x="4533889" y="4190990"/>
+            <a:ext cx="2578094" cy="406399"/>
+          </a:xfrm>
+          <a:prstGeom prst="rect">
+            <a:avLst/>
+          </a:prstGeom>
+          <a:noFill/>
+          <a:ln/>
+        </p:spPr>
+        <p:txBody>
+          <a:bodyPr wrap="square" lIns="0" tIns="0" rIns="0" bIns="0" rtlCol="0" anchor="ctr"/>
+          <a:lstStyle/>
+          <a:p>
+            <a:pPr indent="0" marL="0">
+              <a:buNone/>
+            </a:pPr>
+            <a:r>
+              <a:rPr lang="en-US" sz="950" dirty="0">
+                <a:solidFill>
+                  <a:srgbClr val="6F6A5C"/>
+                </a:solidFill>
+                <a:latin typeface="Arial" pitchFamily="34" charset="0"/>
+                <a:ea typeface="Arial" pitchFamily="34" charset="-122"/>
+                <a:cs typeface="Arial" pitchFamily="34" charset="-120"/>
+              </a:rPr>
+              <a:t>Verwachte leads</a:t>
+            </a:r>
+            <a:endParaRPr lang="en-US" sz="950" dirty="0"/>
+          </a:p>
+        </p:txBody>
+      </p:sp>
+      <p:sp>
+        <p:nvSpPr>
+          <p:cNvPr id="34" name="Text 32"/>
+          <p:cNvSpPr txBox="1"/>
+          <p:nvPr/>
+        </p:nvSpPr>
+        <p:spPr>
+          <a:xfrm>
+            <a:off x="6832583" y="4190990"/>
+            <a:ext cx="825498" cy="406399"/>
+          </a:xfrm>
+          <a:prstGeom prst="rect">
+            <a:avLst/>
+          </a:prstGeom>
+          <a:noFill/>
+          <a:ln/>
+        </p:spPr>
+        <p:txBody>
+          <a:bodyPr wrap="square" lIns="0" tIns="0" rIns="0" bIns="0" rtlCol="0" anchor="ctr"/>
+          <a:lstStyle/>
+          <a:p>
+            <a:pPr algn="r" indent="0" marL="0">
+              <a:buNone/>
+            </a:pPr>
+            <a:r>
+              <a:rPr lang="en-US" sz="1150" b="1" dirty="0">
+                <a:solidFill>
+                  <a:srgbClr val="1C2230"/>
+                </a:solidFill>
+                <a:latin typeface="Arial" pitchFamily="34" charset="0"/>
+                <a:ea typeface="Arial" pitchFamily="34" charset="-122"/>
+                <a:cs typeface="Arial" pitchFamily="34" charset="-120"/>
+              </a:rPr>
+              <a:t>± 19</a:t>
+            </a:r>
+            <a:endParaRPr lang="en-US" sz="1150" dirty="0"/>
+          </a:p>
+        </p:txBody>
+      </p:sp>
+      <p:sp>
+        <p:nvSpPr>
+          <p:cNvPr id="35" name="Shape 33"/>
+          <p:cNvSpPr/>
+          <p:nvPr/>
+        </p:nvSpPr>
+        <p:spPr>
+          <a:xfrm>
+            <a:off x="4533889" y="4597389"/>
+            <a:ext cx="3124192" cy="0"/>
+          </a:xfrm>
+          <a:prstGeom prst="line">
+            <a:avLst/>
+          </a:prstGeom>
+          <a:noFill/>
+          <a:ln w="9525">
+            <a:solidFill>
+              <a:srgbClr val="D8D2C4"/>
+            </a:solidFill>
+            <a:prstDash val="solid"/>
+          </a:ln>
+        </p:spPr>
+      </p:sp>
+      <p:sp>
+        <p:nvSpPr>
+          <p:cNvPr id="36" name="Text 34"/>
+          <p:cNvSpPr txBox="1"/>
+          <p:nvPr/>
+        </p:nvSpPr>
+        <p:spPr>
+          <a:xfrm>
+            <a:off x="4533889" y="4597389"/>
+            <a:ext cx="2578094" cy="406399"/>
+          </a:xfrm>
+          <a:prstGeom prst="rect">
+            <a:avLst/>
+          </a:prstGeom>
+          <a:noFill/>
+          <a:ln/>
+        </p:spPr>
+        <p:txBody>
+          <a:bodyPr wrap="square" lIns="0" tIns="0" rIns="0" bIns="0" rtlCol="0" anchor="ctr"/>
+          <a:lstStyle/>
+          <a:p>
+            <a:pPr indent="0" marL="0">
+              <a:buNone/>
+            </a:pPr>
+            <a:r>
+              <a:rPr lang="en-US" sz="950" dirty="0">
+                <a:solidFill>
+                  <a:srgbClr val="6F6A5C"/>
+                </a:solidFill>
+                <a:latin typeface="Arial" pitchFamily="34" charset="0"/>
+                <a:ea typeface="Arial" pitchFamily="34" charset="-122"/>
+                <a:cs typeface="Arial" pitchFamily="34" charset="-120"/>
+              </a:rPr>
+              <a:t>Waarvan tastings</a:t>
+            </a:r>
+            <a:endParaRPr lang="en-US" sz="950" dirty="0"/>
+          </a:p>
+        </p:txBody>
+      </p:sp>
+      <p:sp>
+        <p:nvSpPr>
+          <p:cNvPr id="37" name="Text 35"/>
+          <p:cNvSpPr txBox="1"/>
+          <p:nvPr/>
+        </p:nvSpPr>
+        <p:spPr>
+          <a:xfrm>
+            <a:off x="6832583" y="4597389"/>
+            <a:ext cx="825498" cy="406399"/>
+          </a:xfrm>
+          <a:prstGeom prst="rect">
+            <a:avLst/>
+          </a:prstGeom>
+          <a:noFill/>
+          <a:ln/>
+        </p:spPr>
+        <p:txBody>
+          <a:bodyPr wrap="square" lIns="0" tIns="0" rIns="0" bIns="0" rtlCol="0" anchor="ctr"/>
+          <a:lstStyle/>
+          <a:p>
+            <a:pPr algn="r" indent="0" marL="0">
+              <a:buNone/>
+            </a:pPr>
+            <a:r>
+              <a:rPr lang="en-US" sz="1150" b="1" dirty="0">
+                <a:solidFill>
+                  <a:srgbClr val="1C2230"/>
+                </a:solidFill>
+                <a:latin typeface="Arial" pitchFamily="34" charset="0"/>
+                <a:ea typeface="Arial" pitchFamily="34" charset="-122"/>
+                <a:cs typeface="Arial" pitchFamily="34" charset="-120"/>
+              </a:rPr>
+              <a:t>± 7</a:t>
+            </a:r>
+            <a:endParaRPr lang="en-US" sz="1150" dirty="0"/>
+          </a:p>
+        </p:txBody>
+      </p:sp>
+      <p:sp>
+        <p:nvSpPr>
+          <p:cNvPr id="38" name="Shape 36"/>
+          <p:cNvSpPr/>
+          <p:nvPr/>
+        </p:nvSpPr>
+        <p:spPr>
+          <a:xfrm>
+            <a:off x="4533889" y="5003787"/>
+            <a:ext cx="3124192" cy="0"/>
+          </a:xfrm>
+          <a:prstGeom prst="line">
+            <a:avLst/>
+          </a:prstGeom>
+          <a:noFill/>
+          <a:ln w="9525">
+            <a:solidFill>
+              <a:srgbClr val="D8D2C4"/>
+            </a:solidFill>
+            <a:prstDash val="solid"/>
+          </a:ln>
+        </p:spPr>
+      </p:sp>
+      <p:sp>
+        <p:nvSpPr>
+          <p:cNvPr id="39" name="Text 37"/>
+          <p:cNvSpPr txBox="1"/>
+          <p:nvPr/>
+        </p:nvSpPr>
+        <p:spPr>
+          <a:xfrm>
+            <a:off x="4533889" y="5003787"/>
+            <a:ext cx="2578094" cy="406399"/>
+          </a:xfrm>
+          <a:prstGeom prst="rect">
+            <a:avLst/>
+          </a:prstGeom>
+          <a:noFill/>
+          <a:ln/>
+        </p:spPr>
+        <p:txBody>
+          <a:bodyPr wrap="square" lIns="0" tIns="0" rIns="0" bIns="0" rtlCol="0" anchor="ctr"/>
+          <a:lstStyle/>
+          <a:p>
+            <a:pPr indent="0" marL="0">
+              <a:buNone/>
+            </a:pPr>
+            <a:r>
+              <a:rPr lang="en-US" sz="950" dirty="0">
+                <a:solidFill>
+                  <a:srgbClr val="6F6A5C"/>
+                </a:solidFill>
+                <a:latin typeface="Arial" pitchFamily="34" charset="0"/>
+                <a:ea typeface="Arial" pitchFamily="34" charset="-122"/>
+                <a:cs typeface="Arial" pitchFamily="34" charset="-120"/>
+              </a:rPr>
+              <a:t>Prijs per lead</a:t>
+            </a:r>
+            <a:endParaRPr lang="en-US" sz="950" dirty="0"/>
+          </a:p>
+        </p:txBody>
+      </p:sp>
+      <p:sp>
+        <p:nvSpPr>
+          <p:cNvPr id="40" name="Text 38"/>
+          <p:cNvSpPr txBox="1"/>
+          <p:nvPr/>
+        </p:nvSpPr>
+        <p:spPr>
+          <a:xfrm>
+            <a:off x="6832583" y="5003787"/>
+            <a:ext cx="825498" cy="406399"/>
+          </a:xfrm>
+          <a:prstGeom prst="rect">
+            <a:avLst/>
+          </a:prstGeom>
+          <a:noFill/>
+          <a:ln/>
+        </p:spPr>
+        <p:txBody>
+          <a:bodyPr wrap="square" lIns="0" tIns="0" rIns="0" bIns="0" rtlCol="0" anchor="ctr"/>
+          <a:lstStyle/>
+          <a:p>
+            <a:pPr algn="r" indent="0" marL="0">
+              <a:buNone/>
+            </a:pPr>
+            <a:r>
+              <a:rPr lang="en-US" sz="1150" b="1" dirty="0">
+                <a:solidFill>
+                  <a:srgbClr val="1C2230"/>
+                </a:solidFill>
+                <a:latin typeface="Arial" pitchFamily="34" charset="0"/>
+                <a:ea typeface="Arial" pitchFamily="34" charset="-122"/>
+                <a:cs typeface="Arial" pitchFamily="34" charset="-120"/>
+              </a:rPr>
+              <a:t>€ 215</a:t>
+            </a:r>
+            <a:endParaRPr lang="en-US" sz="1150" dirty="0"/>
+          </a:p>
+        </p:txBody>
+      </p:sp>
+      <p:sp>
+        <p:nvSpPr>
+          <p:cNvPr id="41" name="Shape 39"/>
+          <p:cNvSpPr/>
+          <p:nvPr/>
+        </p:nvSpPr>
+        <p:spPr>
+          <a:xfrm>
+            <a:off x="8026380" y="2489194"/>
+            <a:ext cx="3555991" cy="2768593"/>
+          </a:xfrm>
+          <a:prstGeom prst="roundRect">
+            <a:avLst>
+              <a:gd name="adj" fmla="val 3670"/>
+            </a:avLst>
+          </a:prstGeom>
+          <a:solidFill>
             <a:srgbClr val="000000"/>
           </a:solidFill>
           <a:ln/>
@@ -4909,14 +5562,14 @@
       </p:sp>
       <p:sp>
         <p:nvSpPr>
-          <p:cNvPr id="22" name="Text 20"/>
-          <p:cNvSpPr txBox="1"/>
-          <p:nvPr/>
-        </p:nvSpPr>
-        <p:spPr>
-          <a:xfrm>
-            <a:off x="6527784" y="2768593"/>
-            <a:ext cx="4724388" cy="190500"/>
+          <p:cNvPr id="42" name="Text 40"/>
+          <p:cNvSpPr txBox="1"/>
+          <p:nvPr/>
+        </p:nvSpPr>
+        <p:spPr>
+          <a:xfrm>
+            <a:off x="8242279" y="2743193"/>
+            <a:ext cx="3124192" cy="190500"/>
           </a:xfrm>
           <a:prstGeom prst="rect">
             <a:avLst/>
@@ -4940,7 +5593,7 @@
                 <a:ea typeface="Arial" pitchFamily="34" charset="-122"/>
                 <a:cs typeface="Arial" pitchFamily="34" charset="-120"/>
               </a:rPr>
-              <a:t>VOORSTEL · ACHT BELDAGEN</a:t>
+              <a:t>DRIE KEER</a:t>
             </a:r>
             <a:endParaRPr lang="en-US" sz="800" dirty="0"/>
           </a:p>
@@ -4948,14 +5601,14 @@
       </p:sp>
       <p:sp>
         <p:nvSpPr>
-          <p:cNvPr id="23" name="Text 21"/>
-          <p:cNvSpPr txBox="1"/>
-          <p:nvPr/>
-        </p:nvSpPr>
-        <p:spPr>
-          <a:xfrm>
-            <a:off x="6527784" y="2984493"/>
-            <a:ext cx="4724388" cy="330199"/>
+          <p:cNvPr id="43" name="Text 41"/>
+          <p:cNvSpPr txBox="1"/>
+          <p:nvPr/>
+        </p:nvSpPr>
+        <p:spPr>
+          <a:xfrm>
+            <a:off x="8242279" y="2959093"/>
+            <a:ext cx="3124192" cy="355599"/>
           </a:xfrm>
           <a:prstGeom prst="rect">
             <a:avLst/>
@@ -4968,10 +5621,13 @@
           <a:lstStyle/>
           <a:p>
             <a:pPr indent="0" marL="0">
-              <a:buNone/>
-            </a:pPr>
-            <a:r>
-              <a:rPr lang="en-US" sz="1500" b="1" dirty="0">
+              <a:lnSpc>
+                <a:spcPct val="115000"/>
+              </a:lnSpc>
+              <a:buNone/>
+            </a:pPr>
+            <a:r>
+              <a:rPr lang="en-US" sz="1250" b="1" dirty="0">
                 <a:solidFill>
                   <a:srgbClr val="F2EFE6"/>
                 </a:solidFill>
@@ -4979,22 +5635,22 @@
                 <a:ea typeface="Arial" pitchFamily="34" charset="-122"/>
                 <a:cs typeface="Arial" pitchFamily="34" charset="-120"/>
               </a:rPr>
-              <a:t>€ 500 per beldag, verder niets</a:t>
-            </a:r>
-            <a:endParaRPr lang="en-US" sz="1500" dirty="0"/>
-          </a:p>
-        </p:txBody>
-      </p:sp>
-      <p:sp>
-        <p:nvSpPr>
-          <p:cNvPr id="24" name="Text 22"/>
-          <p:cNvSpPr txBox="1"/>
-          <p:nvPr/>
-        </p:nvSpPr>
-        <p:spPr>
-          <a:xfrm>
-            <a:off x="6527784" y="3378192"/>
-            <a:ext cx="3479791" cy="419099"/>
+              <a:t>12 beldagen per 4 weken</a:t>
+            </a:r>
+            <a:endParaRPr lang="en-US" sz="1250" dirty="0"/>
+          </a:p>
+        </p:txBody>
+      </p:sp>
+      <p:sp>
+        <p:nvSpPr>
+          <p:cNvPr id="44" name="Text 42"/>
+          <p:cNvSpPr txBox="1"/>
+          <p:nvPr/>
+        </p:nvSpPr>
+        <p:spPr>
+          <a:xfrm>
+            <a:off x="8242279" y="3378192"/>
+            <a:ext cx="2578094" cy="406399"/>
           </a:xfrm>
           <a:prstGeom prst="rect">
             <a:avLst/>
@@ -5010,7 +5666,7 @@
               <a:buNone/>
             </a:pPr>
             <a:r>
-              <a:rPr lang="en-US" sz="1100" dirty="0">
+              <a:rPr lang="en-US" sz="950" dirty="0">
                 <a:solidFill>
                   <a:srgbClr val="C2C8D2"/>
                 </a:solidFill>
@@ -5020,20 +5676,20 @@
               </a:rPr>
               <a:t>Kosten per 4 weken</a:t>
             </a:r>
-            <a:endParaRPr lang="en-US" sz="1100" dirty="0"/>
-          </a:p>
-        </p:txBody>
-      </p:sp>
-      <p:sp>
-        <p:nvSpPr>
-          <p:cNvPr id="25" name="Text 23"/>
-          <p:cNvSpPr txBox="1"/>
-          <p:nvPr/>
-        </p:nvSpPr>
-        <p:spPr>
-          <a:xfrm>
-            <a:off x="10007575" y="3378192"/>
-            <a:ext cx="1244597" cy="419099"/>
+            <a:endParaRPr lang="en-US" sz="950" dirty="0"/>
+          </a:p>
+        </p:txBody>
+      </p:sp>
+      <p:sp>
+        <p:nvSpPr>
+          <p:cNvPr id="45" name="Text 43"/>
+          <p:cNvSpPr txBox="1"/>
+          <p:nvPr/>
+        </p:nvSpPr>
+        <p:spPr>
+          <a:xfrm>
+            <a:off x="10540974" y="3378192"/>
+            <a:ext cx="825498" cy="406399"/>
           </a:xfrm>
           <a:prstGeom prst="rect">
             <a:avLst/>
@@ -5049,7 +5705,7 @@
               <a:buNone/>
             </a:pPr>
             <a:r>
-              <a:rPr lang="en-US" sz="1350" b="1" dirty="0">
+              <a:rPr lang="en-US" sz="1150" b="1" dirty="0">
                 <a:solidFill>
                   <a:srgbClr val="38B6FF"/>
                 </a:solidFill>
@@ -5057,22 +5713,22 @@
                 <a:ea typeface="Arial" pitchFamily="34" charset="-122"/>
                 <a:cs typeface="Arial" pitchFamily="34" charset="-120"/>
               </a:rPr>
-              <a:t>€ 4.000</a:t>
-            </a:r>
-            <a:endParaRPr lang="en-US" sz="1350" dirty="0"/>
-          </a:p>
-        </p:txBody>
-      </p:sp>
-      <p:sp>
-        <p:nvSpPr>
-          <p:cNvPr id="26" name="Shape 24"/>
+              <a:t>€ 6.000</a:t>
+            </a:r>
+            <a:endParaRPr lang="en-US" sz="1150" dirty="0"/>
+          </a:p>
+        </p:txBody>
+      </p:sp>
+      <p:sp>
+        <p:nvSpPr>
+          <p:cNvPr id="46" name="Shape 44"/>
           <p:cNvSpPr/>
           <p:nvPr/>
         </p:nvSpPr>
         <p:spPr>
           <a:xfrm>
-            <a:off x="6527784" y="3797291"/>
-            <a:ext cx="4724388" cy="0"/>
+            <a:off x="8242279" y="3784591"/>
+            <a:ext cx="3124192" cy="0"/>
           </a:xfrm>
           <a:prstGeom prst="line">
             <a:avLst/>
@@ -5088,14 +5744,14 @@
       </p:sp>
       <p:sp>
         <p:nvSpPr>
-          <p:cNvPr id="27" name="Text 25"/>
-          <p:cNvSpPr txBox="1"/>
-          <p:nvPr/>
-        </p:nvSpPr>
-        <p:spPr>
-          <a:xfrm>
-            <a:off x="6527784" y="3797291"/>
-            <a:ext cx="3479791" cy="419099"/>
+          <p:cNvPr id="47" name="Text 45"/>
+          <p:cNvSpPr txBox="1"/>
+          <p:nvPr/>
+        </p:nvSpPr>
+        <p:spPr>
+          <a:xfrm>
+            <a:off x="8242279" y="3784591"/>
+            <a:ext cx="2578094" cy="406399"/>
           </a:xfrm>
           <a:prstGeom prst="rect">
             <a:avLst/>
@@ -5111,7 +5767,7 @@
               <a:buNone/>
             </a:pPr>
             <a:r>
-              <a:rPr lang="en-US" sz="1100" dirty="0">
+              <a:rPr lang="en-US" sz="950" dirty="0">
                 <a:solidFill>
                   <a:srgbClr val="C2C8D2"/>
                 </a:solidFill>
@@ -5121,20 +5777,20 @@
               </a:rPr>
               <a:t>Gesprekspogingen</a:t>
             </a:r>
-            <a:endParaRPr lang="en-US" sz="1100" dirty="0"/>
-          </a:p>
-        </p:txBody>
-      </p:sp>
-      <p:sp>
-        <p:nvSpPr>
-          <p:cNvPr id="28" name="Text 26"/>
-          <p:cNvSpPr txBox="1"/>
-          <p:nvPr/>
-        </p:nvSpPr>
-        <p:spPr>
-          <a:xfrm>
-            <a:off x="10007575" y="3797291"/>
-            <a:ext cx="1244597" cy="419099"/>
+            <a:endParaRPr lang="en-US" sz="950" dirty="0"/>
+          </a:p>
+        </p:txBody>
+      </p:sp>
+      <p:sp>
+        <p:nvSpPr>
+          <p:cNvPr id="48" name="Text 46"/>
+          <p:cNvSpPr txBox="1"/>
+          <p:nvPr/>
+        </p:nvSpPr>
+        <p:spPr>
+          <a:xfrm>
+            <a:off x="10540974" y="3784591"/>
+            <a:ext cx="825498" cy="406399"/>
           </a:xfrm>
           <a:prstGeom prst="rect">
             <a:avLst/>
@@ -5150,7 +5806,7 @@
               <a:buNone/>
             </a:pPr>
             <a:r>
-              <a:rPr lang="en-US" sz="1350" b="1" dirty="0">
+              <a:rPr lang="en-US" sz="1150" b="1" dirty="0">
                 <a:solidFill>
                   <a:srgbClr val="38B6FF"/>
                 </a:solidFill>
@@ -5158,22 +5814,22 @@
                 <a:ea typeface="Arial" pitchFamily="34" charset="-122"/>
                 <a:cs typeface="Arial" pitchFamily="34" charset="-120"/>
               </a:rPr>
-              <a:t>± 800</a:t>
-            </a:r>
-            <a:endParaRPr lang="en-US" sz="1350" dirty="0"/>
-          </a:p>
-        </p:txBody>
-      </p:sp>
-      <p:sp>
-        <p:nvSpPr>
-          <p:cNvPr id="29" name="Shape 27"/>
+              <a:t>± 1.200</a:t>
+            </a:r>
+            <a:endParaRPr lang="en-US" sz="1150" dirty="0"/>
+          </a:p>
+        </p:txBody>
+      </p:sp>
+      <p:sp>
+        <p:nvSpPr>
+          <p:cNvPr id="49" name="Shape 47"/>
           <p:cNvSpPr/>
           <p:nvPr/>
         </p:nvSpPr>
         <p:spPr>
           <a:xfrm>
-            <a:off x="6527784" y="4216389"/>
-            <a:ext cx="4724388" cy="0"/>
+            <a:off x="8242279" y="4190990"/>
+            <a:ext cx="3124192" cy="0"/>
           </a:xfrm>
           <a:prstGeom prst="line">
             <a:avLst/>
@@ -5189,14 +5845,14 @@
       </p:sp>
       <p:sp>
         <p:nvSpPr>
-          <p:cNvPr id="30" name="Text 28"/>
-          <p:cNvSpPr txBox="1"/>
-          <p:nvPr/>
-        </p:nvSpPr>
-        <p:spPr>
-          <a:xfrm>
-            <a:off x="6527784" y="4216389"/>
-            <a:ext cx="3479791" cy="419099"/>
+          <p:cNvPr id="50" name="Text 48"/>
+          <p:cNvSpPr txBox="1"/>
+          <p:nvPr/>
+        </p:nvSpPr>
+        <p:spPr>
+          <a:xfrm>
+            <a:off x="8242279" y="4190990"/>
+            <a:ext cx="2578094" cy="406399"/>
           </a:xfrm>
           <a:prstGeom prst="rect">
             <a:avLst/>
@@ -5212,7 +5868,7 @@
               <a:buNone/>
             </a:pPr>
             <a:r>
-              <a:rPr lang="en-US" sz="1100" dirty="0">
+              <a:rPr lang="en-US" sz="950" dirty="0">
                 <a:solidFill>
                   <a:srgbClr val="C2C8D2"/>
                 </a:solidFill>
@@ -5222,20 +5878,20 @@
               </a:rPr>
               <a:t>Verwachte leads</a:t>
             </a:r>
-            <a:endParaRPr lang="en-US" sz="1100" dirty="0"/>
-          </a:p>
-        </p:txBody>
-      </p:sp>
-      <p:sp>
-        <p:nvSpPr>
-          <p:cNvPr id="31" name="Text 29"/>
-          <p:cNvSpPr txBox="1"/>
-          <p:nvPr/>
-        </p:nvSpPr>
-        <p:spPr>
-          <a:xfrm>
-            <a:off x="10007575" y="4216389"/>
-            <a:ext cx="1244597" cy="419099"/>
+            <a:endParaRPr lang="en-US" sz="950" dirty="0"/>
+          </a:p>
+        </p:txBody>
+      </p:sp>
+      <p:sp>
+        <p:nvSpPr>
+          <p:cNvPr id="51" name="Text 49"/>
+          <p:cNvSpPr txBox="1"/>
+          <p:nvPr/>
+        </p:nvSpPr>
+        <p:spPr>
+          <a:xfrm>
+            <a:off x="10540974" y="4190990"/>
+            <a:ext cx="825498" cy="406399"/>
           </a:xfrm>
           <a:prstGeom prst="rect">
             <a:avLst/>
@@ -5251,7 +5907,7 @@
               <a:buNone/>
             </a:pPr>
             <a:r>
-              <a:rPr lang="en-US" sz="1350" b="1" dirty="0">
+              <a:rPr lang="en-US" sz="1150" b="1" dirty="0">
                 <a:solidFill>
                   <a:srgbClr val="38B6FF"/>
                 </a:solidFill>
@@ -5259,22 +5915,22 @@
                 <a:ea typeface="Arial" pitchFamily="34" charset="-122"/>
                 <a:cs typeface="Arial" pitchFamily="34" charset="-120"/>
               </a:rPr>
-              <a:t>± 19</a:t>
-            </a:r>
-            <a:endParaRPr lang="en-US" sz="1350" dirty="0"/>
-          </a:p>
-        </p:txBody>
-      </p:sp>
-      <p:sp>
-        <p:nvSpPr>
-          <p:cNvPr id="32" name="Shape 30"/>
+              <a:t>± 28</a:t>
+            </a:r>
+            <a:endParaRPr lang="en-US" sz="1150" dirty="0"/>
+          </a:p>
+        </p:txBody>
+      </p:sp>
+      <p:sp>
+        <p:nvSpPr>
+          <p:cNvPr id="52" name="Shape 50"/>
           <p:cNvSpPr/>
           <p:nvPr/>
         </p:nvSpPr>
         <p:spPr>
           <a:xfrm>
-            <a:off x="6527784" y="4635488"/>
-            <a:ext cx="4724388" cy="0"/>
+            <a:off x="8242279" y="4597389"/>
+            <a:ext cx="3124192" cy="0"/>
           </a:xfrm>
           <a:prstGeom prst="line">
             <a:avLst/>
@@ -5290,14 +5946,14 @@
       </p:sp>
       <p:sp>
         <p:nvSpPr>
-          <p:cNvPr id="33" name="Text 31"/>
-          <p:cNvSpPr txBox="1"/>
-          <p:nvPr/>
-        </p:nvSpPr>
-        <p:spPr>
-          <a:xfrm>
-            <a:off x="6527784" y="4635488"/>
-            <a:ext cx="3479791" cy="419099"/>
+          <p:cNvPr id="53" name="Text 51"/>
+          <p:cNvSpPr txBox="1"/>
+          <p:nvPr/>
+        </p:nvSpPr>
+        <p:spPr>
+          <a:xfrm>
+            <a:off x="8242279" y="4597389"/>
+            <a:ext cx="2578094" cy="406399"/>
           </a:xfrm>
           <a:prstGeom prst="rect">
             <a:avLst/>
@@ -5313,7 +5969,7 @@
               <a:buNone/>
             </a:pPr>
             <a:r>
-              <a:rPr lang="en-US" sz="1100" dirty="0">
+              <a:rPr lang="en-US" sz="950" dirty="0">
                 <a:solidFill>
                   <a:srgbClr val="C2C8D2"/>
                 </a:solidFill>
@@ -5321,22 +5977,123 @@
                 <a:ea typeface="Arial" pitchFamily="34" charset="-122"/>
                 <a:cs typeface="Arial" pitchFamily="34" charset="-120"/>
               </a:rPr>
+              <a:t>Waarvan tastings</a:t>
+            </a:r>
+            <a:endParaRPr lang="en-US" sz="950" dirty="0"/>
+          </a:p>
+        </p:txBody>
+      </p:sp>
+      <p:sp>
+        <p:nvSpPr>
+          <p:cNvPr id="54" name="Text 52"/>
+          <p:cNvSpPr txBox="1"/>
+          <p:nvPr/>
+        </p:nvSpPr>
+        <p:spPr>
+          <a:xfrm>
+            <a:off x="10540974" y="4597389"/>
+            <a:ext cx="825498" cy="406399"/>
+          </a:xfrm>
+          <a:prstGeom prst="rect">
+            <a:avLst/>
+          </a:prstGeom>
+          <a:noFill/>
+          <a:ln/>
+        </p:spPr>
+        <p:txBody>
+          <a:bodyPr wrap="square" lIns="0" tIns="0" rIns="0" bIns="0" rtlCol="0" anchor="ctr"/>
+          <a:lstStyle/>
+          <a:p>
+            <a:pPr algn="r" indent="0" marL="0">
+              <a:buNone/>
+            </a:pPr>
+            <a:r>
+              <a:rPr lang="en-US" sz="1150" b="1" dirty="0">
+                <a:solidFill>
+                  <a:srgbClr val="38B6FF"/>
+                </a:solidFill>
+                <a:latin typeface="Arial" pitchFamily="34" charset="0"/>
+                <a:ea typeface="Arial" pitchFamily="34" charset="-122"/>
+                <a:cs typeface="Arial" pitchFamily="34" charset="-120"/>
+              </a:rPr>
+              <a:t>± 10</a:t>
+            </a:r>
+            <a:endParaRPr lang="en-US" sz="1150" dirty="0"/>
+          </a:p>
+        </p:txBody>
+      </p:sp>
+      <p:sp>
+        <p:nvSpPr>
+          <p:cNvPr id="55" name="Shape 53"/>
+          <p:cNvSpPr/>
+          <p:nvPr/>
+        </p:nvSpPr>
+        <p:spPr>
+          <a:xfrm>
+            <a:off x="8242279" y="5003787"/>
+            <a:ext cx="3124192" cy="0"/>
+          </a:xfrm>
+          <a:prstGeom prst="line">
+            <a:avLst/>
+          </a:prstGeom>
+          <a:noFill/>
+          <a:ln w="9525">
+            <a:solidFill>
+              <a:srgbClr val="3A4152"/>
+            </a:solidFill>
+            <a:prstDash val="solid"/>
+          </a:ln>
+        </p:spPr>
+      </p:sp>
+      <p:sp>
+        <p:nvSpPr>
+          <p:cNvPr id="56" name="Text 54"/>
+          <p:cNvSpPr txBox="1"/>
+          <p:nvPr/>
+        </p:nvSpPr>
+        <p:spPr>
+          <a:xfrm>
+            <a:off x="8242279" y="5003787"/>
+            <a:ext cx="2578094" cy="406399"/>
+          </a:xfrm>
+          <a:prstGeom prst="rect">
+            <a:avLst/>
+          </a:prstGeom>
+          <a:noFill/>
+          <a:ln/>
+        </p:spPr>
+        <p:txBody>
+          <a:bodyPr wrap="square" lIns="0" tIns="0" rIns="0" bIns="0" rtlCol="0" anchor="ctr"/>
+          <a:lstStyle/>
+          <a:p>
+            <a:pPr indent="0" marL="0">
+              <a:buNone/>
+            </a:pPr>
+            <a:r>
+              <a:rPr lang="en-US" sz="950" dirty="0">
+                <a:solidFill>
+                  <a:srgbClr val="C2C8D2"/>
+                </a:solidFill>
+                <a:latin typeface="Arial" pitchFamily="34" charset="0"/>
+                <a:ea typeface="Arial" pitchFamily="34" charset="-122"/>
+                <a:cs typeface="Arial" pitchFamily="34" charset="-120"/>
+              </a:rPr>
               <a:t>Prijs per lead</a:t>
             </a:r>
-            <a:endParaRPr lang="en-US" sz="1100" dirty="0"/>
-          </a:p>
-        </p:txBody>
-      </p:sp>
-      <p:sp>
-        <p:nvSpPr>
-          <p:cNvPr id="34" name="Text 32"/>
-          <p:cNvSpPr txBox="1"/>
-          <p:nvPr/>
-        </p:nvSpPr>
-        <p:spPr>
-          <a:xfrm>
-            <a:off x="10007575" y="4635488"/>
-            <a:ext cx="1244597" cy="419099"/>
+            <a:endParaRPr lang="en-US" sz="950" dirty="0"/>
+          </a:p>
+        </p:txBody>
+      </p:sp>
+      <p:sp>
+        <p:nvSpPr>
+          <p:cNvPr id="57" name="Text 55"/>
+          <p:cNvSpPr txBox="1"/>
+          <p:nvPr/>
+        </p:nvSpPr>
+        <p:spPr>
+          <a:xfrm>
+            <a:off x="10540974" y="5003787"/>
+            <a:ext cx="825498" cy="406399"/>
           </a:xfrm>
           <a:prstGeom prst="rect">
             <a:avLst/>
@@ -5352,7 +6109,7 @@
               <a:buNone/>
             </a:pPr>
             <a:r>
-              <a:rPr lang="en-US" sz="1350" b="1" dirty="0">
+              <a:rPr lang="en-US" sz="1150" b="1" dirty="0">
                 <a:solidFill>
                   <a:srgbClr val="38B6FF"/>
                 </a:solidFill>
@@ -5360,15 +6117,15 @@
                 <a:ea typeface="Arial" pitchFamily="34" charset="-122"/>
                 <a:cs typeface="Arial" pitchFamily="34" charset="-120"/>
               </a:rPr>
-              <a:t>€ 215</a:t>
-            </a:r>
-            <a:endParaRPr lang="en-US" sz="1350" dirty="0"/>
-          </a:p>
-        </p:txBody>
-      </p:sp>
-      <p:sp>
-        <p:nvSpPr>
-          <p:cNvPr id="35" name="Shape 33"/>
+              <a:t>€ 216</a:t>
+            </a:r>
+            <a:endParaRPr lang="en-US" sz="1150" dirty="0"/>
+          </a:p>
+        </p:txBody>
+      </p:sp>
+      <p:sp>
+        <p:nvSpPr>
+          <p:cNvPr id="58" name="Shape 56"/>
           <p:cNvSpPr/>
           <p:nvPr/>
         </p:nvSpPr>
@@ -5388,7 +6145,7 @@
       </p:sp>
       <p:sp>
         <p:nvSpPr>
-          <p:cNvPr id="36" name="Text 34"/>
+          <p:cNvPr id="59" name="Text 57"/>
           <p:cNvSpPr txBox="1"/>
           <p:nvPr/>
         </p:nvSpPr>
@@ -5419,7 +6176,7 @@
                 <a:ea typeface="Arial" pitchFamily="34" charset="-122"/>
                 <a:cs typeface="Arial" pitchFamily="34" charset="-120"/>
               </a:rPr>
-              <a:t>Acht beldagen is 93 procent meer gesprekken dan we nu per periode voeren, tegen vrijwel dezelfde prijs per lead. En jullie weten vooraf wat een periode kost, in plaats van achteraf.</a:t>
+              <a:t>De bezetting en de bellijst liggen er al. Verdubbelen kan vanaf de eerstvolgende periode, verdriedubbelen ook, en de prijs per lead blijft rond € 215.</a:t>
             </a:r>
             <a:endParaRPr lang="en-US" sz="1200" dirty="0"/>
           </a:p>
@@ -8438,7 +9195,7 @@
                 <a:ea typeface="Arial" pitchFamily="34" charset="-122"/>
                 <a:cs typeface="Arial" pitchFamily="34" charset="-120"/>
               </a:rPr>
-              <a:t>Jullie kiezen hoeveel beldagen per vier weken. Ons advies is acht.</a:t>
+              <a:t>Jullie kiezen hoeveel beldagen per vier weken. Verdubbelen of verdriedubbelen kan allebei direct.</a:t>
             </a:r>
             <a:endParaRPr lang="en-US" sz="1100" dirty="0"/>
           </a:p>

</xml_diff>

<commit_message>
Moyee: wat een klant oplevert als eigen onderdeel in deck en sheet
300 kg per jaar, 6.192,75 euro omzet, 29 leads per klant, 9 klanten voor
een heel jaar bellen. Klantwaarde staat in moyee-stats.json.

Co-Authored-By: Claude Opus 5 <noreply@anthropic.com>
Claude-Session: https://claude.ai/code/session_0141FN3f3hHkYQHTyvTJJGrw
</commit_message>
<xml_diff>
--- a/output/LINK. voorstel Moyee Coffee.pptx
+++ b/output/LINK. voorstel Moyee Coffee.pptx
@@ -19,9 +19,10 @@
     <p:sldId id="267" r:id="rId13"/>
     <p:sldId id="268" r:id="rId14"/>
     <p:sldId id="269" r:id="rId15"/>
+    <p:sldId id="270" r:id="rId16"/>
   </p:sldIdLst>
   <p:notesMasterIdLst>
-    <p:notesMasterId r:id="rId16"/>
+    <p:notesMasterId r:id="rId17"/>
   </p:notesMasterIdLst>
   <p:sldSz cx="12191970" cy="6858000"/>
   <p:notesSz cx="6858000" cy="12191970"/>
@@ -979,6 +980,94 @@
             <a:fld id="{F7021451-1387-4CA6-816F-3879F97B5CBC}" type="slidenum">
               <a:rPr lang="en-US"/>
               <a:t>14</a:t>
+            </a:fld>
+            <a:endParaRPr lang="en-US"/>
+          </a:p>
+        </p:txBody>
+      </p:sp>
+    </p:spTree>
+    <p:extLst>
+      <p:ext uri="{BB962C8B-B14F-4D97-AF65-F5344CB8AC3E}">
+        <p14:creationId xmlns:p14="http://schemas.microsoft.com/office/powerpoint/2010/main" val="1024086991"/>
+      </p:ext>
+    </p:extLst>
+  </p:cSld>
+  <p:clrMapOvr>
+    <a:masterClrMapping/>
+  </p:clrMapOvr>
+</p:notes>
+</file>
+
+<file path=ppt/notesSlides/notesSlide15.xml><?xml version="1.0" encoding="utf-8"?>
+<p:notes xmlns:a="http://schemas.openxmlformats.org/drawingml/2006/main" xmlns:r="http://schemas.openxmlformats.org/officeDocument/2006/relationships" xmlns:p="http://schemas.openxmlformats.org/presentationml/2006/main">
+  <p:cSld>
+    <p:spTree>
+      <p:nvGrpSpPr>
+        <p:cNvPr id="1" name=""/>
+        <p:cNvGrpSpPr/>
+        <p:nvPr/>
+      </p:nvGrpSpPr>
+      <p:grpSpPr>
+        <a:xfrm>
+          <a:off x="0" y="0"/>
+          <a:ext cx="0" cy="0"/>
+          <a:chOff x="0" y="0"/>
+          <a:chExt cx="0" cy="0"/>
+        </a:xfrm>
+      </p:grpSpPr>
+      <p:sp>
+        <p:nvSpPr>
+          <p:cNvPr id="2" name="Slide Image Placeholder 1"/>
+          <p:cNvSpPr>
+            <a:spLocks noGrp="1" noRot="1" noChangeAspect="1"/>
+          </p:cNvSpPr>
+          <p:nvPr>
+            <p:ph type="sldImg"/>
+          </p:nvPr>
+        </p:nvSpPr>
+        <p:spPr/>
+      </p:sp>
+      <p:sp>
+        <p:nvSpPr>
+          <p:cNvPr id="3" name="Notes Placeholder 2"/>
+          <p:cNvSpPr>
+            <a:spLocks noGrp="1"/>
+          </p:cNvSpPr>
+          <p:nvPr>
+            <p:ph type="body" idx="1"/>
+          </p:nvPr>
+        </p:nvSpPr>
+        <p:spPr/>
+        <p:txBody>
+          <a:bodyPr/>
+          <a:lstStyle/>
+          <a:p>
+            <a:r>
+              <a:rPr lang="en-US" dirty="0"/>
+              <a:t/>
+            </a:r>
+            <a:endParaRPr lang="en-US" dirty="0"/>
+          </a:p>
+        </p:txBody>
+      </p:sp>
+      <p:sp>
+        <p:nvSpPr>
+          <p:cNvPr id="4" name="Slide Number Placeholder 3"/>
+          <p:cNvSpPr>
+            <a:spLocks noGrp="1"/>
+          </p:cNvSpPr>
+          <p:nvPr>
+            <p:ph type="sldNum" sz="quarter" idx="10"/>
+          </p:nvPr>
+        </p:nvSpPr>
+        <p:spPr/>
+        <p:txBody>
+          <a:bodyPr/>
+          <a:lstStyle/>
+          <a:p>
+            <a:fld id="{F7021451-1387-4CA6-816F-3879F97B5CBC}" type="slidenum">
+              <a:rPr lang="en-US"/>
+              <a:t>15</a:t>
             </a:fld>
             <a:endParaRPr lang="en-US"/>
           </a:p>
@@ -2718,7 +2807,7 @@
                 <a:ea typeface="Arial" pitchFamily="34" charset="-122"/>
                 <a:cs typeface="Arial" pitchFamily="34" charset="-120"/>
               </a:rPr>
-              <a:t>1 / 14</a:t>
+              <a:t>1 / 15</a:t>
             </a:r>
             <a:endParaRPr lang="en-US" sz="750" dirty="0"/>
           </a:p>
@@ -3193,7 +3282,7 @@
                 <a:ea typeface="Arial" pitchFamily="34" charset="-122"/>
                 <a:cs typeface="Arial" pitchFamily="34" charset="-120"/>
               </a:rPr>
-              <a:t>10 / 14</a:t>
+              <a:t>10 / 15</a:t>
             </a:r>
             <a:endParaRPr lang="en-US" sz="750" dirty="0"/>
           </a:p>
@@ -4247,7 +4336,7 @@
                 <a:ea typeface="Arial" pitchFamily="34" charset="-122"/>
                 <a:cs typeface="Arial" pitchFamily="34" charset="-120"/>
               </a:rPr>
-              <a:t>11 / 14</a:t>
+              <a:t>11 / 15</a:t>
             </a:r>
             <a:endParaRPr lang="en-US" sz="750" dirty="0"/>
           </a:p>
@@ -6193,6 +6282,911 @@
 <file path=ppt/slides/slide12.xml><?xml version="1.0" encoding="utf-8"?>
 <p:sld xmlns:a="http://schemas.openxmlformats.org/drawingml/2006/main" xmlns:r="http://schemas.openxmlformats.org/officeDocument/2006/relationships" xmlns:p="http://schemas.openxmlformats.org/presentationml/2006/main">
   <p:cSld name="Slide 12">
+    <p:bg>
+      <p:bgPr>
+        <a:solidFill>
+          <a:srgbClr val="E9E0CD"/>
+        </a:solidFill>
+      </p:bgPr>
+    </p:bg>
+    <p:spTree>
+      <p:nvGrpSpPr>
+        <p:cNvPr id="1" name=""/>
+        <p:cNvGrpSpPr/>
+        <p:nvPr/>
+      </p:nvGrpSpPr>
+      <p:grpSpPr>
+        <a:xfrm>
+          <a:off x="0" y="0"/>
+          <a:ext cx="0" cy="0"/>
+          <a:chOff x="0" y="0"/>
+          <a:chExt cx="0" cy="0"/>
+        </a:xfrm>
+      </p:grpSpPr>
+      <p:sp>
+        <p:nvSpPr>
+          <p:cNvPr id="2" name="Text 0"/>
+          <p:cNvSpPr txBox="1"/>
+          <p:nvPr/>
+        </p:nvSpPr>
+        <p:spPr>
+          <a:xfrm>
+            <a:off x="596899" y="368299"/>
+            <a:ext cx="1904995" cy="330199"/>
+          </a:xfrm>
+          <a:prstGeom prst="rect">
+            <a:avLst/>
+          </a:prstGeom>
+          <a:noFill/>
+          <a:ln/>
+        </p:spPr>
+        <p:txBody>
+          <a:bodyPr wrap="square" lIns="0" tIns="0" rIns="0" bIns="0" rtlCol="0" anchor="ctr"/>
+          <a:lstStyle/>
+          <a:p>
+            <a:pPr algn="l" indent="0" marL="0">
+              <a:buNone/>
+            </a:pPr>
+            <a:r>
+              <a:rPr lang="en-US" sz="1800" b="1" dirty="0">
+                <a:solidFill>
+                  <a:srgbClr val="1C2230"/>
+                </a:solidFill>
+                <a:latin typeface="Arial" pitchFamily="34" charset="0"/>
+                <a:ea typeface="Arial" pitchFamily="34" charset="-122"/>
+                <a:cs typeface="Arial" pitchFamily="34" charset="-120"/>
+              </a:rPr>
+              <a:t>LINK</a:t>
+            </a:r>
+            <a:pPr algn="l" indent="0" marL="0">
+              <a:buNone/>
+            </a:pPr>
+            <a:r>
+              <a:rPr lang="en-US" sz="1800" b="1" dirty="0">
+                <a:solidFill>
+                  <a:srgbClr val="38B6FF"/>
+                </a:solidFill>
+                <a:latin typeface="Arial" pitchFamily="34" charset="0"/>
+                <a:ea typeface="Arial" pitchFamily="34" charset="-122"/>
+                <a:cs typeface="Arial" pitchFamily="34" charset="-120"/>
+              </a:rPr>
+              <a:t>.</a:t>
+            </a:r>
+            <a:endParaRPr lang="en-US" sz="1800" dirty="0"/>
+          </a:p>
+        </p:txBody>
+      </p:sp>
+      <p:sp>
+        <p:nvSpPr>
+          <p:cNvPr id="3" name="Text 1"/>
+          <p:cNvSpPr txBox="1"/>
+          <p:nvPr/>
+        </p:nvSpPr>
+        <p:spPr>
+          <a:xfrm>
+            <a:off x="609598" y="6381734"/>
+            <a:ext cx="5714986" cy="228599"/>
+          </a:xfrm>
+          <a:prstGeom prst="rect">
+            <a:avLst/>
+          </a:prstGeom>
+          <a:noFill/>
+          <a:ln/>
+        </p:spPr>
+        <p:txBody>
+          <a:bodyPr wrap="square" lIns="0" tIns="0" rIns="0" bIns="0" rtlCol="0" anchor="ctr"/>
+          <a:lstStyle/>
+          <a:p>
+            <a:pPr algn="l" indent="0" marL="0">
+              <a:buNone/>
+            </a:pPr>
+            <a:r>
+              <a:rPr lang="en-US" sz="750" b="1" spc="100" kern="0" dirty="0">
+                <a:solidFill>
+                  <a:srgbClr val="6F6A5C"/>
+                </a:solidFill>
+                <a:latin typeface="Arial" pitchFamily="34" charset="0"/>
+                <a:ea typeface="Arial" pitchFamily="34" charset="-122"/>
+                <a:cs typeface="Arial" pitchFamily="34" charset="-120"/>
+              </a:rPr>
+              <a:t>LINK. · Moyee Coffee</a:t>
+            </a:r>
+            <a:endParaRPr lang="en-US" sz="750" dirty="0"/>
+          </a:p>
+        </p:txBody>
+      </p:sp>
+      <p:sp>
+        <p:nvSpPr>
+          <p:cNvPr id="4" name="Text 2"/>
+          <p:cNvSpPr txBox="1"/>
+          <p:nvPr/>
+        </p:nvSpPr>
+        <p:spPr>
+          <a:xfrm>
+            <a:off x="9677376" y="6381734"/>
+            <a:ext cx="1904995" cy="228599"/>
+          </a:xfrm>
+          <a:prstGeom prst="rect">
+            <a:avLst/>
+          </a:prstGeom>
+          <a:noFill/>
+          <a:ln/>
+        </p:spPr>
+        <p:txBody>
+          <a:bodyPr wrap="square" lIns="0" tIns="0" rIns="0" bIns="0" rtlCol="0" anchor="ctr"/>
+          <a:lstStyle/>
+          <a:p>
+            <a:pPr algn="r" indent="0" marL="0">
+              <a:buNone/>
+            </a:pPr>
+            <a:r>
+              <a:rPr lang="en-US" sz="750" b="1" spc="100" kern="0" dirty="0">
+                <a:solidFill>
+                  <a:srgbClr val="6F6A5C"/>
+                </a:solidFill>
+                <a:latin typeface="Arial" pitchFamily="34" charset="0"/>
+                <a:ea typeface="Arial" pitchFamily="34" charset="-122"/>
+                <a:cs typeface="Arial" pitchFamily="34" charset="-120"/>
+              </a:rPr>
+              <a:t>12 / 15</a:t>
+            </a:r>
+            <a:endParaRPr lang="en-US" sz="750" dirty="0"/>
+          </a:p>
+        </p:txBody>
+      </p:sp>
+      <p:sp>
+        <p:nvSpPr>
+          <p:cNvPr id="5" name="Text 3"/>
+          <p:cNvSpPr txBox="1"/>
+          <p:nvPr/>
+        </p:nvSpPr>
+        <p:spPr>
+          <a:xfrm>
+            <a:off x="609598" y="1206497"/>
+            <a:ext cx="10159975" cy="215899"/>
+          </a:xfrm>
+          <a:prstGeom prst="rect">
+            <a:avLst/>
+          </a:prstGeom>
+          <a:noFill/>
+          <a:ln/>
+        </p:spPr>
+        <p:txBody>
+          <a:bodyPr wrap="square" lIns="0" tIns="0" rIns="0" bIns="0" rtlCol="0" anchor="ctr"/>
+          <a:lstStyle/>
+          <a:p>
+            <a:pPr algn="l" indent="0" marL="0">
+              <a:buNone/>
+            </a:pPr>
+            <a:r>
+              <a:rPr lang="en-US" sz="950" b="1" spc="400" kern="0" dirty="0">
+                <a:solidFill>
+                  <a:srgbClr val="38B6FF"/>
+                </a:solidFill>
+                <a:latin typeface="Arial" pitchFamily="34" charset="0"/>
+                <a:ea typeface="Arial" pitchFamily="34" charset="-122"/>
+                <a:cs typeface="Arial" pitchFamily="34" charset="-120"/>
+              </a:rPr>
+              <a:t>WAT ER TEGENOVER STAAT</a:t>
+            </a:r>
+            <a:endParaRPr lang="en-US" sz="950" dirty="0"/>
+          </a:p>
+        </p:txBody>
+      </p:sp>
+      <p:sp>
+        <p:nvSpPr>
+          <p:cNvPr id="6" name="Text 4"/>
+          <p:cNvSpPr txBox="1"/>
+          <p:nvPr/>
+        </p:nvSpPr>
+        <p:spPr>
+          <a:xfrm>
+            <a:off x="609598" y="1511296"/>
+            <a:ext cx="10972773" cy="1142997"/>
+          </a:xfrm>
+          <a:prstGeom prst="rect">
+            <a:avLst/>
+          </a:prstGeom>
+          <a:noFill/>
+          <a:ln/>
+        </p:spPr>
+        <p:txBody>
+          <a:bodyPr wrap="square" lIns="0" tIns="0" rIns="0" bIns="0" rtlCol="0" anchor="t"/>
+          <a:lstStyle/>
+          <a:p>
+            <a:pPr algn="l" indent="0" marL="0">
+              <a:lnSpc>
+                <a:spcPct val="108000"/>
+              </a:lnSpc>
+              <a:buNone/>
+            </a:pPr>
+            <a:r>
+              <a:rPr lang="en-US" sz="3200" b="1" dirty="0">
+                <a:solidFill>
+                  <a:srgbClr val="1C2230"/>
+                </a:solidFill>
+                <a:latin typeface="Arial" pitchFamily="34" charset="0"/>
+                <a:ea typeface="Arial" pitchFamily="34" charset="-122"/>
+                <a:cs typeface="Arial" pitchFamily="34" charset="-120"/>
+              </a:rPr>
+              <a:t>Eén nieuwe klant betaalt </a:t>
+            </a:r>
+            <a:pPr algn="l" indent="0" marL="0">
+              <a:lnSpc>
+                <a:spcPct val="108000"/>
+              </a:lnSpc>
+              <a:buNone/>
+            </a:pPr>
+            <a:r>
+              <a:rPr lang="en-US" sz="3000" i="1" dirty="0">
+                <a:solidFill>
+                  <a:srgbClr val="1C2230"/>
+                </a:solidFill>
+                <a:latin typeface="Georgia" pitchFamily="34" charset="0"/>
+                <a:ea typeface="Georgia" pitchFamily="34" charset="-122"/>
+                <a:cs typeface="Georgia" pitchFamily="34" charset="-120"/>
+              </a:rPr>
+              <a:t>29 leads</a:t>
+            </a:r>
+            <a:pPr algn="l" indent="0" marL="0">
+              <a:lnSpc>
+                <a:spcPct val="108000"/>
+              </a:lnSpc>
+              <a:buNone/>
+            </a:pPr>
+            <a:r>
+              <a:rPr lang="en-US" sz="3200" b="1" dirty="0">
+                <a:solidFill>
+                  <a:srgbClr val="1C2230"/>
+                </a:solidFill>
+                <a:latin typeface="Arial" pitchFamily="34" charset="0"/>
+                <a:ea typeface="Arial" pitchFamily="34" charset="-122"/>
+                <a:cs typeface="Arial" pitchFamily="34" charset="-120"/>
+              </a:rPr>
+              <a:t> terug.</a:t>
+            </a:r>
+            <a:endParaRPr lang="en-US" sz="3200" dirty="0"/>
+          </a:p>
+        </p:txBody>
+      </p:sp>
+      <p:sp>
+        <p:nvSpPr>
+          <p:cNvPr id="7" name="Shape 5"/>
+          <p:cNvSpPr/>
+          <p:nvPr/>
+        </p:nvSpPr>
+        <p:spPr>
+          <a:xfrm>
+            <a:off x="609598" y="2730493"/>
+            <a:ext cx="2628893" cy="2222494"/>
+          </a:xfrm>
+          <a:prstGeom prst="roundRect">
+            <a:avLst>
+              <a:gd name="adj" fmla="val 4571"/>
+            </a:avLst>
+          </a:prstGeom>
+          <a:solidFill>
+            <a:srgbClr val="F8F4EB"/>
+          </a:solidFill>
+          <a:ln/>
+        </p:spPr>
+      </p:sp>
+      <p:sp>
+        <p:nvSpPr>
+          <p:cNvPr id="8" name="Text 6"/>
+          <p:cNvSpPr txBox="1"/>
+          <p:nvPr/>
+        </p:nvSpPr>
+        <p:spPr>
+          <a:xfrm>
+            <a:off x="850898" y="2997193"/>
+            <a:ext cx="2146295" cy="507999"/>
+          </a:xfrm>
+          <a:prstGeom prst="rect">
+            <a:avLst/>
+          </a:prstGeom>
+          <a:noFill/>
+          <a:ln/>
+        </p:spPr>
+        <p:txBody>
+          <a:bodyPr wrap="square" lIns="0" tIns="0" rIns="0" bIns="0" rtlCol="0" anchor="ctr"/>
+          <a:lstStyle/>
+          <a:p>
+            <a:pPr indent="0" marL="0">
+              <a:buNone/>
+            </a:pPr>
+            <a:r>
+              <a:rPr lang="en-US" sz="3600" b="1" dirty="0">
+                <a:solidFill>
+                  <a:srgbClr val="1C2230"/>
+                </a:solidFill>
+                <a:latin typeface="Arial" pitchFamily="34" charset="0"/>
+                <a:ea typeface="Arial" pitchFamily="34" charset="-122"/>
+                <a:cs typeface="Arial" pitchFamily="34" charset="-120"/>
+              </a:rPr>
+              <a:t>300 kg</a:t>
+            </a:r>
+            <a:endParaRPr lang="en-US" sz="3600" dirty="0"/>
+          </a:p>
+        </p:txBody>
+      </p:sp>
+      <p:sp>
+        <p:nvSpPr>
+          <p:cNvPr id="9" name="Text 7"/>
+          <p:cNvSpPr txBox="1"/>
+          <p:nvPr/>
+        </p:nvSpPr>
+        <p:spPr>
+          <a:xfrm>
+            <a:off x="850898" y="3555991"/>
+            <a:ext cx="2146295" cy="215899"/>
+          </a:xfrm>
+          <a:prstGeom prst="rect">
+            <a:avLst/>
+          </a:prstGeom>
+          <a:noFill/>
+          <a:ln/>
+        </p:spPr>
+        <p:txBody>
+          <a:bodyPr wrap="square" lIns="0" tIns="0" rIns="0" bIns="0" rtlCol="0" anchor="ctr"/>
+          <a:lstStyle/>
+          <a:p>
+            <a:pPr indent="0" marL="0">
+              <a:buNone/>
+            </a:pPr>
+            <a:r>
+              <a:rPr lang="en-US" sz="900" b="1" spc="120" kern="0" dirty="0">
+                <a:solidFill>
+                  <a:srgbClr val="38B6FF"/>
+                </a:solidFill>
+                <a:latin typeface="Arial" pitchFamily="34" charset="0"/>
+                <a:ea typeface="Arial" pitchFamily="34" charset="-122"/>
+                <a:cs typeface="Arial" pitchFamily="34" charset="-120"/>
+              </a:rPr>
+              <a:t>KOFFIE PER JAAR</a:t>
+            </a:r>
+            <a:endParaRPr lang="en-US" sz="900" dirty="0"/>
+          </a:p>
+        </p:txBody>
+      </p:sp>
+      <p:sp>
+        <p:nvSpPr>
+          <p:cNvPr id="10" name="Text 8"/>
+          <p:cNvSpPr txBox="1"/>
+          <p:nvPr/>
+        </p:nvSpPr>
+        <p:spPr>
+          <a:xfrm>
+            <a:off x="850898" y="3975090"/>
+            <a:ext cx="2146295" cy="888998"/>
+          </a:xfrm>
+          <a:prstGeom prst="rect">
+            <a:avLst/>
+          </a:prstGeom>
+          <a:noFill/>
+          <a:ln/>
+        </p:spPr>
+        <p:txBody>
+          <a:bodyPr wrap="square" lIns="0" tIns="0" rIns="0" bIns="0" rtlCol="0" anchor="t"/>
+          <a:lstStyle/>
+          <a:p>
+            <a:pPr indent="0" marL="0">
+              <a:lnSpc>
+                <a:spcPct val="135000"/>
+              </a:lnSpc>
+              <a:buNone/>
+            </a:pPr>
+            <a:r>
+              <a:rPr lang="en-US" sz="950" dirty="0">
+                <a:solidFill>
+                  <a:srgbClr val="6F6A5C"/>
+                </a:solidFill>
+                <a:latin typeface="Arial" pitchFamily="34" charset="0"/>
+                <a:ea typeface="Arial" pitchFamily="34" charset="-122"/>
+                <a:cs typeface="Arial" pitchFamily="34" charset="-120"/>
+              </a:rPr>
+              <a:t>Het verbruik van één kantoor waar we een tasting hebben ingepland. Geen uitschieter, gewoon een normaal kantoor.</a:t>
+            </a:r>
+            <a:endParaRPr lang="en-US" sz="950" dirty="0"/>
+          </a:p>
+        </p:txBody>
+      </p:sp>
+      <p:sp>
+        <p:nvSpPr>
+          <p:cNvPr id="11" name="Shape 9"/>
+          <p:cNvSpPr/>
+          <p:nvPr/>
+        </p:nvSpPr>
+        <p:spPr>
+          <a:xfrm>
+            <a:off x="3390892" y="2730493"/>
+            <a:ext cx="2628893" cy="2222494"/>
+          </a:xfrm>
+          <a:prstGeom prst="roundRect">
+            <a:avLst>
+              <a:gd name="adj" fmla="val 4571"/>
+            </a:avLst>
+          </a:prstGeom>
+          <a:solidFill>
+            <a:srgbClr val="F8F4EB"/>
+          </a:solidFill>
+          <a:ln/>
+        </p:spPr>
+      </p:sp>
+      <p:sp>
+        <p:nvSpPr>
+          <p:cNvPr id="12" name="Text 10"/>
+          <p:cNvSpPr txBox="1"/>
+          <p:nvPr/>
+        </p:nvSpPr>
+        <p:spPr>
+          <a:xfrm>
+            <a:off x="3632191" y="2997193"/>
+            <a:ext cx="2146295" cy="507999"/>
+          </a:xfrm>
+          <a:prstGeom prst="rect">
+            <a:avLst/>
+          </a:prstGeom>
+          <a:noFill/>
+          <a:ln/>
+        </p:spPr>
+        <p:txBody>
+          <a:bodyPr wrap="square" lIns="0" tIns="0" rIns="0" bIns="0" rtlCol="0" anchor="ctr"/>
+          <a:lstStyle/>
+          <a:p>
+            <a:pPr indent="0" marL="0">
+              <a:buNone/>
+            </a:pPr>
+            <a:r>
+              <a:rPr lang="en-US" sz="3600" b="1" dirty="0">
+                <a:solidFill>
+                  <a:srgbClr val="1C2230"/>
+                </a:solidFill>
+                <a:latin typeface="Arial" pitchFamily="34" charset="0"/>
+                <a:ea typeface="Arial" pitchFamily="34" charset="-122"/>
+                <a:cs typeface="Arial" pitchFamily="34" charset="-120"/>
+              </a:rPr>
+              <a:t>€ 6.193</a:t>
+            </a:r>
+            <a:endParaRPr lang="en-US" sz="3600" dirty="0"/>
+          </a:p>
+        </p:txBody>
+      </p:sp>
+      <p:sp>
+        <p:nvSpPr>
+          <p:cNvPr id="13" name="Text 11"/>
+          <p:cNvSpPr txBox="1"/>
+          <p:nvPr/>
+        </p:nvSpPr>
+        <p:spPr>
+          <a:xfrm>
+            <a:off x="3632191" y="3555991"/>
+            <a:ext cx="2146295" cy="215899"/>
+          </a:xfrm>
+          <a:prstGeom prst="rect">
+            <a:avLst/>
+          </a:prstGeom>
+          <a:noFill/>
+          <a:ln/>
+        </p:spPr>
+        <p:txBody>
+          <a:bodyPr wrap="square" lIns="0" tIns="0" rIns="0" bIns="0" rtlCol="0" anchor="ctr"/>
+          <a:lstStyle/>
+          <a:p>
+            <a:pPr indent="0" marL="0">
+              <a:buNone/>
+            </a:pPr>
+            <a:r>
+              <a:rPr lang="en-US" sz="900" b="1" spc="120" kern="0" dirty="0">
+                <a:solidFill>
+                  <a:srgbClr val="38B6FF"/>
+                </a:solidFill>
+                <a:latin typeface="Arial" pitchFamily="34" charset="0"/>
+                <a:ea typeface="Arial" pitchFamily="34" charset="-122"/>
+                <a:cs typeface="Arial" pitchFamily="34" charset="-120"/>
+              </a:rPr>
+              <a:t>OMZET PER JAAR</a:t>
+            </a:r>
+            <a:endParaRPr lang="en-US" sz="900" dirty="0"/>
+          </a:p>
+        </p:txBody>
+      </p:sp>
+      <p:sp>
+        <p:nvSpPr>
+          <p:cNvPr id="14" name="Text 12"/>
+          <p:cNvSpPr txBox="1"/>
+          <p:nvPr/>
+        </p:nvSpPr>
+        <p:spPr>
+          <a:xfrm>
+            <a:off x="3632191" y="3975090"/>
+            <a:ext cx="2146295" cy="888998"/>
+          </a:xfrm>
+          <a:prstGeom prst="rect">
+            <a:avLst/>
+          </a:prstGeom>
+          <a:noFill/>
+          <a:ln/>
+        </p:spPr>
+        <p:txBody>
+          <a:bodyPr wrap="square" lIns="0" tIns="0" rIns="0" bIns="0" rtlCol="0" anchor="t"/>
+          <a:lstStyle/>
+          <a:p>
+            <a:pPr indent="0" marL="0">
+              <a:lnSpc>
+                <a:spcPct val="135000"/>
+              </a:lnSpc>
+              <a:buNone/>
+            </a:pPr>
+            <a:r>
+              <a:rPr lang="en-US" sz="950" dirty="0">
+                <a:solidFill>
+                  <a:srgbClr val="6F6A5C"/>
+                </a:solidFill>
+                <a:latin typeface="Arial" pitchFamily="34" charset="0"/>
+                <a:ea typeface="Arial" pitchFamily="34" charset="-122"/>
+                <a:cs typeface="Arial" pitchFamily="34" charset="-120"/>
+              </a:rPr>
+              <a:t>Alleen de koffie, tegen € 20,64 per kilo. Cross- en upsell zitten er nog niet in.</a:t>
+            </a:r>
+            <a:endParaRPr lang="en-US" sz="950" dirty="0"/>
+          </a:p>
+        </p:txBody>
+      </p:sp>
+      <p:sp>
+        <p:nvSpPr>
+          <p:cNvPr id="15" name="Shape 13"/>
+          <p:cNvSpPr/>
+          <p:nvPr/>
+        </p:nvSpPr>
+        <p:spPr>
+          <a:xfrm>
+            <a:off x="6172185" y="2730493"/>
+            <a:ext cx="2628893" cy="2222494"/>
+          </a:xfrm>
+          <a:prstGeom prst="roundRect">
+            <a:avLst>
+              <a:gd name="adj" fmla="val 4571"/>
+            </a:avLst>
+          </a:prstGeom>
+          <a:solidFill>
+            <a:srgbClr val="F8F4EB"/>
+          </a:solidFill>
+          <a:ln/>
+        </p:spPr>
+      </p:sp>
+      <p:sp>
+        <p:nvSpPr>
+          <p:cNvPr id="16" name="Text 14"/>
+          <p:cNvSpPr txBox="1"/>
+          <p:nvPr/>
+        </p:nvSpPr>
+        <p:spPr>
+          <a:xfrm>
+            <a:off x="6413484" y="2997193"/>
+            <a:ext cx="2146295" cy="507999"/>
+          </a:xfrm>
+          <a:prstGeom prst="rect">
+            <a:avLst/>
+          </a:prstGeom>
+          <a:noFill/>
+          <a:ln/>
+        </p:spPr>
+        <p:txBody>
+          <a:bodyPr wrap="square" lIns="0" tIns="0" rIns="0" bIns="0" rtlCol="0" anchor="ctr"/>
+          <a:lstStyle/>
+          <a:p>
+            <a:pPr indent="0" marL="0">
+              <a:buNone/>
+            </a:pPr>
+            <a:r>
+              <a:rPr lang="en-US" sz="3600" b="1" dirty="0">
+                <a:solidFill>
+                  <a:srgbClr val="1C2230"/>
+                </a:solidFill>
+                <a:latin typeface="Arial" pitchFamily="34" charset="0"/>
+                <a:ea typeface="Arial" pitchFamily="34" charset="-122"/>
+                <a:cs typeface="Arial" pitchFamily="34" charset="-120"/>
+              </a:rPr>
+              <a:t>€ 215</a:t>
+            </a:r>
+            <a:endParaRPr lang="en-US" sz="3600" dirty="0"/>
+          </a:p>
+        </p:txBody>
+      </p:sp>
+      <p:sp>
+        <p:nvSpPr>
+          <p:cNvPr id="17" name="Text 15"/>
+          <p:cNvSpPr txBox="1"/>
+          <p:nvPr/>
+        </p:nvSpPr>
+        <p:spPr>
+          <a:xfrm>
+            <a:off x="6413484" y="3555991"/>
+            <a:ext cx="2146295" cy="215899"/>
+          </a:xfrm>
+          <a:prstGeom prst="rect">
+            <a:avLst/>
+          </a:prstGeom>
+          <a:noFill/>
+          <a:ln/>
+        </p:spPr>
+        <p:txBody>
+          <a:bodyPr wrap="square" lIns="0" tIns="0" rIns="0" bIns="0" rtlCol="0" anchor="ctr"/>
+          <a:lstStyle/>
+          <a:p>
+            <a:pPr indent="0" marL="0">
+              <a:buNone/>
+            </a:pPr>
+            <a:r>
+              <a:rPr lang="en-US" sz="900" b="1" spc="120" kern="0" dirty="0">
+                <a:solidFill>
+                  <a:srgbClr val="38B6FF"/>
+                </a:solidFill>
+                <a:latin typeface="Arial" pitchFamily="34" charset="0"/>
+                <a:ea typeface="Arial" pitchFamily="34" charset="-122"/>
+                <a:cs typeface="Arial" pitchFamily="34" charset="-120"/>
+              </a:rPr>
+              <a:t>KOST EEN LEAD</a:t>
+            </a:r>
+            <a:endParaRPr lang="en-US" sz="900" dirty="0"/>
+          </a:p>
+        </p:txBody>
+      </p:sp>
+      <p:sp>
+        <p:nvSpPr>
+          <p:cNvPr id="18" name="Text 16"/>
+          <p:cNvSpPr txBox="1"/>
+          <p:nvPr/>
+        </p:nvSpPr>
+        <p:spPr>
+          <a:xfrm>
+            <a:off x="6413484" y="3975090"/>
+            <a:ext cx="2146295" cy="888998"/>
+          </a:xfrm>
+          <a:prstGeom prst="rect">
+            <a:avLst/>
+          </a:prstGeom>
+          <a:noFill/>
+          <a:ln/>
+        </p:spPr>
+        <p:txBody>
+          <a:bodyPr wrap="square" lIns="0" tIns="0" rIns="0" bIns="0" rtlCol="0" anchor="t"/>
+          <a:lstStyle/>
+          <a:p>
+            <a:pPr indent="0" marL="0">
+              <a:lnSpc>
+                <a:spcPct val="135000"/>
+              </a:lnSpc>
+              <a:buNone/>
+            </a:pPr>
+            <a:r>
+              <a:rPr lang="en-US" sz="950" dirty="0">
+                <a:solidFill>
+                  <a:srgbClr val="6F6A5C"/>
+                </a:solidFill>
+                <a:latin typeface="Arial" pitchFamily="34" charset="0"/>
+                <a:ea typeface="Arial" pitchFamily="34" charset="-122"/>
+                <a:cs typeface="Arial" pitchFamily="34" charset="-120"/>
+              </a:rPr>
+              <a:t>Bij acht beldagen per vier weken. Eén klant van dit formaat betaalt er 29 terug.</a:t>
+            </a:r>
+            <a:endParaRPr lang="en-US" sz="950" dirty="0"/>
+          </a:p>
+        </p:txBody>
+      </p:sp>
+      <p:sp>
+        <p:nvSpPr>
+          <p:cNvPr id="19" name="Shape 17"/>
+          <p:cNvSpPr/>
+          <p:nvPr/>
+        </p:nvSpPr>
+        <p:spPr>
+          <a:xfrm>
+            <a:off x="8953478" y="2730493"/>
+            <a:ext cx="2628893" cy="2222494"/>
+          </a:xfrm>
+          <a:prstGeom prst="roundRect">
+            <a:avLst>
+              <a:gd name="adj" fmla="val 4571"/>
+            </a:avLst>
+          </a:prstGeom>
+          <a:solidFill>
+            <a:srgbClr val="000000"/>
+          </a:solidFill>
+          <a:ln/>
+        </p:spPr>
+      </p:sp>
+      <p:sp>
+        <p:nvSpPr>
+          <p:cNvPr id="20" name="Text 18"/>
+          <p:cNvSpPr txBox="1"/>
+          <p:nvPr/>
+        </p:nvSpPr>
+        <p:spPr>
+          <a:xfrm>
+            <a:off x="9194777" y="2997193"/>
+            <a:ext cx="2146295" cy="507999"/>
+          </a:xfrm>
+          <a:prstGeom prst="rect">
+            <a:avLst/>
+          </a:prstGeom>
+          <a:noFill/>
+          <a:ln/>
+        </p:spPr>
+        <p:txBody>
+          <a:bodyPr wrap="square" lIns="0" tIns="0" rIns="0" bIns="0" rtlCol="0" anchor="ctr"/>
+          <a:lstStyle/>
+          <a:p>
+            <a:pPr indent="0" marL="0">
+              <a:buNone/>
+            </a:pPr>
+            <a:r>
+              <a:rPr lang="en-US" sz="3600" b="1" dirty="0">
+                <a:solidFill>
+                  <a:srgbClr val="38B6FF"/>
+                </a:solidFill>
+                <a:latin typeface="Arial" pitchFamily="34" charset="0"/>
+                <a:ea typeface="Arial" pitchFamily="34" charset="-122"/>
+                <a:cs typeface="Arial" pitchFamily="34" charset="-120"/>
+              </a:rPr>
+              <a:t>9</a:t>
+            </a:r>
+            <a:endParaRPr lang="en-US" sz="3600" dirty="0"/>
+          </a:p>
+        </p:txBody>
+      </p:sp>
+      <p:sp>
+        <p:nvSpPr>
+          <p:cNvPr id="21" name="Text 19"/>
+          <p:cNvSpPr txBox="1"/>
+          <p:nvPr/>
+        </p:nvSpPr>
+        <p:spPr>
+          <a:xfrm>
+            <a:off x="9194777" y="3555991"/>
+            <a:ext cx="2146295" cy="215899"/>
+          </a:xfrm>
+          <a:prstGeom prst="rect">
+            <a:avLst/>
+          </a:prstGeom>
+          <a:noFill/>
+          <a:ln/>
+        </p:spPr>
+        <p:txBody>
+          <a:bodyPr wrap="square" lIns="0" tIns="0" rIns="0" bIns="0" rtlCol="0" anchor="ctr"/>
+          <a:lstStyle/>
+          <a:p>
+            <a:pPr indent="0" marL="0">
+              <a:buNone/>
+            </a:pPr>
+            <a:r>
+              <a:rPr lang="en-US" sz="900" b="1" spc="120" kern="0" dirty="0">
+                <a:solidFill>
+                  <a:srgbClr val="38B6FF"/>
+                </a:solidFill>
+                <a:latin typeface="Arial" pitchFamily="34" charset="0"/>
+                <a:ea typeface="Arial" pitchFamily="34" charset="-122"/>
+                <a:cs typeface="Arial" pitchFamily="34" charset="-120"/>
+              </a:rPr>
+              <a:t>KLANTEN PER JAAR</a:t>
+            </a:r>
+            <a:endParaRPr lang="en-US" sz="900" dirty="0"/>
+          </a:p>
+        </p:txBody>
+      </p:sp>
+      <p:sp>
+        <p:nvSpPr>
+          <p:cNvPr id="22" name="Text 20"/>
+          <p:cNvSpPr txBox="1"/>
+          <p:nvPr/>
+        </p:nvSpPr>
+        <p:spPr>
+          <a:xfrm>
+            <a:off x="9194777" y="3975090"/>
+            <a:ext cx="2146295" cy="888998"/>
+          </a:xfrm>
+          <a:prstGeom prst="rect">
+            <a:avLst/>
+          </a:prstGeom>
+          <a:noFill/>
+          <a:ln/>
+        </p:spPr>
+        <p:txBody>
+          <a:bodyPr wrap="square" lIns="0" tIns="0" rIns="0" bIns="0" rtlCol="0" anchor="t"/>
+          <a:lstStyle/>
+          <a:p>
+            <a:pPr indent="0" marL="0">
+              <a:lnSpc>
+                <a:spcPct val="135000"/>
+              </a:lnSpc>
+              <a:buNone/>
+            </a:pPr>
+            <a:r>
+              <a:rPr lang="en-US" sz="950" dirty="0">
+                <a:solidFill>
+                  <a:srgbClr val="C2C8D2"/>
+                </a:solidFill>
+                <a:latin typeface="Arial" pitchFamily="34" charset="0"/>
+                <a:ea typeface="Arial" pitchFamily="34" charset="-122"/>
+                <a:cs typeface="Arial" pitchFamily="34" charset="-120"/>
+              </a:rPr>
+              <a:t>Zoveel klanten van dit formaat maken een heel jaar bellen terugverdiend, uit ± 242 leads.</a:t>
+            </a:r>
+            <a:endParaRPr lang="en-US" sz="950" dirty="0"/>
+          </a:p>
+        </p:txBody>
+      </p:sp>
+      <p:sp>
+        <p:nvSpPr>
+          <p:cNvPr id="23" name="Shape 21"/>
+          <p:cNvSpPr/>
+          <p:nvPr/>
+        </p:nvSpPr>
+        <p:spPr>
+          <a:xfrm>
+            <a:off x="609598" y="5854685"/>
+            <a:ext cx="76200" cy="76200"/>
+          </a:xfrm>
+          <a:prstGeom prst="ellipse">
+            <a:avLst/>
+          </a:prstGeom>
+          <a:solidFill>
+            <a:srgbClr val="38B6FF"/>
+          </a:solidFill>
+          <a:ln/>
+        </p:spPr>
+      </p:sp>
+      <p:sp>
+        <p:nvSpPr>
+          <p:cNvPr id="24" name="Text 22"/>
+          <p:cNvSpPr txBox="1"/>
+          <p:nvPr/>
+        </p:nvSpPr>
+        <p:spPr>
+          <a:xfrm>
+            <a:off x="800098" y="5714986"/>
+            <a:ext cx="9905975" cy="355599"/>
+          </a:xfrm>
+          <a:prstGeom prst="rect">
+            <a:avLst/>
+          </a:prstGeom>
+          <a:noFill/>
+          <a:ln/>
+        </p:spPr>
+        <p:txBody>
+          <a:bodyPr wrap="square" lIns="0" tIns="0" rIns="0" bIns="0" rtlCol="0" anchor="ctr"/>
+          <a:lstStyle/>
+          <a:p>
+            <a:pPr indent="0" marL="0">
+              <a:buNone/>
+            </a:pPr>
+            <a:r>
+              <a:rPr lang="en-US" sz="1200" b="1" dirty="0">
+                <a:solidFill>
+                  <a:srgbClr val="1C2230"/>
+                </a:solidFill>
+                <a:latin typeface="Arial" pitchFamily="34" charset="0"/>
+                <a:ea typeface="Arial" pitchFamily="34" charset="-122"/>
+                <a:cs typeface="Arial" pitchFamily="34" charset="-120"/>
+              </a:rPr>
+              <a:t>Bij acht beldagen leveren we ongeveer 242 gekwalificeerde leads per jaar op. Worden daar 9 klanten van dit formaat uit, dan staat de investering van € 52.000 quitte en loopt die omzet daarna gewoon door.</a:t>
+            </a:r>
+            <a:endParaRPr lang="en-US" sz="1200" dirty="0"/>
+          </a:p>
+        </p:txBody>
+      </p:sp>
+    </p:spTree>
+  </p:cSld>
+  <p:clrMapOvr>
+    <a:masterClrMapping/>
+  </p:clrMapOvr>
+</p:sld>
+</file>
+
+<file path=ppt/slides/slide13.xml><?xml version="1.0" encoding="utf-8"?>
+<p:sld xmlns:a="http://schemas.openxmlformats.org/drawingml/2006/main" xmlns:r="http://schemas.openxmlformats.org/officeDocument/2006/relationships" xmlns:p="http://schemas.openxmlformats.org/presentationml/2006/main">
+  <p:cSld name="Slide 13">
     <p:bg>
       <p:bgPr>
         <a:solidFill>
@@ -6339,7 +7333,7 @@
                 <a:ea typeface="Arial" pitchFamily="34" charset="-122"/>
                 <a:cs typeface="Arial" pitchFamily="34" charset="-120"/>
               </a:rPr>
-              <a:t>12 / 14</a:t>
+              <a:t>13 / 15</a:t>
             </a:r>
             <a:endParaRPr lang="en-US" sz="750" dirty="0"/>
           </a:p>
@@ -7215,9 +8209,9 @@
 </p:sld>
 </file>
 
-<file path=ppt/slides/slide13.xml><?xml version="1.0" encoding="utf-8"?>
+<file path=ppt/slides/slide14.xml><?xml version="1.0" encoding="utf-8"?>
 <p:sld xmlns:a="http://schemas.openxmlformats.org/drawingml/2006/main" xmlns:r="http://schemas.openxmlformats.org/officeDocument/2006/relationships" xmlns:p="http://schemas.openxmlformats.org/presentationml/2006/main">
-  <p:cSld name="Slide 13">
+  <p:cSld name="Slide 14">
     <p:bg>
       <p:bgPr>
         <a:solidFill>
@@ -7364,7 +8358,7 @@
                 <a:ea typeface="Arial" pitchFamily="34" charset="-122"/>
                 <a:cs typeface="Arial" pitchFamily="34" charset="-120"/>
               </a:rPr>
-              <a:t>13 / 14</a:t>
+              <a:t>14 / 15</a:t>
             </a:r>
             <a:endParaRPr lang="en-US" sz="750" dirty="0"/>
           </a:p>
@@ -8647,9 +9641,9 @@
 </p:sld>
 </file>
 
-<file path=ppt/slides/slide14.xml><?xml version="1.0" encoding="utf-8"?>
+<file path=ppt/slides/slide15.xml><?xml version="1.0" encoding="utf-8"?>
 <p:sld xmlns:a="http://schemas.openxmlformats.org/drawingml/2006/main" xmlns:r="http://schemas.openxmlformats.org/officeDocument/2006/relationships" xmlns:p="http://schemas.openxmlformats.org/presentationml/2006/main">
-  <p:cSld name="Slide 14">
+  <p:cSld name="Slide 15">
     <p:bg>
       <p:bgPr>
         <a:solidFill>
@@ -8796,7 +9790,7 @@
                 <a:ea typeface="Arial" pitchFamily="34" charset="-122"/>
                 <a:cs typeface="Arial" pitchFamily="34" charset="-120"/>
               </a:rPr>
-              <a:t>14 / 14</a:t>
+              <a:t>15 / 15</a:t>
             </a:r>
             <a:endParaRPr lang="en-US" sz="750" dirty="0"/>
           </a:p>
@@ -9722,7 +10716,7 @@
                 <a:ea typeface="Arial" pitchFamily="34" charset="-122"/>
                 <a:cs typeface="Arial" pitchFamily="34" charset="-120"/>
               </a:rPr>
-              <a:t>2 / 14</a:t>
+              <a:t>2 / 15</a:t>
             </a:r>
             <a:endParaRPr lang="en-US" sz="750" dirty="0"/>
           </a:p>
@@ -10349,7 +11343,7 @@
                 <a:ea typeface="Arial" pitchFamily="34" charset="-122"/>
                 <a:cs typeface="Arial" pitchFamily="34" charset="-120"/>
               </a:rPr>
-              <a:t>3 / 14</a:t>
+              <a:t>3 / 15</a:t>
             </a:r>
             <a:endParaRPr lang="en-US" sz="750" dirty="0"/>
           </a:p>
@@ -11235,7 +12229,7 @@
                 <a:ea typeface="Arial" pitchFamily="34" charset="-122"/>
                 <a:cs typeface="Arial" pitchFamily="34" charset="-120"/>
               </a:rPr>
-              <a:t>4 / 14</a:t>
+              <a:t>4 / 15</a:t>
             </a:r>
             <a:endParaRPr lang="en-US" sz="750" dirty="0"/>
           </a:p>
@@ -12474,7 +13468,7 @@
                 <a:ea typeface="Arial" pitchFamily="34" charset="-122"/>
                 <a:cs typeface="Arial" pitchFamily="34" charset="-120"/>
               </a:rPr>
-              <a:t>5 / 14</a:t>
+              <a:t>5 / 15</a:t>
             </a:r>
             <a:endParaRPr lang="en-US" sz="750" dirty="0"/>
           </a:p>
@@ -13379,7 +14373,7 @@
                 <a:ea typeface="Arial" pitchFamily="34" charset="-122"/>
                 <a:cs typeface="Arial" pitchFamily="34" charset="-120"/>
               </a:rPr>
-              <a:t>6 / 14</a:t>
+              <a:t>6 / 15</a:t>
             </a:r>
             <a:endParaRPr lang="en-US" sz="750" dirty="0"/>
           </a:p>
@@ -14404,7 +15398,7 @@
                 <a:ea typeface="Arial" pitchFamily="34" charset="-122"/>
                 <a:cs typeface="Arial" pitchFamily="34" charset="-120"/>
               </a:rPr>
-              <a:t>7 / 14</a:t>
+              <a:t>7 / 15</a:t>
             </a:r>
             <a:endParaRPr lang="en-US" sz="750" dirty="0"/>
           </a:p>
@@ -15188,7 +16182,7 @@
                 <a:ea typeface="Arial" pitchFamily="34" charset="-122"/>
                 <a:cs typeface="Arial" pitchFamily="34" charset="-120"/>
               </a:rPr>
-              <a:t>8 / 14</a:t>
+              <a:t>8 / 15</a:t>
             </a:r>
             <a:endParaRPr lang="en-US" sz="750" dirty="0"/>
           </a:p>
@@ -16062,7 +17056,7 @@
                 <a:ea typeface="Arial" pitchFamily="34" charset="-122"/>
                 <a:cs typeface="Arial" pitchFamily="34" charset="-120"/>
               </a:rPr>
-              <a:t>9 / 14</a:t>
+              <a:t>9 / 15</a:t>
             </a:r>
             <a:endParaRPr lang="en-US" sz="750" dirty="0"/>
           </a:p>

</xml_diff>

<commit_message>
Moyee: klantwaarde zonder jaarbedragen, focus op wat het hen oplevert
Co-Authored-By: Claude Opus 5 <noreply@anthropic.com>
Claude-Session: https://claude.ai/code/session_0141FN3f3hHkYQHTyvTJJGrw
</commit_message>
<xml_diff>
--- a/output/LINK. voorstel Moyee Coffee.pptx
+++ b/output/LINK. voorstel Moyee Coffee.pptx
@@ -6850,7 +6850,7 @@
             </a:avLst>
           </a:prstGeom>
           <a:solidFill>
-            <a:srgbClr val="F8F4EB"/>
+            <a:srgbClr val="000000"/>
           </a:solidFill>
           <a:ln/>
         </p:spPr>
@@ -6882,13 +6882,13 @@
             <a:r>
               <a:rPr lang="en-US" sz="3600" b="1" dirty="0">
                 <a:solidFill>
-                  <a:srgbClr val="1C2230"/>
-                </a:solidFill>
-                <a:latin typeface="Arial" pitchFamily="34" charset="0"/>
-                <a:ea typeface="Arial" pitchFamily="34" charset="-122"/>
-                <a:cs typeface="Arial" pitchFamily="34" charset="-120"/>
-              </a:rPr>
-              <a:t>€ 215</a:t>
+                  <a:srgbClr val="38B6FF"/>
+                </a:solidFill>
+                <a:latin typeface="Arial" pitchFamily="34" charset="0"/>
+                <a:ea typeface="Arial" pitchFamily="34" charset="-122"/>
+                <a:cs typeface="Arial" pitchFamily="34" charset="-120"/>
+              </a:rPr>
+              <a:t>1 op 29</a:t>
             </a:r>
             <a:endParaRPr lang="en-US" sz="3600" dirty="0"/>
           </a:p>
@@ -6927,7 +6927,7 @@
                 <a:ea typeface="Arial" pitchFamily="34" charset="-122"/>
                 <a:cs typeface="Arial" pitchFamily="34" charset="-120"/>
               </a:rPr>
-              <a:t>KOST EEN LEAD</a:t>
+              <a:t>LEADS WORDT KLANT</a:t>
             </a:r>
             <a:endParaRPr lang="en-US" sz="900" dirty="0"/>
           </a:p>
@@ -6963,13 +6963,13 @@
             <a:r>
               <a:rPr lang="en-US" sz="950" dirty="0">
                 <a:solidFill>
-                  <a:srgbClr val="6F6A5C"/>
-                </a:solidFill>
-                <a:latin typeface="Arial" pitchFamily="34" charset="0"/>
-                <a:ea typeface="Arial" pitchFamily="34" charset="-122"/>
-                <a:cs typeface="Arial" pitchFamily="34" charset="-120"/>
-              </a:rPr>
-              <a:t>Bij acht beldagen per vier weken. Eén klant van dit formaat betaalt er 29 terug.</a:t>
+                  <a:srgbClr val="C2C8D2"/>
+                </a:solidFill>
+                <a:latin typeface="Arial" pitchFamily="34" charset="0"/>
+                <a:ea typeface="Arial" pitchFamily="34" charset="-122"/>
+                <a:cs typeface="Arial" pitchFamily="34" charset="-120"/>
+              </a:rPr>
+              <a:t>Meer is er niet nodig om het bellen terug te verdienen. Alles daarboven is winst.</a:t>
             </a:r>
             <a:endParaRPr lang="en-US" sz="950" dirty="0"/>
           </a:p>
@@ -6992,7 +6992,7 @@
             </a:avLst>
           </a:prstGeom>
           <a:solidFill>
-            <a:srgbClr val="000000"/>
+            <a:srgbClr val="F8F4EB"/>
           </a:solidFill>
           <a:ln/>
         </p:spPr>
@@ -7024,13 +7024,13 @@
             <a:r>
               <a:rPr lang="en-US" sz="3600" b="1" dirty="0">
                 <a:solidFill>
-                  <a:srgbClr val="38B6FF"/>
-                </a:solidFill>
-                <a:latin typeface="Arial" pitchFamily="34" charset="0"/>
-                <a:ea typeface="Arial" pitchFamily="34" charset="-122"/>
-                <a:cs typeface="Arial" pitchFamily="34" charset="-120"/>
-              </a:rPr>
-              <a:t>9</a:t>
+                  <a:srgbClr val="1C2230"/>
+                </a:solidFill>
+                <a:latin typeface="Arial" pitchFamily="34" charset="0"/>
+                <a:ea typeface="Arial" pitchFamily="34" charset="-122"/>
+                <a:cs typeface="Arial" pitchFamily="34" charset="-120"/>
+              </a:rPr>
+              <a:t>23</a:t>
             </a:r>
             <a:endParaRPr lang="en-US" sz="3600" dirty="0"/>
           </a:p>
@@ -7069,7 +7069,7 @@
                 <a:ea typeface="Arial" pitchFamily="34" charset="-122"/>
                 <a:cs typeface="Arial" pitchFamily="34" charset="-120"/>
               </a:rPr>
-              <a:t>KLANTEN PER JAAR</a:t>
+              <a:t>TASTINGS STAAN ER AL</a:t>
             </a:r>
             <a:endParaRPr lang="en-US" sz="900" dirty="0"/>
           </a:p>
@@ -7105,13 +7105,13 @@
             <a:r>
               <a:rPr lang="en-US" sz="950" dirty="0">
                 <a:solidFill>
-                  <a:srgbClr val="C2C8D2"/>
-                </a:solidFill>
-                <a:latin typeface="Arial" pitchFamily="34" charset="0"/>
-                <a:ea typeface="Arial" pitchFamily="34" charset="-122"/>
-                <a:cs typeface="Arial" pitchFamily="34" charset="-120"/>
-              </a:rPr>
-              <a:t>Zoveel klanten van dit formaat maken een heel jaar bellen terugverdiend, uit ± 242 leads.</a:t>
+                  <a:srgbClr val="6F6A5C"/>
+                </a:solidFill>
+                <a:latin typeface="Arial" pitchFamily="34" charset="0"/>
+                <a:ea typeface="Arial" pitchFamily="34" charset="-122"/>
+                <a:cs typeface="Arial" pitchFamily="34" charset="-120"/>
+              </a:rPr>
+              <a:t>Uit de periode die achter ons ligt. Elke tasting die klant wordt, telt vanaf dat moment mee.</a:t>
             </a:r>
             <a:endParaRPr lang="en-US" sz="950" dirty="0"/>
           </a:p>
@@ -7170,7 +7170,7 @@
                 <a:ea typeface="Arial" pitchFamily="34" charset="-122"/>
                 <a:cs typeface="Arial" pitchFamily="34" charset="-120"/>
               </a:rPr>
-              <a:t>Bij acht beldagen leveren we ongeveer 242 gekwalificeerde leads per jaar op. Worden daar 9 klanten van dit formaat uit, dan staat de investering van € 52.000 quitte en loopt die omzet daarna gewoon door.</a:t>
+              <a:t>En het stopt niet na een jaar. Een klant die blijft bestellen levert die omzet elk jaar opnieuw op, zonder dat er nieuwe acquisitiekosten tegenover staan.</a:t>
             </a:r>
             <a:endParaRPr lang="en-US" sz="1200" dirty="0"/>
           </a:p>

</xml_diff>

<commit_message>
Brew sheet: koffie-eigen datavisuals
- filterkegel als trechter: 2.629 pogingen naar 1.470 gesproken, dan druppels
- pijplijn als staafjes op schaal tegen de 2.100 benaderde bedrijven
- 29 koffiebonen met er een gevuld voor de terugverdiendrempel
- drempelkaart herschreven na opmerking: 1 op 29 is genoeg, geen conversiecijfer

Co-Authored-By: Claude Opus 5 <noreply@anthropic.com>
Claude-Session: https://claude.ai/code/session_0141FN3f3hHkYQHTyvTJJGrw
</commit_message>
<xml_diff>
--- a/output/LINK. voorstel Moyee Coffee.pptx
+++ b/output/LINK. voorstel Moyee Coffee.pptx
@@ -6927,7 +6927,7 @@
                 <a:ea typeface="Arial" pitchFamily="34" charset="-122"/>
                 <a:cs typeface="Arial" pitchFamily="34" charset="-120"/>
               </a:rPr>
-              <a:t>LEADS WORDT KLANT</a:t>
+              <a:t>LEADS IS GENOEG</a:t>
             </a:r>
             <a:endParaRPr lang="en-US" sz="900" dirty="0"/>
           </a:p>
@@ -6969,7 +6969,7 @@
                 <a:ea typeface="Arial" pitchFamily="34" charset="-122"/>
                 <a:cs typeface="Arial" pitchFamily="34" charset="-120"/>
               </a:rPr>
-              <a:t>Meer is er niet nodig om het bellen terug te verdienen. Alles daarboven is winst.</a:t>
+              <a:t>Meer hoeft er niet klant te worden om het bellen terug te verdienen. In de praktijk ligt dat aandeel hoger, en alles daarboven is winst.</a:t>
             </a:r>
             <a:endParaRPr lang="en-US" sz="950" dirty="0"/>
           </a:p>

</xml_diff>

<commit_message>
Moyee: brouwcyclus als een doorlopende animatie, klantwaarde op opbrengst
- de volautomaat telt het display op, zet koffie, stoomt en eindigt in een
  kaartje Tasting ingepland; de vier staven lopen in hetzelfde ritme mee
- waarde-sectie omgedraaid van terugverdienen naar opbrengst, met een ladder
  van 1, 5 en 10 klanten en hun jaaromzet

Co-Authored-By: Claude Opus 5 <noreply@anthropic.com>
Claude-Session: https://claude.ai/code/session_0141FN3f3hHkYQHTyvTJJGrw
</commit_message>
<xml_diff>
--- a/output/LINK. voorstel Moyee Coffee.pptx
+++ b/output/LINK. voorstel Moyee Coffee.pptx
@@ -6467,7 +6467,7 @@
                 <a:ea typeface="Arial" pitchFamily="34" charset="-122"/>
                 <a:cs typeface="Arial" pitchFamily="34" charset="-120"/>
               </a:rPr>
-              <a:t>WAT ER TEGENOVER STAAT</a:t>
+              <a:t>WAT EEN KLANT OPLEVERT</a:t>
             </a:r>
             <a:endParaRPr lang="en-US" sz="950" dirty="0"/>
           </a:p>
@@ -6509,7 +6509,7 @@
                 <a:ea typeface="Arial" pitchFamily="34" charset="-122"/>
                 <a:cs typeface="Arial" pitchFamily="34" charset="-120"/>
               </a:rPr>
-              <a:t>Eén nieuwe klant betaalt </a:t>
+              <a:t>Elke tasting is een kans op een klant die </a:t>
             </a:r>
             <a:pPr algn="l" indent="0" marL="0">
               <a:lnSpc>
@@ -6526,7 +6526,7 @@
                 <a:ea typeface="Georgia" pitchFamily="34" charset="-122"/>
                 <a:cs typeface="Georgia" pitchFamily="34" charset="-120"/>
               </a:rPr>
-              <a:t>29 leads</a:t>
+              <a:t>jaren blijft</a:t>
             </a:r>
             <a:pPr algn="l" indent="0" marL="0">
               <a:lnSpc>
@@ -6543,7 +6543,7 @@
                 <a:ea typeface="Arial" pitchFamily="34" charset="-122"/>
                 <a:cs typeface="Arial" pitchFamily="34" charset="-120"/>
               </a:rPr>
-              <a:t> terug.</a:t>
+              <a:t>.</a:t>
             </a:r>
             <a:endParaRPr lang="en-US" sz="3200" dirty="0"/>
           </a:p>
@@ -6708,7 +6708,7 @@
             </a:avLst>
           </a:prstGeom>
           <a:solidFill>
-            <a:srgbClr val="F8F4EB"/>
+            <a:srgbClr val="000000"/>
           </a:solidFill>
           <a:ln/>
         </p:spPr>
@@ -6740,7 +6740,7 @@
             <a:r>
               <a:rPr lang="en-US" sz="3600" b="1" dirty="0">
                 <a:solidFill>
-                  <a:srgbClr val="1C2230"/>
+                  <a:srgbClr val="38B6FF"/>
                 </a:solidFill>
                 <a:latin typeface="Arial" pitchFamily="34" charset="0"/>
                 <a:ea typeface="Arial" pitchFamily="34" charset="-122"/>
@@ -6785,7 +6785,7 @@
                 <a:ea typeface="Arial" pitchFamily="34" charset="-122"/>
                 <a:cs typeface="Arial" pitchFamily="34" charset="-120"/>
               </a:rPr>
-              <a:t>OMZET PER JAAR</a:t>
+              <a:t>PER KLANT PER JAAR</a:t>
             </a:r>
             <a:endParaRPr lang="en-US" sz="900" dirty="0"/>
           </a:p>
@@ -6821,13 +6821,13 @@
             <a:r>
               <a:rPr lang="en-US" sz="950" dirty="0">
                 <a:solidFill>
-                  <a:srgbClr val="6F6A5C"/>
-                </a:solidFill>
-                <a:latin typeface="Arial" pitchFamily="34" charset="0"/>
-                <a:ea typeface="Arial" pitchFamily="34" charset="-122"/>
-                <a:cs typeface="Arial" pitchFamily="34" charset="-120"/>
-              </a:rPr>
-              <a:t>Alleen de koffie, tegen € 20,64 per kilo. Cross- en upsell zitten er nog niet in.</a:t>
+                  <a:srgbClr val="C2C8D2"/>
+                </a:solidFill>
+                <a:latin typeface="Arial" pitchFamily="34" charset="0"/>
+                <a:ea typeface="Arial" pitchFamily="34" charset="-122"/>
+                <a:cs typeface="Arial" pitchFamily="34" charset="-120"/>
+              </a:rPr>
+              <a:t>Alleen de koffie, tegen € 20,64 per kilo. Dat komt elk jaar opnieuw binnen zolang ze bestellen.</a:t>
             </a:r>
             <a:endParaRPr lang="en-US" sz="950" dirty="0"/>
           </a:p>
@@ -6850,7 +6850,7 @@
             </a:avLst>
           </a:prstGeom>
           <a:solidFill>
-            <a:srgbClr val="000000"/>
+            <a:srgbClr val="F8F4EB"/>
           </a:solidFill>
           <a:ln/>
         </p:spPr>
@@ -6882,13 +6882,13 @@
             <a:r>
               <a:rPr lang="en-US" sz="3600" b="1" dirty="0">
                 <a:solidFill>
-                  <a:srgbClr val="38B6FF"/>
-                </a:solidFill>
-                <a:latin typeface="Arial" pitchFamily="34" charset="0"/>
-                <a:ea typeface="Arial" pitchFamily="34" charset="-122"/>
-                <a:cs typeface="Arial" pitchFamily="34" charset="-120"/>
-              </a:rPr>
-              <a:t>1 op 29</a:t>
+                  <a:srgbClr val="1C2230"/>
+                </a:solidFill>
+                <a:latin typeface="Arial" pitchFamily="34" charset="0"/>
+                <a:ea typeface="Arial" pitchFamily="34" charset="-122"/>
+                <a:cs typeface="Arial" pitchFamily="34" charset="-120"/>
+              </a:rPr>
+              <a:t>€ 30.964</a:t>
             </a:r>
             <a:endParaRPr lang="en-US" sz="3600" dirty="0"/>
           </a:p>
@@ -6927,7 +6927,7 @@
                 <a:ea typeface="Arial" pitchFamily="34" charset="-122"/>
                 <a:cs typeface="Arial" pitchFamily="34" charset="-120"/>
               </a:rPr>
-              <a:t>LEADS IS GENOEG</a:t>
+              <a:t>BIJ VIJF ZULKE KLANTEN</a:t>
             </a:r>
             <a:endParaRPr lang="en-US" sz="900" dirty="0"/>
           </a:p>
@@ -6963,13 +6963,13 @@
             <a:r>
               <a:rPr lang="en-US" sz="950" dirty="0">
                 <a:solidFill>
-                  <a:srgbClr val="C2C8D2"/>
-                </a:solidFill>
-                <a:latin typeface="Arial" pitchFamily="34" charset="0"/>
-                <a:ea typeface="Arial" pitchFamily="34" charset="-122"/>
-                <a:cs typeface="Arial" pitchFamily="34" charset="-120"/>
-              </a:rPr>
-              <a:t>Meer hoeft er niet klant te worden om het bellen terug te verdienen. In de praktijk ligt dat aandeel hoger, en alles daarboven is winst.</a:t>
+                  <a:srgbClr val="6F6A5C"/>
+                </a:solidFill>
+                <a:latin typeface="Arial" pitchFamily="34" charset="0"/>
+                <a:ea typeface="Arial" pitchFamily="34" charset="-122"/>
+                <a:cs typeface="Arial" pitchFamily="34" charset="-120"/>
+              </a:rPr>
+              <a:t>En cross- en upsell zitten daar nog niet in. Hoe meer tastings, hoe meer kans op zulke kantoren.</a:t>
             </a:r>
             <a:endParaRPr lang="en-US" sz="950" dirty="0"/>
           </a:p>
@@ -7030,7 +7030,7 @@
                 <a:ea typeface="Arial" pitchFamily="34" charset="-122"/>
                 <a:cs typeface="Arial" pitchFamily="34" charset="-120"/>
               </a:rPr>
-              <a:t>23</a:t>
+              <a:t>± 7</a:t>
             </a:r>
             <a:endParaRPr lang="en-US" sz="3600" dirty="0"/>
           </a:p>
@@ -7069,7 +7069,7 @@
                 <a:ea typeface="Arial" pitchFamily="34" charset="-122"/>
                 <a:cs typeface="Arial" pitchFamily="34" charset="-120"/>
               </a:rPr>
-              <a:t>TASTINGS STAAN ER AL</a:t>
+              <a:t>TASTINGS PER PERIODE</a:t>
             </a:r>
             <a:endParaRPr lang="en-US" sz="900" dirty="0"/>
           </a:p>
@@ -7111,7 +7111,7 @@
                 <a:ea typeface="Arial" pitchFamily="34" charset="-122"/>
                 <a:cs typeface="Arial" pitchFamily="34" charset="-120"/>
               </a:rPr>
-              <a:t>Uit de periode die achter ons ligt. Elke tasting die klant wordt, telt vanaf dat moment mee.</a:t>
+              <a:t>Bij acht beldagen. Meer beldagen betekent meer tastings, en dus meer kansen.</a:t>
             </a:r>
             <a:endParaRPr lang="en-US" sz="950" dirty="0"/>
           </a:p>
@@ -7170,7 +7170,7 @@
                 <a:ea typeface="Arial" pitchFamily="34" charset="-122"/>
                 <a:cs typeface="Arial" pitchFamily="34" charset="-120"/>
               </a:rPr>
-              <a:t>En het stopt niet na een jaar. Een klant die blijft bestellen levert die omzet elk jaar opnieuw op, zonder dat er nieuwe acquisitiekosten tegenover staan.</a:t>
+              <a:t>Daarom sturen we op zoveel mogelijk tastings. Een klant die blijft bestellen telt niet één keer mee, maar elk jaar opnieuw.</a:t>
             </a:r>
             <a:endParaRPr lang="en-US" sz="1200" dirty="0"/>
           </a:p>

</xml_diff>